<commit_message>
feat: Add Quarto presentation project with extensive assets and content, and update existing thesis chapters.
</commit_message>
<xml_diff>
--- a/keynote/main.pptx
+++ b/keynote/main.pptx
@@ -34,6 +34,11 @@
     <p:sldId id="282" r:id="rId28"/>
     <p:sldId id="283" r:id="rId29"/>
     <p:sldId id="284" r:id="rId30"/>
+    <p:sldId id="285" r:id="rId31"/>
+    <p:sldId id="286" r:id="rId32"/>
+    <p:sldId id="287" r:id="rId33"/>
+    <p:sldId id="288" r:id="rId34"/>
+    <p:sldId id="289" r:id="rId35"/>
   </p:sldIdLst>
   <p:sldSz cx="9144000" cy="5143500" type="screen16x9"/>
   <p:notesSz cx="6858000" cy="9144000"/>
@@ -3231,165 +3236,60 @@
           <a:chExt cx="0" cy="0"/>
         </a:xfrm>
       </p:grpSpPr>
-      <p:sp>
-        <p:nvSpPr>
-          <p:cNvPr id="2" name="Title 1"/>
-          <p:cNvSpPr>
-            <a:spLocks noGrp="1"/>
-          </p:cNvSpPr>
-          <p:nvPr>
-            <p:ph type="title"/>
-          </p:nvPr>
-        </p:nvSpPr>
-        <p:spPr/>
-        <p:txBody>
-          <a:bodyPr/>
-          <a:lstStyle/>
-          <a:p>
-            <a:pPr lvl="0" indent="0" marL="0">
-              <a:buNone/>
-            </a:pPr>
-            <a:r>
-              <a:rPr/>
-              <a:t>極低溫精密量測系統 (Measurement Setup)</a:t>
-            </a:r>
-          </a:p>
-        </p:txBody>
-      </p:sp>
       <mc:AlternateContent xmlns:mc="http://schemas.openxmlformats.org/markup-compatibility/2006">
         <mc:Choice xmlns:a14="http://schemas.microsoft.com/office/drawing/2010/main" Requires="a14">
           <p:sp>
             <p:nvSpPr>
-              <p:cNvPr id="3" name="Content Placeholder 2"/>
+              <p:cNvPr id="2" name="Title 1"/>
               <p:cNvSpPr>
                 <a:spLocks noGrp="1"/>
               </p:cNvSpPr>
               <p:nvPr>
-                <p:ph idx="1" sz="half"/>
+                <p:ph type="title"/>
               </p:nvPr>
             </p:nvSpPr>
-            <p:spPr/>
+            <p:spPr>
+              <a:xfrm>
+                <a:off x="722313" y="3305176"/>
+                <a:ext cx="7772400" cy="1021556"/>
+              </a:xfrm>
+            </p:spPr>
             <p:txBody>
               <a:bodyPr/>
               <a:lstStyle/>
               <a:p>
-                <a:pPr lvl="0"/>
-                <a:r>
-                  <a:rPr b="1"/>
-                  <a:t>環境</a:t>
-                </a:r>
-                <a:r>
-                  <a:rPr/>
-                  <a:t>：Bluefors 稀釋制冷機 (</a:t>
+                <a:pPr lvl="0" indent="0" marL="0">
+                  <a:buNone/>
+                </a:pPr>
+                <a:r>
+                  <a:rPr/>
+                  <a:t>研究設計：高透明 PtTe</a:t>
                 </a:r>
                 <a14:m>
                   <m:oMath xmlns:m="http://schemas.openxmlformats.org/officeDocument/2006/math">
-                    <m:r>
-                      <m:t>T</m:t>
-                    </m:r>
-                    <m:r>
-                      <m:rPr>
-                        <m:sty m:val="p"/>
-                      </m:rPr>
-                      <m:t>≈</m:t>
-                    </m:r>
-                    <m:r>
-                      <m:t>40</m:t>
-                    </m:r>
+                    <m:sSub>
+                      <m:e>
+                        <m:r>
+                          <m:t>​</m:t>
+                        </m:r>
+                      </m:e>
+                      <m:sub>
+                        <m:r>
+                          <m:t>2</m:t>
+                        </m:r>
+                      </m:sub>
+                    </m:sSub>
                   </m:oMath>
                 </a14:m>
                 <a:r>
                   <a:rPr/>
-                  <a:t> mK)。</a:t>
-                </a:r>
-              </a:p>
-              <a:p>
-                <a:pPr lvl="0"/>
-                <a:r>
-                  <a:rPr b="1"/>
-                  <a:t>磁場</a:t>
-                </a:r>
-                <a:r>
-                  <a:rPr/>
-                  <a:t>：3D 向量超導磁鐵 (9-1-1 T) </a:t>
-                </a:r>
-                <a14:m>
-                  <m:oMath xmlns:m="http://schemas.openxmlformats.org/officeDocument/2006/math">
-                    <m:r>
-                      <m:rPr>
-                        <m:sty m:val="p"/>
-                      </m:rPr>
-                      <m:t>→</m:t>
-                    </m:r>
-                  </m:oMath>
-                </a14:m>
-                <a:r>
-                  <a:rPr/>
-                  <a:t> 任意方向磁場。</a:t>
-                </a:r>
-              </a:p>
-              <a:p>
-                <a:pPr lvl="0"/>
-                <a:r>
-                  <a:rPr b="1"/>
-                  <a:t>訊號處理</a:t>
-                </a:r>
-              </a:p>
-              <a:p>
-                <a:pPr lvl="1"/>
-                <a:r>
-                  <a:rPr b="1"/>
-                  <a:t>多級濾波</a:t>
-                </a:r>
-                <a:r>
-                  <a:rPr/>
-                  <a:t>：QDevil (mK段) + IR Filter，抑制熱噪聲。</a:t>
-                </a:r>
-              </a:p>
-              <a:p>
-                <a:pPr lvl="1"/>
-                <a:r>
-                  <a:rPr b="1"/>
-                  <a:t>低雜訊量測</a:t>
-                </a:r>
-                <a:r>
-                  <a:rPr/>
-                  <a:t>：BPI 低噪聲放大器 + IVVI-rack (電池供電)。</a:t>
+                  <a:t> 接面搭配低雜訊向量磁場</a:t>
                 </a:r>
               </a:p>
             </p:txBody>
           </p:sp>
         </mc:Choice>
       </mc:AlternateContent>
-      <p:sp>
-        <p:nvSpPr>
-          <p:cNvPr id="4" name="Content Placeholder 3"/>
-          <p:cNvSpPr>
-            <a:spLocks noGrp="1"/>
-          </p:cNvSpPr>
-          <p:nvPr>
-            <p:ph idx="2" sz="half"/>
-          </p:nvPr>
-        </p:nvSpPr>
-        <p:spPr/>
-        <p:txBody>
-          <a:bodyPr/>
-          <a:lstStyle/>
-          <a:p>
-            <a:pPr lvl="0" indent="0" marL="0">
-              <a:buNone/>
-            </a:pPr>
-            <a:r>
-              <a:rPr b="1"/>
-              <a:t>關鍵特點</a:t>
-            </a:r>
-            <a:r>
-              <a:rPr/>
-              <a:t>： 極低電子溫度 高訊雜比 任意磁場向量</a:t>
-            </a:r>
-          </a:p>
-        </p:txBody>
-      </p:sp>
     </p:spTree>
   </p:cSld>
 </p:sld>
@@ -3422,12 +3322,7 @@
             <p:ph type="title"/>
           </p:nvPr>
         </p:nvSpPr>
-        <p:spPr>
-          <a:xfrm>
-            <a:off x="722313" y="3305176"/>
-            <a:ext cx="7772400" cy="1021556"/>
-          </a:xfrm>
-        </p:spPr>
+        <p:spPr/>
         <p:txBody>
           <a:bodyPr/>
           <a:lstStyle/>
@@ -3437,11 +3332,125 @@
             </a:pPr>
             <a:r>
               <a:rPr/>
-              <a:t>實驗結果</a:t>
-            </a:r>
-          </a:p>
-        </p:txBody>
-      </p:sp>
+              <a:t>製程關鍵：確保低阻抗與均勻度</a:t>
+            </a:r>
+          </a:p>
+        </p:txBody>
+      </p:sp>
+      <mc:AlternateContent xmlns:mc="http://schemas.openxmlformats.org/markup-compatibility/2006">
+        <mc:Choice xmlns:a14="http://schemas.microsoft.com/office/drawing/2010/main" Requires="a14">
+          <p:sp>
+            <p:nvSpPr>
+              <p:cNvPr id="3" name="Content Placeholder 2"/>
+              <p:cNvSpPr>
+                <a:spLocks noGrp="1"/>
+              </p:cNvSpPr>
+              <p:nvPr>
+                <p:ph idx="1"/>
+              </p:nvPr>
+            </p:nvSpPr>
+            <p:spPr/>
+            <p:txBody>
+              <a:bodyPr/>
+              <a:lstStyle/>
+              <a:p>
+                <a:pPr lvl="0"/>
+                <a:r>
+                  <a:rPr b="1"/>
+                  <a:t>材料</a:t>
+                </a:r>
+                <a:r>
+                  <a:rPr/>
+                  <a:t>：1T-PtTe</a:t>
+                </a:r>
+                <a14:m>
+                  <m:oMath xmlns:m="http://schemas.openxmlformats.org/officeDocument/2006/math">
+                    <m:sSub>
+                      <m:e>
+                        <m:r>
+                          <m:t>​</m:t>
+                        </m:r>
+                      </m:e>
+                      <m:sub>
+                        <m:r>
+                          <m:t>2</m:t>
+                        </m:r>
+                      </m:sub>
+                    </m:sSub>
+                  </m:oMath>
+                </a14:m>
+                <a:r>
+                  <a:rPr/>
+                  <a:t> 單晶（助熔劑法生長）。</a:t>
+                </a:r>
+              </a:p>
+              <a:p>
+                <a:pPr lvl="0"/>
+                <a:r>
+                  <a:rPr b="1"/>
+                  <a:t>流程</a:t>
+                </a:r>
+                <a:r>
+                  <a:rPr/>
+                  <a:t>：</a:t>
+                </a:r>
+              </a:p>
+              <a:p>
+                <a:pPr lvl="1" indent="-342900" marL="685800">
+                  <a:buAutoNum type="arabicPeriod"/>
+                </a:pPr>
+                <a:r>
+                  <a:rPr b="1"/>
+                  <a:t>機械剝離</a:t>
+                </a:r>
+                <a:r>
+                  <a:rPr/>
+                  <a:t> 製得原子級厚度薄片。</a:t>
+                </a:r>
+              </a:p>
+              <a:p>
+                <a:pPr lvl="1" indent="-342900" marL="685800">
+                  <a:buAutoNum type="arabicPeriod"/>
+                </a:pPr>
+                <a:r>
+                  <a:rPr b="1"/>
+                  <a:t>電子束微影 (EBL)</a:t>
+                </a:r>
+                <a:r>
+                  <a:rPr/>
+                  <a:t> 定義奈米電極圖案。</a:t>
+                </a:r>
+              </a:p>
+              <a:p>
+                <a:pPr lvl="1" indent="-342900" marL="685800">
+                  <a:buAutoNum type="arabicPeriod"/>
+                </a:pPr>
+                <a:r>
+                  <a:rPr b="1"/>
+                  <a:t>原位離子銑削</a:t>
+                </a:r>
+                <a:r>
+                  <a:rPr/>
+                  <a:t> 清潔接面以降低接觸電阻。</a:t>
+                </a:r>
+              </a:p>
+              <a:p>
+                <a:pPr lvl="1" indent="-342900" marL="685800">
+                  <a:buAutoNum type="arabicPeriod"/>
+                </a:pPr>
+                <a:r>
+                  <a:rPr b="1"/>
+                  <a:t>NbTi 濺鍍 (70–120 nm)</a:t>
+                </a:r>
+                <a:r>
+                  <a:rPr/>
+                  <a:t> 形成超導電極並維持側壁品質。</a:t>
+                </a:r>
+              </a:p>
+            </p:txBody>
+          </p:sp>
+        </mc:Choice>
+      </mc:AlternateContent>
     </p:spTree>
   </p:cSld>
 </p:sld>
@@ -3484,7 +3493,513 @@
             </a:pPr>
             <a:r>
               <a:rPr/>
-              <a:t>基礎電性特徵：高品質擴散型接面</a:t>
+              <a:t>量測設定：向量磁場 + 濾波管線支撐 CPR 讀取</a:t>
+            </a:r>
+          </a:p>
+        </p:txBody>
+      </p:sp>
+      <mc:AlternateContent xmlns:mc="http://schemas.openxmlformats.org/markup-compatibility/2006">
+        <mc:Choice xmlns:a14="http://schemas.microsoft.com/office/drawing/2010/main" Requires="a14">
+          <p:sp>
+            <p:nvSpPr>
+              <p:cNvPr id="3" name="Content Placeholder 2"/>
+              <p:cNvSpPr>
+                <a:spLocks noGrp="1"/>
+              </p:cNvSpPr>
+              <p:nvPr>
+                <p:ph idx="1" sz="half"/>
+              </p:nvPr>
+            </p:nvSpPr>
+            <p:spPr/>
+            <p:txBody>
+              <a:bodyPr/>
+              <a:lstStyle/>
+              <a:p>
+                <a:pPr lvl="0"/>
+                <a:r>
+                  <a:rPr b="1"/>
+                  <a:t>環境</a:t>
+                </a:r>
+                <a:r>
+                  <a:rPr/>
+                  <a:t>：Bluefors 稀釋制冷機 (</a:t>
+                </a:r>
+                <a14:m>
+                  <m:oMath xmlns:m="http://schemas.openxmlformats.org/officeDocument/2006/math">
+                    <m:r>
+                      <m:t>T</m:t>
+                    </m:r>
+                    <m:r>
+                      <m:rPr>
+                        <m:sty m:val="p"/>
+                      </m:rPr>
+                      <m:t>≈</m:t>
+                    </m:r>
+                    <m:r>
+                      <m:t>40</m:t>
+                    </m:r>
+                  </m:oMath>
+                </a14:m>
+                <a:r>
+                  <a:rPr/>
+                  <a:t> mK)，穩定低電子溫度。</a:t>
+                </a:r>
+              </a:p>
+              <a:p>
+                <a:pPr lvl="0"/>
+                <a:r>
+                  <a:rPr b="1"/>
+                  <a:t>磁場</a:t>
+                </a:r>
+                <a:r>
+                  <a:rPr/>
+                  <a:t>：3D 向量超導磁鐵 (9-1-1 T)，可精確設定面內場方向。</a:t>
+                </a:r>
+              </a:p>
+              <a:p>
+                <a:pPr lvl="0"/>
+                <a:r>
+                  <a:rPr b="1"/>
+                  <a:t>訊號鏈</a:t>
+                </a:r>
+                <a:r>
+                  <a:rPr/>
+                  <a:t>：</a:t>
+                </a:r>
+              </a:p>
+              <a:p>
+                <a:pPr lvl="1"/>
+                <a:r>
+                  <a:rPr/>
+                  <a:t>多級濾波（QDevil + IR Filter）抑制熱雜訊。</a:t>
+                </a:r>
+              </a:p>
+              <a:p>
+                <a:pPr lvl="1"/>
+                <a:r>
+                  <a:rPr/>
+                  <a:t>BPI 低雜訊放大器 + IVVI-rack（電池供電）確保高訊雜比。</a:t>
+                </a:r>
+              </a:p>
+            </p:txBody>
+          </p:sp>
+        </mc:Choice>
+      </mc:AlternateContent>
+      <p:sp>
+        <p:nvSpPr>
+          <p:cNvPr id="4" name="Content Placeholder 3"/>
+          <p:cNvSpPr>
+            <a:spLocks noGrp="1"/>
+          </p:cNvSpPr>
+          <p:nvPr>
+            <p:ph idx="2" sz="half"/>
+          </p:nvPr>
+        </p:nvSpPr>
+        <p:spPr/>
+        <p:txBody>
+          <a:bodyPr/>
+          <a:lstStyle/>
+          <a:p>
+            <a:pPr lvl="0" indent="0" marL="0">
+              <a:buNone/>
+            </a:pPr>
+            <a:r>
+              <a:rPr b="1"/>
+              <a:t>設計重點</a:t>
+            </a:r>
+            <a:br/>
+            <a:r>
+              <a:rPr/>
+              <a:t>極低電子溫度</a:t>
+            </a:r>
+            <a:br/>
+            <a:r>
+              <a:rPr/>
+              <a:t>任意磁場向量</a:t>
+            </a:r>
+            <a:br/>
+            <a:r>
+              <a:rPr/>
+              <a:t>低噪訊讀出路徑</a:t>
+            </a:r>
+          </a:p>
+        </p:txBody>
+      </p:sp>
+    </p:spTree>
+  </p:cSld>
+</p:sld>
+</file>
+
+<file path=ppt/slides/slide13.xml><?xml version="1.0" encoding="utf-8"?>
+<p:sld xmlns:a="http://schemas.openxmlformats.org/drawingml/2006/main" xmlns:r="http://schemas.openxmlformats.org/officeDocument/2006/relationships" xmlns:p="http://schemas.openxmlformats.org/presentationml/2006/main">
+  <p:cSld>
+    <p:spTree>
+      <p:nvGrpSpPr>
+        <p:cNvPr id="1" name=""/>
+        <p:cNvGrpSpPr/>
+        <p:nvPr/>
+      </p:nvGrpSpPr>
+      <p:grpSpPr>
+        <a:xfrm>
+          <a:off x="0" y="0"/>
+          <a:ext cx="0" cy="0"/>
+          <a:chOff x="0" y="0"/>
+          <a:chExt cx="0" cy="0"/>
+        </a:xfrm>
+      </p:grpSpPr>
+      <p:sp>
+        <p:nvSpPr>
+          <p:cNvPr id="2" name="Title 1"/>
+          <p:cNvSpPr>
+            <a:spLocks noGrp="1"/>
+          </p:cNvSpPr>
+          <p:nvPr>
+            <p:ph type="title"/>
+          </p:nvPr>
+        </p:nvSpPr>
+        <p:spPr/>
+        <p:txBody>
+          <a:bodyPr/>
+          <a:lstStyle/>
+          <a:p>
+            <a:pPr lvl="0" indent="0" marL="0">
+              <a:buNone/>
+            </a:pPr>
+            <a:r>
+              <a:rPr/>
+              <a:t>數據品質控管：I_c(Φ) → CPR 重構的可信度</a:t>
+            </a:r>
+          </a:p>
+        </p:txBody>
+      </p:sp>
+      <mc:AlternateContent xmlns:mc="http://schemas.openxmlformats.org/markup-compatibility/2006">
+        <mc:Choice xmlns:a14="http://schemas.microsoft.com/office/drawing/2010/main" Requires="a14">
+          <p:sp>
+            <p:nvSpPr>
+              <p:cNvPr id="3" name="Content Placeholder 2"/>
+              <p:cNvSpPr>
+                <a:spLocks noGrp="1"/>
+              </p:cNvSpPr>
+              <p:nvPr>
+                <p:ph idx="1"/>
+              </p:nvPr>
+            </p:nvSpPr>
+            <p:spPr/>
+            <p:txBody>
+              <a:bodyPr/>
+              <a:lstStyle/>
+              <a:p>
+                <a:pPr lvl="0"/>
+                <a:r>
+                  <a:rPr b="1"/>
+                  <a:t>CPR 重構流程</a:t>
+                </a:r>
+                <a:r>
+                  <a:rPr/>
+                  <a:t>：量測 </a:t>
+                </a:r>
+                <a14:m>
+                  <m:oMath xmlns:m="http://schemas.openxmlformats.org/officeDocument/2006/math">
+                    <m:sSub>
+                      <m:e>
+                        <m:r>
+                          <m:t>I</m:t>
+                        </m:r>
+                      </m:e>
+                      <m:sub>
+                        <m:r>
+                          <m:t>c</m:t>
+                        </m:r>
+                      </m:sub>
+                    </m:sSub>
+                    <m:d>
+                      <m:dPr>
+                        <m:begChr m:val="("/>
+                        <m:sepChr m:val=""/>
+                        <m:endChr m:val=")"/>
+                        <m:grow/>
+                      </m:dPr>
+                      <m:e>
+                        <m:r>
+                          <m:t>Φ</m:t>
+                        </m:r>
+                      </m:e>
+                    </m:d>
+                  </m:oMath>
+                </a14:m>
+                <a:r>
+                  <a:rPr/>
+                  <a:t>，以諧波展開模型擬合，提取 </a:t>
+                </a:r>
+                <a14:m>
+                  <m:oMath xmlns:m="http://schemas.openxmlformats.org/officeDocument/2006/math">
+                    <m:sSub>
+                      <m:e>
+                        <m:r>
+                          <m:t>I</m:t>
+                        </m:r>
+                      </m:e>
+                      <m:sub>
+                        <m:r>
+                          <m:t>1</m:t>
+                        </m:r>
+                      </m:sub>
+                    </m:sSub>
+                  </m:oMath>
+                </a14:m>
+                <a:r>
+                  <a:rPr/>
+                  <a:t>, </a:t>
+                </a:r>
+                <a14:m>
+                  <m:oMath xmlns:m="http://schemas.openxmlformats.org/officeDocument/2006/math">
+                    <m:sSub>
+                      <m:e>
+                        <m:r>
+                          <m:t>I</m:t>
+                        </m:r>
+                      </m:e>
+                      <m:sub>
+                        <m:r>
+                          <m:t>2</m:t>
+                        </m:r>
+                      </m:sub>
+                    </m:sSub>
+                  </m:oMath>
+                </a14:m>
+                <a:r>
+                  <a:rPr/>
+                  <a:t>, </a:t>
+                </a:r>
+                <a14:m>
+                  <m:oMath xmlns:m="http://schemas.openxmlformats.org/officeDocument/2006/math">
+                    <m:r>
+                      <m:t>δ</m:t>
+                    </m:r>
+                  </m:oMath>
+                </a14:m>
+                <a:r>
+                  <a:rPr/>
+                  <a:t>。</a:t>
+                </a:r>
+              </a:p>
+              <a:p>
+                <a:pPr lvl="0"/>
+                <a:r>
+                  <a:rPr b="1"/>
+                  <a:t>交叉驗證</a:t>
+                </a:r>
+                <a:r>
+                  <a:rPr/>
+                  <a:t>：多重安德烈夫反射 (MAR) 分析得到 </a:t>
+                </a:r>
+                <a14:m>
+                  <m:oMath xmlns:m="http://schemas.openxmlformats.org/officeDocument/2006/math">
+                    <m:r>
+                      <m:t>Δ</m:t>
+                    </m:r>
+                    <m:r>
+                      <m:rPr>
+                        <m:sty m:val="p"/>
+                      </m:rPr>
+                      <m:t>≈</m:t>
+                    </m:r>
+                    <m:r>
+                      <m:t>0.97</m:t>
+                    </m:r>
+                  </m:oMath>
+                </a14:m>
+                <a:r>
+                  <a:rPr/>
+                  <a:t> meV、</a:t>
+                </a:r>
+                <a14:m>
+                  <m:oMath xmlns:m="http://schemas.openxmlformats.org/officeDocument/2006/math">
+                    <m:r>
+                      <m:t>τ</m:t>
+                    </m:r>
+                    <m:r>
+                      <m:rPr>
+                        <m:sty m:val="p"/>
+                      </m:rPr>
+                      <m:t>≈</m:t>
+                    </m:r>
+                    <m:r>
+                      <m:t>0.63</m:t>
+                    </m:r>
+                  </m:oMath>
+                </a14:m>
+                <a:r>
+                  <a:rPr/>
+                  <a:t>，與 CPR 擬合所需透明度一致。</a:t>
+                </a:r>
+              </a:p>
+              <a:p>
+                <a:pPr lvl="0"/>
+                <a:r>
+                  <a:rPr b="1"/>
+                  <a:t>錯誤防範</a:t>
+                </a:r>
+                <a:r>
+                  <a:rPr/>
+                  <a:t>：控制磁場與樣品座標角度（</a:t>
+                </a:r>
+                <a14:m>
+                  <m:oMath xmlns:m="http://schemas.openxmlformats.org/officeDocument/2006/math">
+                    <m:r>
+                      <m:t>α</m:t>
+                    </m:r>
+                    <m:r>
+                      <m:rPr>
+                        <m:sty m:val="p"/>
+                      </m:rPr>
+                      <m:t>≈</m:t>
+                    </m:r>
+                    <m:sSup>
+                      <m:e>
+                        <m:r>
+                          <m:t>121</m:t>
+                        </m:r>
+                      </m:e>
+                      <m:sup>
+                        <m:r>
+                          <m:rPr>
+                            <m:sty m:val="p"/>
+                          </m:rPr>
+                          <m:t>∘</m:t>
+                        </m:r>
+                      </m:sup>
+                    </m:sSup>
+                  </m:oMath>
+                </a14:m>
+                <a:r>
+                  <a:rPr/>
+                  <a:t>），避免投影誤差，符合白皮書「方法論防禦」要求。</a:t>
+                </a:r>
+              </a:p>
+            </p:txBody>
+          </p:sp>
+        </mc:Choice>
+      </mc:AlternateContent>
+    </p:spTree>
+  </p:cSld>
+</p:sld>
+</file>
+
+<file path=ppt/slides/slide14.xml><?xml version="1.0" encoding="utf-8"?>
+<p:sld xmlns:a="http://schemas.openxmlformats.org/drawingml/2006/main" xmlns:r="http://schemas.openxmlformats.org/officeDocument/2006/relationships" xmlns:p="http://schemas.openxmlformats.org/presentationml/2006/main">
+  <p:cSld>
+    <p:spTree>
+      <p:nvGrpSpPr>
+        <p:cNvPr id="1" name=""/>
+        <p:cNvGrpSpPr/>
+        <p:nvPr/>
+      </p:nvGrpSpPr>
+      <p:grpSpPr>
+        <a:xfrm>
+          <a:off x="0" y="0"/>
+          <a:ext cx="0" cy="0"/>
+          <a:chOff x="0" y="0"/>
+          <a:chExt cx="0" cy="0"/>
+        </a:xfrm>
+      </p:grpSpPr>
+      <mc:AlternateContent xmlns:mc="http://schemas.openxmlformats.org/markup-compatibility/2006">
+        <mc:Choice xmlns:a14="http://schemas.microsoft.com/office/drawing/2010/main" Requires="a14">
+          <p:sp>
+            <p:nvSpPr>
+              <p:cNvPr id="2" name="Title 1"/>
+              <p:cNvSpPr>
+                <a:spLocks noGrp="1"/>
+              </p:cNvSpPr>
+              <p:nvPr>
+                <p:ph type="title"/>
+              </p:nvPr>
+            </p:nvSpPr>
+            <p:spPr>
+              <a:xfrm>
+                <a:off x="722313" y="3305176"/>
+                <a:ext cx="7772400" cy="1021556"/>
+              </a:xfrm>
+            </p:spPr>
+            <p:txBody>
+              <a:bodyPr/>
+              <a:lstStyle/>
+              <a:p>
+                <a:pPr lvl="0" indent="0" marL="0">
+                  <a:buNone/>
+                </a:pPr>
+                <a:r>
+                  <a:rPr/>
+                  <a:t>核心結果：面內磁場重塑 PtTe</a:t>
+                </a:r>
+                <a14:m>
+                  <m:oMath xmlns:m="http://schemas.openxmlformats.org/officeDocument/2006/math">
+                    <m:sSub>
+                      <m:e>
+                        <m:r>
+                          <m:t>​</m:t>
+                        </m:r>
+                      </m:e>
+                      <m:sub>
+                        <m:r>
+                          <m:t>2</m:t>
+                        </m:r>
+                      </m:sub>
+                    </m:sSub>
+                  </m:oMath>
+                </a14:m>
+                <a:r>
+                  <a:rPr/>
+                  <a:t> CPR</a:t>
+                </a:r>
+              </a:p>
+            </p:txBody>
+          </p:sp>
+        </mc:Choice>
+      </mc:AlternateContent>
+    </p:spTree>
+  </p:cSld>
+</p:sld>
+</file>
+
+<file path=ppt/slides/slide15.xml><?xml version="1.0" encoding="utf-8"?>
+<p:sld xmlns:a="http://schemas.openxmlformats.org/drawingml/2006/main" xmlns:r="http://schemas.openxmlformats.org/officeDocument/2006/relationships" xmlns:p="http://schemas.openxmlformats.org/presentationml/2006/main">
+  <p:cSld>
+    <p:spTree>
+      <p:nvGrpSpPr>
+        <p:cNvPr id="1" name=""/>
+        <p:cNvGrpSpPr/>
+        <p:nvPr/>
+      </p:nvGrpSpPr>
+      <p:grpSpPr>
+        <a:xfrm>
+          <a:off x="0" y="0"/>
+          <a:ext cx="0" cy="0"/>
+          <a:chOff x="0" y="0"/>
+          <a:chExt cx="0" cy="0"/>
+        </a:xfrm>
+      </p:grpSpPr>
+      <p:sp>
+        <p:nvSpPr>
+          <p:cNvPr id="2" name="Title 1"/>
+          <p:cNvSpPr>
+            <a:spLocks noGrp="1"/>
+          </p:cNvSpPr>
+          <p:nvPr>
+            <p:ph type="title"/>
+          </p:nvPr>
+        </p:nvSpPr>
+        <p:spPr/>
+        <p:txBody>
+          <a:bodyPr/>
+          <a:lstStyle/>
+          <a:p>
+            <a:pPr lvl="0" indent="0" marL="0">
+              <a:buNone/>
+            </a:pPr>
+            <a:r>
+              <a:rPr/>
+              <a:t>基線確認：I-V 與 MAR 顯示高透明接面</a:t>
             </a:r>
           </a:p>
         </p:txBody>
@@ -3539,14 +4054,11 @@
                 <a:pPr lvl="0"/>
                 <a:r>
                   <a:rPr b="1"/>
-                  <a:t>典型 I-V 曲線</a:t>
-                </a:r>
-              </a:p>
-              <a:p>
-                <a:pPr lvl="1"/>
-                <a:r>
-                  <a:rPr/>
-                  <a:t>清晰的超電流 (</a:t>
+                  <a:t>I-V</a:t>
+                </a:r>
+                <a:r>
+                  <a:rPr/>
+                  <a:t>：清晰超電流 (</a:t>
                 </a:r>
                 <a14:m>
                   <m:oMath xmlns:m="http://schemas.openxmlformats.org/officeDocument/2006/math">
@@ -3581,42 +4093,18 @@
                 </a14:m>
                 <a:r>
                   <a:rPr/>
-                  <a:t>)。</a:t>
-                </a:r>
-              </a:p>
-              <a:p>
-                <a:pPr lvl="1"/>
-                <a:r>
-                  <a:rPr/>
-                  <a:t>顯著遲滯 (Hysteresis) </a:t>
-                </a:r>
-                <a14:m>
-                  <m:oMath xmlns:m="http://schemas.openxmlformats.org/officeDocument/2006/math">
-                    <m:r>
-                      <m:rPr>
-                        <m:sty m:val="p"/>
-                      </m:rPr>
-                      <m:t>→</m:t>
-                    </m:r>
-                  </m:oMath>
-                </a14:m>
-                <a:r>
-                  <a:rPr/>
-                  <a:t> 欠阻尼狀態。</a:t>
+                  <a:t>)，遲滯顯示欠阻尼。</a:t>
                 </a:r>
               </a:p>
               <a:p>
                 <a:pPr lvl="0"/>
                 <a:r>
                   <a:rPr b="1"/>
-                  <a:t>多重安德烈夫反射 (MAR)</a:t>
-                </a:r>
-              </a:p>
-              <a:p>
-                <a:pPr lvl="1"/>
-                <a:r>
-                  <a:rPr/>
-                  <a:t>觀測到次諧波能隙結構 (</a:t>
+                  <a:t>MAR</a:t>
+                </a:r>
+                <a:r>
+                  <a:rPr/>
+                  <a:t>：次諧波能隙結構 (</a:t>
                 </a:r>
                 <a14:m>
                   <m:oMath xmlns:m="http://schemas.openxmlformats.org/officeDocument/2006/math">
@@ -3660,14 +4148,7 @@
                 </a14:m>
                 <a:r>
                   <a:rPr/>
-                  <a:t>)。</a:t>
-                </a:r>
-              </a:p>
-              <a:p>
-                <a:pPr lvl="1"/>
-                <a:r>
-                  <a:rPr/>
-                  <a:t>推導參數：</a:t>
+                  <a:t>) 清楚，推得 </a:t>
                 </a:r>
                 <a14:m>
                   <m:oMath xmlns:m="http://schemas.openxmlformats.org/officeDocument/2006/math">
@@ -3707,7 +4188,7 @@
                 </a14:m>
                 <a:r>
                   <a:rPr/>
-                  <a:t> (高透明度)。</a:t>
+                  <a:t>，支撐高透明度假設。</a:t>
                 </a:r>
               </a:p>
             </p:txBody>
@@ -3719,7 +4200,7 @@
 </p:sld>
 </file>
 
-<file path=ppt/slides/slide13.xml><?xml version="1.0" encoding="utf-8"?>
+<file path=ppt/slides/slide16.xml><?xml version="1.0" encoding="utf-8"?>
 <p:sld xmlns:a="http://schemas.openxmlformats.org/drawingml/2006/main" xmlns:r="http://schemas.openxmlformats.org/officeDocument/2006/relationships" xmlns:p="http://schemas.openxmlformats.org/presentationml/2006/main">
   <p:cSld>
     <p:spTree>
@@ -3756,7 +4237,7 @@
             </a:pPr>
             <a:r>
               <a:rPr/>
-              <a:t>零面內場特性：均勻的超電流分佈</a:t>
+              <a:t>零場干涉：對稱 Fraunhofer 顯示均勻 CPR</a:t>
             </a:r>
           </a:p>
         </p:txBody>
@@ -3811,11 +4292,12 @@
                 <a:pPr lvl="0"/>
                 <a:r>
                   <a:rPr b="1"/>
-                  <a:t>類夫朗和費干涉 (Fraunhofer-like)</a:t>
-                </a:r>
-              </a:p>
-              <a:p>
-                <a:pPr lvl="1"/>
+                  <a:t>干涉型態</a:t>
+                </a:r>
+                <a:r>
+                  <a:rPr/>
+                  <a:t>：</a:t>
+                </a:r>
                 <a14:m>
                   <m:oMath xmlns:m="http://schemas.openxmlformats.org/officeDocument/2006/math">
                     <m:sSub>
@@ -3867,14 +4349,7 @@
                 </a14:m>
                 <a:r>
                   <a:rPr/>
-                  <a:t> 時呈現高度對稱。</a:t>
-                </a:r>
-              </a:p>
-              <a:p>
-                <a:pPr lvl="1"/>
-                <a:r>
-                  <a:rPr/>
-                  <a:t>形式接近 </a:t>
+                  <a:t> 時高度對稱，形式接近 </a:t>
                 </a:r>
                 <a14:m>
                   <m:oMath xmlns:m="http://schemas.openxmlformats.org/officeDocument/2006/math">
@@ -3919,29 +4394,19 @@
                 <a:pPr lvl="0"/>
                 <a:r>
                   <a:rPr b="1"/>
-                  <a:t>物理意義</a:t>
-                </a:r>
-              </a:p>
-              <a:p>
-                <a:pPr lvl="1"/>
-                <a:r>
-                  <a:rPr/>
-                  <a:t>證實接面內部超電流密度分佈 </a:t>
+                  <a:t>意義</a:t>
+                </a:r>
+                <a:r>
+                  <a:rPr/>
+                  <a:t>：證實接面內部超電流密度分佈 </a:t>
                 </a:r>
                 <a:r>
                   <a:rPr b="1"/>
-                  <a:t>高度均勻</a:t>
-                </a:r>
-                <a:r>
-                  <a:rPr/>
-                  <a:t>。</a:t>
-                </a:r>
-              </a:p>
-              <a:p>
-                <a:pPr lvl="1"/>
-                <a:r>
-                  <a:rPr/>
-                  <a:t>無明顯缺陷或不均勻性。</a:t>
+                  <a:t>均勻</a:t>
+                </a:r>
+                <a:r>
+                  <a:rPr/>
+                  <a:t>，排除結構缺陷干擾後續磁場實驗。</a:t>
                 </a:r>
               </a:p>
             </p:txBody>
@@ -3953,7 +4418,7 @@
 </p:sld>
 </file>
 
-<file path=ppt/slides/slide14.xml><?xml version="1.0" encoding="utf-8"?>
+<file path=ppt/slides/slide17.xml><?xml version="1.0" encoding="utf-8"?>
 <p:sld xmlns:a="http://schemas.openxmlformats.org/drawingml/2006/main" xmlns:r="http://schemas.openxmlformats.org/officeDocument/2006/relationships" xmlns:p="http://schemas.openxmlformats.org/presentationml/2006/main">
   <p:cSld>
     <p:spTree>
@@ -3990,7 +4455,7 @@
             </a:pPr>
             <a:r>
               <a:rPr/>
-              <a:t>面內磁場效應 I：干涉圖樣畸變</a:t>
+              <a:t>Deep Dive 1：面內磁場扭曲干涉 → CPR 變形</a:t>
             </a:r>
           </a:p>
         </p:txBody>
@@ -4045,7 +4510,7 @@
                 <a:pPr lvl="0"/>
                 <a:r>
                   <a:rPr b="1"/>
-                  <a:t>現象</a:t>
+                  <a:t>觀察</a:t>
                 </a:r>
                 <a:r>
                   <a:rPr/>
@@ -4093,29 +4558,14 @@
                 </a14:m>
                 <a:r>
                   <a:rPr/>
-                  <a:t> 後，干涉圖樣 </a:t>
-                </a:r>
-                <a:r>
-                  <a:rPr b="1"/>
-                  <a:t>不再對稱</a:t>
-                </a:r>
-                <a:r>
-                  <a:rPr/>
-                  <a:t>。</a:t>
+                  <a:t> 後，干涉圖樣失去對稱。</a:t>
                 </a:r>
               </a:p>
               <a:p>
                 <a:pPr lvl="1"/>
                 <a:r>
                   <a:rPr/>
-                  <a:t>極小值位置偏移 (Node Shift)。</a:t>
-                </a:r>
-              </a:p>
-              <a:p>
-                <a:pPr lvl="1"/>
-                <a:r>
-                  <a:rPr/>
-                  <a:t>包絡線形狀改變 (Envelope Distortion)。</a:t>
+                  <a:t>節點偏移 (Node Shift)、包絡線畸變。</a:t>
                 </a:r>
               </a:p>
               <a:p>
@@ -4182,7 +4632,7 @@
                 </a14:m>
                 <a:r>
                   <a:rPr/>
-                  <a:t> (潛在的二極體效應訊號)。</a:t>
+                  <a:t>，出現二極體式非互易訊號。</a:t>
                 </a:r>
               </a:p>
               <a:p>
@@ -4193,15 +4643,15 @@
                 </a:r>
                 <a:r>
                   <a:rPr/>
-                  <a:t>：面內磁場改變了內部的 </a:t>
+                  <a:t>：面內磁場正在改變 </a:t>
                 </a:r>
                 <a:r>
                   <a:rPr b="1"/>
-                  <a:t>電流-相位關係 (CPR)</a:t>
-                </a:r>
-                <a:r>
-                  <a:rPr/>
-                  <a:t>。</a:t>
+                  <a:t>CPR 形狀與相位</a:t>
+                </a:r>
+                <a:r>
+                  <a:rPr/>
+                  <a:t>，需要模型化驗證。</a:t>
                 </a:r>
               </a:p>
             </p:txBody>
@@ -4213,7 +4663,7 @@
 </p:sld>
 </file>
 
-<file path=ppt/slides/slide15.xml><?xml version="1.0" encoding="utf-8"?>
+<file path=ppt/slides/slide18.xml><?xml version="1.0" encoding="utf-8"?>
 <p:sld xmlns:a="http://schemas.openxmlformats.org/drawingml/2006/main" xmlns:r="http://schemas.openxmlformats.org/officeDocument/2006/relationships" xmlns:p="http://schemas.openxmlformats.org/presentationml/2006/main">
   <p:cSld>
     <p:spTree>
@@ -4250,7 +4700,7 @@
             </a:pPr>
             <a:r>
               <a:rPr/>
-              <a:t>座標系效應：角度依賴性</a:t>
+              <a:t>角度掃描：各向異性證實磁場耦合</a:t>
             </a:r>
           </a:p>
         </p:txBody>
@@ -4273,13 +4723,6 @@
               <a:lstStyle/>
               <a:p>
                 <a:pPr lvl="0"/>
-                <a:r>
-                  <a:rPr b="1"/>
-                  <a:t>各向異性 (Anisotropy)</a:t>
-                </a:r>
-              </a:p>
-              <a:p>
-                <a:pPr lvl="1"/>
                 <a14:m>
                   <m:oMath xmlns:m="http://schemas.openxmlformats.org/officeDocument/2006/math">
                     <m:sSub>
@@ -4322,7 +4765,7 @@
                 </a14:m>
                 <a:r>
                   <a:rPr/>
-                  <a:t> 的效應顯著依賴於角度 </a:t>
+                  <a:t> 效應顯著依賴於角度 </a:t>
                 </a:r>
                 <a14:m>
                   <m:oMath xmlns:m="http://schemas.openxmlformats.org/officeDocument/2006/math">
@@ -4337,10 +4780,10 @@
                 </a:r>
               </a:p>
               <a:p>
-                <a:pPr lvl="1"/>
-                <a:r>
-                  <a:rPr/>
-                  <a:t>需考慮實驗室座標與樣品座標的轉換 (</a:t>
+                <a:pPr lvl="0"/>
+                <a:r>
+                  <a:rPr/>
+                  <a:t>實驗室座標與樣品座標需校正（</a:t>
                 </a:r>
                 <a14:m>
                   <m:oMath xmlns:m="http://schemas.openxmlformats.org/officeDocument/2006/math">
@@ -4372,7 +4815,7 @@
                 </a14:m>
                 <a:r>
                   <a:rPr/>
-                  <a:t>)。</a:t>
+                  <a:t>），確保相位掃描正確。</a:t>
                 </a:r>
               </a:p>
             </p:txBody>
@@ -4414,7 +4857,7 @@
 </p:sld>
 </file>
 
-<file path=ppt/slides/slide16.xml><?xml version="1.0" encoding="utf-8"?>
+<file path=ppt/slides/slide19.xml><?xml version="1.0" encoding="utf-8"?>
 <p:sld xmlns:a="http://schemas.openxmlformats.org/drawingml/2006/main" xmlns:r="http://schemas.openxmlformats.org/officeDocument/2006/relationships" xmlns:p="http://schemas.openxmlformats.org/presentationml/2006/main">
   <p:cSld>
     <p:spTree>
@@ -4451,7 +4894,7 @@
             </a:pPr>
             <a:r>
               <a:rPr/>
-              <a:t>CPR 重構 I：模型選擇</a:t>
+              <a:t>模型選擇：諧波展開優於純透明度模型</a:t>
             </a:r>
           </a:p>
         </p:txBody>
@@ -4506,14 +4949,11 @@
                 <a:pPr lvl="0"/>
                 <a:r>
                   <a:rPr b="1"/>
-                  <a:t>為何不選純透明度模型？</a:t>
-                </a:r>
-              </a:p>
-              <a:p>
-                <a:pPr lvl="1"/>
-                <a:r>
-                  <a:rPr/>
-                  <a:t>實驗觀測到顯著的高階諧波 (</a:t>
+                  <a:t>排除純透明度模型</a:t>
+                </a:r>
+                <a:r>
+                  <a:rPr/>
+                  <a:t>：觀測到 </a:t>
                 </a:r>
                 <a14:m>
                   <m:oMath xmlns:m="http://schemas.openxmlformats.org/officeDocument/2006/math">
@@ -4560,14 +5000,7 @@
                 </a14:m>
                 <a:r>
                   <a:rPr/>
-                  <a:t>)。</a:t>
-                </a:r>
-              </a:p>
-              <a:p>
-                <a:pPr lvl="1"/>
-                <a:r>
-                  <a:rPr/>
-                  <a:t>若用純透明度解釋，需 </a:t>
+                  <a:t>，若以透明度解釋需 </a:t>
                 </a:r>
                 <a14:m>
                   <m:oMath xmlns:m="http://schemas.openxmlformats.org/officeDocument/2006/math">
@@ -4587,7 +5020,7 @@
                 </a14:m>
                 <a:r>
                   <a:rPr/>
-                  <a:t> (不符實驗值 </a:t>
+                  <a:t>，與 MAR 得到的 </a:t>
                 </a:r>
                 <a14:m>
                   <m:oMath xmlns:m="http://schemas.openxmlformats.org/officeDocument/2006/math">
@@ -4604,18 +5037,19 @@
                 </a14:m>
                 <a:r>
                   <a:rPr/>
-                  <a:t>)。</a:t>
+                  <a:t> 不符。</a:t>
                 </a:r>
               </a:p>
               <a:p>
                 <a:pPr lvl="0"/>
                 <a:r>
                   <a:rPr b="1"/>
-                  <a:t>採用模型：諧波展開 (Harmonic Series)</a:t>
-                </a:r>
-              </a:p>
-              <a:p>
-                <a:pPr lvl="1"/>
+                  <a:t>選擇諧波展開</a:t>
+                </a:r>
+                <a:r>
+                  <a:rPr/>
+                  <a:t>：</a:t>
+                </a:r>
                 <a14:m>
                   <m:oMath xmlns:m="http://schemas.openxmlformats.org/officeDocument/2006/math">
                     <m:r>
@@ -4722,12 +5156,9 @@
                     </m:d>
                   </m:oMath>
                 </a14:m>
-              </a:p>
-              <a:p>
-                <a:pPr lvl="1"/>
-                <a:r>
-                  <a:rPr/>
-                  <a:t>引入相位差 </a:t>
+                <a:r>
+                  <a:rPr/>
+                  <a:t>，以 </a:t>
                 </a:r>
                 <a14:m>
                   <m:oMath xmlns:m="http://schemas.openxmlformats.org/officeDocument/2006/math">
@@ -4738,7 +5169,7 @@
                 </a14:m>
                 <a:r>
                   <a:rPr/>
-                  <a:t> 以描述 TRS 破缺。</a:t>
+                  <a:t> 描述 TRS 破缺並量化二階諧波。</a:t>
                 </a:r>
               </a:p>
             </p:txBody>
@@ -4750,7 +5181,7 @@
 </p:sld>
 </file>
 
-<file path=ppt/slides/slide17.xml><?xml version="1.0" encoding="utf-8"?>
+<file path=ppt/slides/slide2.xml><?xml version="1.0" encoding="utf-8"?>
 <p:sld xmlns:a="http://schemas.openxmlformats.org/drawingml/2006/main" xmlns:r="http://schemas.openxmlformats.org/officeDocument/2006/relationships" xmlns:p="http://schemas.openxmlformats.org/presentationml/2006/main">
   <p:cSld>
     <p:spTree>
@@ -4767,6 +5198,82 @@
           <a:chExt cx="0" cy="0"/>
         </a:xfrm>
       </p:grpSpPr>
+      <mc:AlternateContent xmlns:mc="http://schemas.openxmlformats.org/markup-compatibility/2006">
+        <mc:Choice xmlns:a14="http://schemas.microsoft.com/office/drawing/2010/main" Requires="a14">
+          <p:sp>
+            <p:nvSpPr>
+              <p:cNvPr id="2" name="Title 1"/>
+              <p:cNvSpPr>
+                <a:spLocks noGrp="1"/>
+              </p:cNvSpPr>
+              <p:nvPr>
+                <p:ph type="title"/>
+              </p:nvPr>
+            </p:nvSpPr>
+            <p:spPr>
+              <a:xfrm>
+                <a:off x="722313" y="3305176"/>
+                <a:ext cx="7772400" cy="1021556"/>
+              </a:xfrm>
+            </p:spPr>
+            <p:txBody>
+              <a:bodyPr/>
+              <a:lstStyle/>
+              <a:p>
+                <a:pPr lvl="0" indent="0" marL="0">
+                  <a:buNone/>
+                </a:pPr>
+                <a:r>
+                  <a:rPr/>
+                  <a:t>開場：面內磁場讓 PtTe</a:t>
+                </a:r>
+                <a14:m>
+                  <m:oMath xmlns:m="http://schemas.openxmlformats.org/officeDocument/2006/math">
+                    <m:sSub>
+                      <m:e>
+                        <m:r>
+                          <m:t>​</m:t>
+                        </m:r>
+                      </m:e>
+                      <m:sub>
+                        <m:r>
+                          <m:t>2</m:t>
+                        </m:r>
+                      </m:sub>
+                    </m:sSub>
+                  </m:oMath>
+                </a14:m>
+                <a:r>
+                  <a:rPr/>
+                  <a:t> 接面成為可調式 CPR 平台</a:t>
+                </a:r>
+              </a:p>
+            </p:txBody>
+          </p:sp>
+        </mc:Choice>
+      </mc:AlternateContent>
+    </p:spTree>
+  </p:cSld>
+</p:sld>
+</file>
+
+<file path=ppt/slides/slide20.xml><?xml version="1.0" encoding="utf-8"?>
+<p:sld xmlns:a="http://schemas.openxmlformats.org/drawingml/2006/main" xmlns:r="http://schemas.openxmlformats.org/officeDocument/2006/relationships" xmlns:p="http://schemas.openxmlformats.org/presentationml/2006/main">
+  <p:cSld>
+    <p:spTree>
+      <p:nvGrpSpPr>
+        <p:cNvPr id="1" name=""/>
+        <p:cNvGrpSpPr/>
+        <p:nvPr/>
+      </p:nvGrpSpPr>
+      <p:grpSpPr>
+        <a:xfrm>
+          <a:off x="0" y="0"/>
+          <a:ext cx="0" cy="0"/>
+          <a:chOff x="0" y="0"/>
+          <a:chExt cx="0" cy="0"/>
+        </a:xfrm>
+      </p:grpSpPr>
       <p:sp>
         <p:nvSpPr>
           <p:cNvPr id="2" name="Title 1"/>
@@ -4787,7 +5294,7 @@
             </a:pPr>
             <a:r>
               <a:rPr/>
-              <a:t>CPR 重構 II：高面內場下的二階諧波</a:t>
+              <a:t>Deep Dive 2：高面內場下二階諧波與相位差的崛起</a:t>
             </a:r>
           </a:p>
         </p:txBody>
@@ -4842,7 +5349,7 @@
                 <a:pPr lvl="0"/>
                 <a:r>
                   <a:rPr b="1"/>
-                  <a:t>擬合結果 (</a:t>
+                  <a:t>擬合 (</a:t>
                 </a:r>
                 <a14:m>
                   <m:oMath xmlns:m="http://schemas.openxmlformats.org/officeDocument/2006/math">
@@ -4876,27 +5383,10 @@
                   <a:rPr b="1"/>
                   <a:t> mT)</a:t>
                 </a:r>
-              </a:p>
-              <a:p>
-                <a:pPr lvl="1"/>
-                <a:r>
-                  <a:rPr/>
-                  <a:t>二階諧波相位可調模型完美擬合實驗數據。</a:t>
-                </a:r>
-              </a:p>
-              <a:p>
-                <a:pPr lvl="1"/>
-                <a:r>
-                  <a:rPr b="1"/>
-                  <a:t>關鍵發現</a:t>
-                </a:r>
-                <a:r>
-                  <a:rPr/>
-                  <a:t>：</a:t>
-                </a:r>
-              </a:p>
-              <a:p>
-                <a:pPr lvl="2"/>
+                <a:r>
+                  <a:rPr/>
+                  <a:t>：諧波相位可調模型貼合 </a:t>
+                </a:r>
                 <a14:m>
                   <m:oMath xmlns:m="http://schemas.openxmlformats.org/officeDocument/2006/math">
                     <m:sSub>
@@ -4907,6 +5397,49 @@
                       </m:e>
                       <m:sub>
                         <m:r>
+                          <m:t>c</m:t>
+                        </m:r>
+                      </m:sub>
+                    </m:sSub>
+                    <m:d>
+                      <m:dPr>
+                        <m:begChr m:val="("/>
+                        <m:sepChr m:val=""/>
+                        <m:endChr m:val=")"/>
+                        <m:grow/>
+                      </m:dPr>
+                      <m:e>
+                        <m:r>
+                          <m:t>Φ</m:t>
+                        </m:r>
+                      </m:e>
+                    </m:d>
+                  </m:oMath>
+                </a14:m>
+                <a:r>
+                  <a:rPr/>
+                  <a:t>。</a:t>
+                </a:r>
+              </a:p>
+              <a:p>
+                <a:pPr lvl="0"/>
+                <a:r>
+                  <a:rPr b="1"/>
+                  <a:t>關鍵發現</a:t>
+                </a:r>
+              </a:p>
+              <a:p>
+                <a:pPr lvl="1"/>
+                <a14:m>
+                  <m:oMath xmlns:m="http://schemas.openxmlformats.org/officeDocument/2006/math">
+                    <m:sSub>
+                      <m:e>
+                        <m:r>
+                          <m:t>I</m:t>
+                        </m:r>
+                      </m:e>
+                      <m:sub>
+                        <m:r>
                           <m:t>2</m:t>
                         </m:r>
                       </m:sub>
@@ -4915,11 +5448,11 @@
                 </a14:m>
                 <a:r>
                   <a:rPr/>
-                  <a:t> 分量顯著增強。</a:t>
+                  <a:t> 顯著增強，支持非正弦 CPR。</a:t>
                 </a:r>
               </a:p>
               <a:p>
-                <a:pPr lvl="2"/>
+                <a:pPr lvl="1"/>
                 <a:r>
                   <a:rPr/>
                   <a:t>相位差 </a:t>
@@ -4929,11 +5462,40 @@
                     <m:r>
                       <m:t>δ</m:t>
                     </m:r>
+                    <m:r>
+                      <m:rPr>
+                        <m:sty m:val="p"/>
+                      </m:rPr>
+                      <m:t>≠</m:t>
+                    </m:r>
+                    <m:r>
+                      <m:t>0</m:t>
+                    </m:r>
                   </m:oMath>
                 </a14:m>
                 <a:r>
                   <a:rPr/>
-                  <a:t> 非零。</a:t>
+                  <a:t>，對應 </a:t>
+                </a:r>
+                <a14:m>
+                  <m:oMath xmlns:m="http://schemas.openxmlformats.org/officeDocument/2006/math">
+                    <m:sSub>
+                      <m:e>
+                        <m:r>
+                          <m:t>φ</m:t>
+                        </m:r>
+                      </m:e>
+                      <m:sub>
+                        <m:r>
+                          <m:t>0</m:t>
+                        </m:r>
+                      </m:sub>
+                    </m:sSub>
+                  </m:oMath>
+                </a14:m>
+                <a:r>
+                  <a:rPr/>
+                  <a:t> 偏移，與干涉畸變一致。</a:t>
                 </a:r>
               </a:p>
             </p:txBody>
@@ -4945,7 +5507,7 @@
 </p:sld>
 </file>
 
-<file path=ppt/slides/slide18.xml><?xml version="1.0" encoding="utf-8"?>
+<file path=ppt/slides/slide21.xml><?xml version="1.0" encoding="utf-8"?>
 <p:sld xmlns:a="http://schemas.openxmlformats.org/drawingml/2006/main" xmlns:r="http://schemas.openxmlformats.org/officeDocument/2006/relationships" xmlns:p="http://schemas.openxmlformats.org/presentationml/2006/main">
   <p:cSld>
     <p:spTree>
@@ -4982,7 +5544,7 @@
             </a:pPr>
             <a:r>
               <a:rPr/>
-              <a:t>關鍵發現總結：磁場調控 CPR</a:t>
+              <a:t>收斂：面內磁場是 CPR 的可調旋鈕</a:t>
             </a:r>
           </a:p>
         </p:txBody>
@@ -5176,7 +5738,7 @@
 </p:sld>
 </file>
 
-<file path=ppt/slides/slide19.xml><?xml version="1.0" encoding="utf-8"?>
+<file path=ppt/slides/slide22.xml><?xml version="1.0" encoding="utf-8"?>
 <p:sld xmlns:a="http://schemas.openxmlformats.org/drawingml/2006/main" xmlns:r="http://schemas.openxmlformats.org/officeDocument/2006/relationships" xmlns:p="http://schemas.openxmlformats.org/presentationml/2006/main">
   <p:cSld>
     <p:spTree>
@@ -5218,7 +5780,7 @@
             </a:pPr>
             <a:r>
               <a:rPr/>
-              <a:t>討論</a:t>
+              <a:t>討論與意涵：磁場耦合 ABS，形塑非正弦 CPR</a:t>
             </a:r>
           </a:p>
         </p:txBody>
@@ -5228,7 +5790,7 @@
 </p:sld>
 </file>
 
-<file path=ppt/slides/slide2.xml><?xml version="1.0" encoding="utf-8"?>
+<file path=ppt/slides/slide23.xml><?xml version="1.0" encoding="utf-8"?>
 <p:sld xmlns:a="http://schemas.openxmlformats.org/drawingml/2006/main" xmlns:r="http://schemas.openxmlformats.org/officeDocument/2006/relationships" xmlns:p="http://schemas.openxmlformats.org/presentationml/2006/main">
   <p:cSld>
     <p:spTree>
@@ -5255,12 +5817,7 @@
             <p:ph type="title"/>
           </p:nvPr>
         </p:nvSpPr>
-        <p:spPr>
-          <a:xfrm>
-            <a:off x="722313" y="3305176"/>
-            <a:ext cx="7772400" cy="1021556"/>
-          </a:xfrm>
-        </p:spPr>
+        <p:spPr/>
         <p:txBody>
           <a:bodyPr/>
           <a:lstStyle/>
@@ -5270,54 +5827,7 @@
             </a:pPr>
             <a:r>
               <a:rPr/>
-              <a:t>緒論</a:t>
-            </a:r>
-          </a:p>
-        </p:txBody>
-      </p:sp>
-    </p:spTree>
-  </p:cSld>
-</p:sld>
-</file>
-
-<file path=ppt/slides/slide20.xml><?xml version="1.0" encoding="utf-8"?>
-<p:sld xmlns:a="http://schemas.openxmlformats.org/drawingml/2006/main" xmlns:r="http://schemas.openxmlformats.org/officeDocument/2006/relationships" xmlns:p="http://schemas.openxmlformats.org/presentationml/2006/main">
-  <p:cSld>
-    <p:spTree>
-      <p:nvGrpSpPr>
-        <p:cNvPr id="1" name=""/>
-        <p:cNvGrpSpPr/>
-        <p:nvPr/>
-      </p:nvGrpSpPr>
-      <p:grpSpPr>
-        <a:xfrm>
-          <a:off x="0" y="0"/>
-          <a:ext cx="0" cy="0"/>
-          <a:chOff x="0" y="0"/>
-          <a:chExt cx="0" cy="0"/>
-        </a:xfrm>
-      </p:grpSpPr>
-      <p:sp>
-        <p:nvSpPr>
-          <p:cNvPr id="2" name="Title 1"/>
-          <p:cNvSpPr>
-            <a:spLocks noGrp="1"/>
-          </p:cNvSpPr>
-          <p:nvPr>
-            <p:ph type="title"/>
-          </p:nvPr>
-        </p:nvSpPr>
-        <p:spPr/>
-        <p:txBody>
-          <a:bodyPr/>
-          <a:lstStyle/>
-          <a:p>
-            <a:pPr lvl="0" indent="0" marL="0">
-              <a:buNone/>
-            </a:pPr>
-            <a:r>
-              <a:rPr/>
-              <a:t>物理機制探討：非對稱干涉圖樣的起源</a:t>
+              <a:t>機制判讀：諧波相位差捕捉 TRS 破缺</a:t>
             </a:r>
           </a:p>
         </p:txBody>
@@ -5342,11 +5852,12 @@
                 <a:pPr lvl="0"/>
                 <a:r>
                   <a:rPr b="1"/>
-                  <a:t>現象回顧</a:t>
-                </a:r>
-              </a:p>
-              <a:p>
-                <a:pPr lvl="1"/>
+                  <a:t>現象對應</a:t>
+                </a:r>
+                <a:r>
+                  <a:rPr/>
+                  <a:t>：</a:t>
+                </a:r>
                 <a14:m>
                   <m:oMath xmlns:m="http://schemas.openxmlformats.org/officeDocument/2006/math">
                     <m:sSub>
@@ -5398,11 +5909,8 @@
                 </a14:m>
                 <a:r>
                   <a:rPr/>
-                  <a:t> 時，夫朗和費圖樣嚴重扭曲。</a:t>
-                </a:r>
-              </a:p>
-              <a:p>
-                <a:pPr lvl="1"/>
+                  <a:t> 時干涉畸變、</a:t>
+                </a:r>
                 <a14:m>
                   <m:oMath xmlns:m="http://schemas.openxmlformats.org/officeDocument/2006/math">
                     <m:sSubSup>
@@ -5465,7 +5973,7 @@
                 </a14:m>
                 <a:r>
                   <a:rPr/>
-                  <a:t> (Time-Reversal Symmetry Breaking)。</a:t>
+                  <a:t> 皆指向時間反演對稱破缺。</a:t>
                 </a:r>
               </a:p>
               <a:p>
@@ -5474,16 +5982,16 @@
                   <a:rPr b="1"/>
                   <a:t>模型比較</a:t>
                 </a:r>
+                <a:r>
+                  <a:rPr/>
+                  <a:t>：</a:t>
+                </a:r>
               </a:p>
               <a:p>
                 <a:pPr lvl="1"/>
                 <a:r>
-                  <a:rPr b="1"/>
-                  <a:t>透明度模型 (Transparency Model)</a:t>
-                </a:r>
-                <a:r>
-                  <a:rPr/>
-                  <a:t>：需極高 </a:t>
+                  <a:rPr/>
+                  <a:t>透明度模型需 </a:t>
                 </a:r>
                 <a14:m>
                   <m:oMath xmlns:m="http://schemas.openxmlformats.org/officeDocument/2006/math">
@@ -5503,7 +6011,7 @@
                 </a14:m>
                 <a:r>
                   <a:rPr/>
-                  <a:t> 才能解釋 </a:t>
+                  <a:t> 才能產生足夠 </a:t>
                 </a:r>
                 <a14:m>
                   <m:oMath xmlns:m="http://schemas.openxmlformats.org/officeDocument/2006/math">
@@ -5523,18 +6031,34 @@
                 </a14:m>
                 <a:r>
                   <a:rPr/>
-                  <a:t>，且無法解釋不對稱。</a:t>
+                  <a:t>，與實測 </a:t>
+                </a:r>
+                <a14:m>
+                  <m:oMath xmlns:m="http://schemas.openxmlformats.org/officeDocument/2006/math">
+                    <m:r>
+                      <m:t>τ</m:t>
+                    </m:r>
+                    <m:r>
+                      <m:rPr>
+                        <m:sty m:val="p"/>
+                      </m:rPr>
+                      <m:t>≈</m:t>
+                    </m:r>
+                    <m:r>
+                      <m:t>0.6</m:t>
+                    </m:r>
+                  </m:oMath>
+                </a14:m>
+                <a:r>
+                  <a:rPr/>
+                  <a:t> 不符。</a:t>
                 </a:r>
               </a:p>
               <a:p>
                 <a:pPr lvl="1"/>
                 <a:r>
-                  <a:rPr b="1"/>
-                  <a:t>諧波展開 (Harmonic Series)</a:t>
-                </a:r>
-                <a:r>
-                  <a:rPr/>
-                  <a:t>：引入相位 </a:t>
+                  <a:rPr/>
+                  <a:t>諧波展開模型藉由相位差 </a:t>
                 </a:r>
                 <a14:m>
                   <m:oMath xmlns:m="http://schemas.openxmlformats.org/officeDocument/2006/math">
@@ -5545,7 +6069,7 @@
                 </a14:m>
                 <a:r>
                   <a:rPr/>
-                  <a:t>，成功描述 TRS 破缺與高階諧波。</a:t>
+                  <a:t> 同時描述高階諧波與不對稱，與實驗吻合。</a:t>
                 </a:r>
               </a:p>
               <a:p>
@@ -5554,12 +6078,17 @@
                   <a:rPr b="1"/>
                   <a:t>結論</a:t>
                 </a:r>
-              </a:p>
-              <a:p>
-                <a:pPr lvl="1"/>
-                <a:r>
-                  <a:rPr/>
-                  <a:t>PtTe</a:t>
+                <a:r>
+                  <a:rPr/>
+                  <a:t>：面內磁場耦合 </a:t>
+                </a:r>
+                <a:r>
+                  <a:rPr b="1"/>
+                  <a:t>安德烈夫束縛態 (ABS)</a:t>
+                </a:r>
+                <a:r>
+                  <a:rPr/>
+                  <a:t>，在 PtTe</a:t>
                 </a:r>
                 <a14:m>
                   <m:oMath xmlns:m="http://schemas.openxmlformats.org/officeDocument/2006/math">
@@ -5579,460 +6108,27 @@
                 </a14:m>
                 <a:r>
                   <a:rPr/>
-                  <a:t> 接面中存在 </a:t>
-                </a:r>
-                <a:r>
-                  <a:rPr b="1"/>
-                  <a:t>各向異性</a:t>
-                </a:r>
-                <a:r>
-                  <a:rPr/>
-                  <a:t> 的輸運機制。</a:t>
-                </a:r>
-              </a:p>
-              <a:p>
-                <a:pPr lvl="1"/>
-                <a:r>
-                  <a:rPr/>
-                  <a:t>面內磁場有效耦合到 </a:t>
-                </a:r>
-                <a:r>
-                  <a:rPr b="1"/>
-                  <a:t>安德烈夫束縛態 (ABS)</a:t>
-                </a:r>
-                <a:r>
-                  <a:rPr/>
-                  <a:t>，調控其相位。</a:t>
-                </a:r>
-              </a:p>
-            </p:txBody>
-          </p:sp>
-        </mc:Choice>
-      </mc:AlternateContent>
-    </p:spTree>
-  </p:cSld>
-</p:sld>
-</file>
-
-<file path=ppt/slides/slide21.xml><?xml version="1.0" encoding="utf-8"?>
-<p:sld xmlns:a="http://schemas.openxmlformats.org/drawingml/2006/main" xmlns:r="http://schemas.openxmlformats.org/officeDocument/2006/relationships" xmlns:p="http://schemas.openxmlformats.org/presentationml/2006/main">
-  <p:cSld>
-    <p:spTree>
-      <p:nvGrpSpPr>
-        <p:cNvPr id="1" name=""/>
-        <p:cNvGrpSpPr/>
-        <p:nvPr/>
-      </p:nvGrpSpPr>
-      <p:grpSpPr>
-        <a:xfrm>
-          <a:off x="0" y="0"/>
-          <a:ext cx="0" cy="0"/>
-          <a:chOff x="0" y="0"/>
-          <a:chExt cx="0" cy="0"/>
-        </a:xfrm>
-      </p:grpSpPr>
-      <p:sp>
-        <p:nvSpPr>
-          <p:cNvPr id="2" name="Title 1"/>
-          <p:cNvSpPr>
-            <a:spLocks noGrp="1"/>
-          </p:cNvSpPr>
-          <p:nvPr>
-            <p:ph type="title"/>
-          </p:nvPr>
-        </p:nvSpPr>
-        <p:spPr/>
-        <p:txBody>
-          <a:bodyPr/>
-          <a:lstStyle/>
-          <a:p>
-            <a:pPr lvl="0" indent="0" marL="0">
-              <a:buNone/>
-            </a:pPr>
-            <a:r>
-              <a:rPr/>
-              <a:t>技術挑戰與優化方向</a:t>
-            </a:r>
-          </a:p>
-        </p:txBody>
-      </p:sp>
-      <p:sp>
-        <p:nvSpPr>
-          <p:cNvPr id="3" name="Content Placeholder 2"/>
-          <p:cNvSpPr>
-            <a:spLocks noGrp="1"/>
-          </p:cNvSpPr>
-          <p:nvPr>
-            <p:ph idx="1"/>
-          </p:nvPr>
-        </p:nvSpPr>
-        <p:spPr/>
-        <p:txBody>
-          <a:bodyPr/>
-          <a:lstStyle/>
-          <a:p>
-            <a:pPr lvl="0"/>
-            <a:r>
-              <a:rPr b="1"/>
-              <a:t>製程挑戰</a:t>
-            </a:r>
-          </a:p>
-          <a:p>
-            <a:pPr lvl="1"/>
-            <a:r>
-              <a:rPr b="1"/>
-              <a:t>側壁沉積 (Sidewall Deposition)</a:t>
-            </a:r>
-            <a:r>
-              <a:rPr/>
-              <a:t>：可能導致額外並聯路徑。</a:t>
-            </a:r>
-          </a:p>
-          <a:p>
-            <a:pPr lvl="1"/>
-            <a:r>
-              <a:rPr b="1"/>
-              <a:t>表面氧化</a:t>
-            </a:r>
-            <a:r>
-              <a:rPr/>
-              <a:t>：TMD 材料易氧化，需嚴格的原位清洗。</a:t>
-            </a:r>
-          </a:p>
-          <a:p>
-            <a:pPr lvl="0"/>
-            <a:r>
-              <a:rPr b="1"/>
-              <a:t>對量測的影響</a:t>
-            </a:r>
-          </a:p>
-          <a:p>
-            <a:pPr lvl="1"/>
-            <a:r>
-              <a:rPr/>
-              <a:t>接面均勻性影響干涉圖樣的對比度。</a:t>
-            </a:r>
-          </a:p>
-          <a:p>
-            <a:pPr lvl="1"/>
-            <a:r>
-              <a:rPr/>
-              <a:t>需進一步優化 </a:t>
-            </a:r>
-            <a:r>
-              <a:rPr b="1"/>
-              <a:t>離子銑削</a:t>
-            </a:r>
-            <a:r>
-              <a:rPr/>
-              <a:t> 參數與 </a:t>
-            </a:r>
-            <a:r>
-              <a:rPr b="1"/>
-              <a:t>側壁保護</a:t>
-            </a:r>
-            <a:r>
-              <a:rPr/>
-              <a:t> 製程。</a:t>
-            </a:r>
-          </a:p>
-        </p:txBody>
-      </p:sp>
-    </p:spTree>
-  </p:cSld>
-</p:sld>
-</file>
-
-<file path=ppt/slides/slide22.xml><?xml version="1.0" encoding="utf-8"?>
-<p:sld xmlns:a="http://schemas.openxmlformats.org/drawingml/2006/main" xmlns:r="http://schemas.openxmlformats.org/officeDocument/2006/relationships" xmlns:p="http://schemas.openxmlformats.org/presentationml/2006/main">
-  <p:cSld>
-    <p:spTree>
-      <p:nvGrpSpPr>
-        <p:cNvPr id="1" name=""/>
-        <p:cNvGrpSpPr/>
-        <p:nvPr/>
-      </p:nvGrpSpPr>
-      <p:grpSpPr>
-        <a:xfrm>
-          <a:off x="0" y="0"/>
-          <a:ext cx="0" cy="0"/>
-          <a:chOff x="0" y="0"/>
-          <a:chExt cx="0" cy="0"/>
-        </a:xfrm>
-      </p:grpSpPr>
-      <p:sp>
-        <p:nvSpPr>
-          <p:cNvPr id="2" name="Title 1"/>
-          <p:cNvSpPr>
-            <a:spLocks noGrp="1"/>
-          </p:cNvSpPr>
-          <p:nvPr>
-            <p:ph type="title"/>
-          </p:nvPr>
-        </p:nvSpPr>
-        <p:spPr>
-          <a:xfrm>
-            <a:off x="722313" y="3305176"/>
-            <a:ext cx="7772400" cy="1021556"/>
-          </a:xfrm>
-        </p:spPr>
-        <p:txBody>
-          <a:bodyPr/>
-          <a:lstStyle/>
-          <a:p>
-            <a:pPr lvl="0" indent="0" marL="0">
-              <a:buNone/>
-            </a:pPr>
-            <a:r>
-              <a:rPr/>
-              <a:t>結論與展望</a:t>
-            </a:r>
-          </a:p>
-        </p:txBody>
-      </p:sp>
-    </p:spTree>
-  </p:cSld>
-</p:sld>
-</file>
-
-<file path=ppt/slides/slide23.xml><?xml version="1.0" encoding="utf-8"?>
-<p:sld xmlns:a="http://schemas.openxmlformats.org/drawingml/2006/main" xmlns:r="http://schemas.openxmlformats.org/officeDocument/2006/relationships" xmlns:p="http://schemas.openxmlformats.org/presentationml/2006/main">
-  <p:cSld>
-    <p:spTree>
-      <p:nvGrpSpPr>
-        <p:cNvPr id="1" name=""/>
-        <p:cNvGrpSpPr/>
-        <p:nvPr/>
-      </p:nvGrpSpPr>
-      <p:grpSpPr>
-        <a:xfrm>
-          <a:off x="0" y="0"/>
-          <a:ext cx="0" cy="0"/>
-          <a:chOff x="0" y="0"/>
-          <a:chExt cx="0" cy="0"/>
-        </a:xfrm>
-      </p:grpSpPr>
-      <p:sp>
-        <p:nvSpPr>
-          <p:cNvPr id="2" name="Title 1"/>
-          <p:cNvSpPr>
-            <a:spLocks noGrp="1"/>
-          </p:cNvSpPr>
-          <p:nvPr>
-            <p:ph type="title"/>
-          </p:nvPr>
-        </p:nvSpPr>
-        <p:spPr/>
-        <p:txBody>
-          <a:bodyPr/>
-          <a:lstStyle/>
-          <a:p>
-            <a:pPr lvl="0" indent="0" marL="0">
-              <a:buNone/>
-            </a:pPr>
-            <a:r>
-              <a:rPr/>
-              <a:t>總結 (Conclusion)</a:t>
-            </a:r>
-          </a:p>
-        </p:txBody>
-      </p:sp>
-      <mc:AlternateContent xmlns:mc="http://schemas.openxmlformats.org/markup-compatibility/2006">
-        <mc:Choice xmlns:a14="http://schemas.microsoft.com/office/drawing/2010/main" Requires="a14">
-          <p:sp>
-            <p:nvSpPr>
-              <p:cNvPr id="3" name="Content Placeholder 2"/>
-              <p:cNvSpPr>
-                <a:spLocks noGrp="1"/>
-              </p:cNvSpPr>
-              <p:nvPr>
-                <p:ph idx="1"/>
-              </p:nvPr>
-            </p:nvSpPr>
-            <p:spPr/>
-            <p:txBody>
-              <a:bodyPr/>
-              <a:lstStyle/>
-              <a:p>
-                <a:pPr lvl="0" indent="-342900" marL="342900">
-                  <a:buAutoNum type="arabicPeriod"/>
-                </a:pPr>
-                <a:r>
-                  <a:rPr b="1"/>
-                  <a:t>成功建立 PtTe</a:t>
+                  <a:t> 中誘發可調式 </a:t>
                 </a:r>
                 <a14:m>
                   <m:oMath xmlns:m="http://schemas.openxmlformats.org/officeDocument/2006/math">
                     <m:sSub>
                       <m:e>
                         <m:r>
-                          <m:t>​</m:t>
+                          <m:t>φ</m:t>
                         </m:r>
                       </m:e>
                       <m:sub>
                         <m:r>
-                          <m:t>2</m:t>
+                          <m:t>0</m:t>
                         </m:r>
                       </m:sub>
                     </m:sSub>
                   </m:oMath>
                 </a14:m>
                 <a:r>
-                  <a:rPr b="1"/>
-                  <a:t> 量子元件平台</a:t>
-                </a:r>
-              </a:p>
-              <a:p>
-                <a:pPr lvl="1"/>
-                <a:r>
-                  <a:rPr/>
-                  <a:t>結合機械剝離與非對稱 SQUID 技術。</a:t>
-                </a:r>
-              </a:p>
-              <a:p>
-                <a:pPr lvl="1"/>
-                <a:r>
-                  <a:rPr/>
-                  <a:t>實現高品質擴散型接面 (</a:t>
-                </a:r>
-                <a14:m>
-                  <m:oMath xmlns:m="http://schemas.openxmlformats.org/officeDocument/2006/math">
-                    <m:r>
-                      <m:t>L</m:t>
-                    </m:r>
-                    <m:r>
-                      <m:rPr>
-                        <m:sty m:val="p"/>
-                      </m:rPr>
-                      <m:t>≫</m:t>
-                    </m:r>
-                    <m:sSub>
-                      <m:e>
-                        <m:r>
-                          <m:t>l</m:t>
-                        </m:r>
-                      </m:e>
-                      <m:sub>
-                        <m:r>
-                          <m:t>e</m:t>
-                        </m:r>
-                      </m:sub>
-                    </m:sSub>
-                  </m:oMath>
-                </a14:m>
-                <a:r>
-                  <a:rPr/>
-                  <a:t>)。</a:t>
-                </a:r>
-              </a:p>
-              <a:p>
-                <a:pPr lvl="0" indent="-342900" marL="342900">
-                  <a:buAutoNum type="arabicPeriod"/>
-                </a:pPr>
-                <a:r>
-                  <a:rPr b="1"/>
-                  <a:t>發現非傳統電流-相位關係 (Non-sinusoidal CPR)</a:t>
-                </a:r>
-              </a:p>
-              <a:p>
-                <a:pPr lvl="1"/>
-                <a:r>
-                  <a:rPr/>
-                  <a:t>直接觀測到顯著的 </a:t>
-                </a:r>
-                <a:r>
-                  <a:rPr b="1"/>
-                  <a:t>二階諧波 (</a:t>
-                </a:r>
-                <a14:m>
-                  <m:oMath xmlns:m="http://schemas.openxmlformats.org/officeDocument/2006/math">
-                    <m:sSub>
-                      <m:e>
-                        <m:r>
-                          <m:t>I</m:t>
-                        </m:r>
-                      </m:e>
-                      <m:sub>
-                        <m:r>
-                          <m:t>2</m:t>
-                        </m:r>
-                      </m:sub>
-                    </m:sSub>
-                  </m:oMath>
-                </a14:m>
-                <a:r>
-                  <a:rPr b="1"/>
-                  <a:t>)</a:t>
-                </a:r>
-                <a:r>
-                  <a:rPr/>
-                  <a:t>。</a:t>
-                </a:r>
-              </a:p>
-              <a:p>
-                <a:pPr lvl="1"/>
-                <a:r>
-                  <a:rPr/>
-                  <a:t>證實 CPR 形式高度依賴於 </a:t>
-                </a:r>
-                <a:r>
-                  <a:rPr b="1"/>
-                  <a:t>面內磁場</a:t>
-                </a:r>
-                <a:r>
-                  <a:rPr/>
-                  <a:t>。</a:t>
-                </a:r>
-              </a:p>
-              <a:p>
-                <a:pPr lvl="0" indent="-342900" marL="342900">
-                  <a:buAutoNum type="arabicPeriod"/>
-                </a:pPr>
-                <a:r>
-                  <a:rPr b="1"/>
-                  <a:t>磁通量調控 (Magnetic Tuning)</a:t>
-                </a:r>
-              </a:p>
-              <a:p>
-                <a:pPr lvl="1"/>
-                <a:r>
-                  <a:rPr/>
-                  <a:t>實現了「</a:t>
-                </a:r>
-                <a:r>
-                  <a:rPr b="1"/>
-                  <a:t>可調式 </a:t>
-                </a:r>
-                <a14:m>
-                  <m:oMath xmlns:m="http://schemas.openxmlformats.org/officeDocument/2006/math">
-                    <m:sSub>
-                      <m:e>
-                        <m:r>
-                          <m:t>φ</m:t>
-                        </m:r>
-                      </m:e>
-                      <m:sub>
-                        <m:r>
-                          <m:t>0</m:t>
-                        </m:r>
-                      </m:sub>
-                    </m:sSub>
-                  </m:oMath>
-                </a14:m>
-                <a:r>
-                  <a:rPr b="1"/>
-                  <a:t> 接面</a:t>
-                </a:r>
-                <a:r>
-                  <a:rPr/>
-                  <a:t>」。</a:t>
-                </a:r>
-              </a:p>
-              <a:p>
-                <a:pPr lvl="1"/>
-                <a:r>
-                  <a:rPr/>
-                  <a:t>為拓撲超導元件的相位操控提供了新途徑。</a:t>
+                  <a:rPr/>
+                  <a:t> 行為。</a:t>
                 </a:r>
               </a:p>
             </p:txBody>
@@ -6081,139 +6177,84 @@
             </a:pPr>
             <a:r>
               <a:rPr/>
-              <a:t>未來展望 (Future Work)</a:t>
-            </a:r>
-          </a:p>
-        </p:txBody>
-      </p:sp>
-      <mc:AlternateContent xmlns:mc="http://schemas.openxmlformats.org/markup-compatibility/2006">
-        <mc:Choice xmlns:a14="http://schemas.microsoft.com/office/drawing/2010/main" Requires="a14">
-          <p:sp>
-            <p:nvSpPr>
-              <p:cNvPr id="3" name="Content Placeholder 2"/>
-              <p:cNvSpPr>
-                <a:spLocks noGrp="1"/>
-              </p:cNvSpPr>
-              <p:nvPr>
-                <p:ph idx="1"/>
-              </p:nvPr>
-            </p:nvSpPr>
-            <p:spPr/>
-            <p:txBody>
-              <a:bodyPr/>
-              <a:lstStyle/>
-              <a:p>
-                <a:pPr lvl="0"/>
-                <a:r>
-                  <a:rPr b="1"/>
-                  <a:t>短期目標：機制釐清</a:t>
-                </a:r>
-              </a:p>
-              <a:p>
-                <a:pPr lvl="1"/>
-                <a:r>
-                  <a:rPr b="1"/>
-                  <a:t>溫度依賴性量測</a:t>
-                </a:r>
-                <a:r>
-                  <a:rPr/>
-                  <a:t>：區分體相與表面態貢獻。</a:t>
-                </a:r>
-              </a:p>
-              <a:p>
-                <a:pPr lvl="1"/>
-                <a:r>
-                  <a:rPr b="1"/>
-                  <a:t>Shapiro Steps</a:t>
-                </a:r>
-                <a:r>
-                  <a:rPr/>
-                  <a:t>：進一步驗證 AC 約瑟夫森效應。</a:t>
-                </a:r>
-              </a:p>
-              <a:p>
-                <a:pPr lvl="0"/>
-                <a:r>
-                  <a:rPr b="1"/>
-                  <a:t>長期目標：量子應用</a:t>
-                </a:r>
-              </a:p>
-              <a:p>
-                <a:pPr lvl="1"/>
-                <a:r>
-                  <a:rPr b="1"/>
-                  <a:t>超導二極體 (Superconducting Diode)</a:t>
-                </a:r>
-                <a:r>
-                  <a:rPr/>
-                  <a:t>：零磁場下的非互易輸運。</a:t>
-                </a:r>
-              </a:p>
-              <a:p>
-                <a:pPr lvl="1"/>
-                <a:r>
-                  <a:rPr b="1"/>
-                  <a:t>拓撲量子位元 (Topological Qubits)</a:t>
-                </a:r>
-                <a:r>
-                  <a:rPr/>
-                  <a:t>：利用 </a:t>
-                </a:r>
-                <a14:m>
-                  <m:oMath xmlns:m="http://schemas.openxmlformats.org/officeDocument/2006/math">
-                    <m:sSub>
-                      <m:e>
-                        <m:r>
-                          <m:t>φ</m:t>
-                        </m:r>
-                      </m:e>
-                      <m:sub>
-                        <m:r>
-                          <m:t>0</m:t>
-                        </m:r>
-                      </m:sub>
-                    </m:sSub>
-                  </m:oMath>
-                </a14:m>
-                <a:r>
-                  <a:rPr/>
-                  <a:t> 偏移實現免磁場操控。</a:t>
-                </a:r>
-              </a:p>
-              <a:p>
-                <a:pPr lvl="0"/>
-                <a:r>
-                  <a:rPr b="1"/>
-                  <a:t>科學意義</a:t>
-                </a:r>
-              </a:p>
-              <a:p>
-                <a:pPr lvl="1"/>
-                <a:r>
-                  <a:rPr/>
-                  <a:t>連結 </a:t>
-                </a:r>
-                <a:r>
-                  <a:rPr b="1"/>
-                  <a:t>拓撲物理</a:t>
-                </a:r>
-                <a:r>
-                  <a:rPr/>
-                  <a:t> 與 </a:t>
-                </a:r>
-                <a:r>
-                  <a:rPr b="1"/>
-                  <a:t>宏觀量子元件</a:t>
-                </a:r>
-                <a:r>
-                  <a:rPr/>
-                  <a:t> 的橋樑。</a:t>
-                </a:r>
-              </a:p>
-            </p:txBody>
-          </p:sp>
-        </mc:Choice>
-      </mc:AlternateContent>
+              <a:t>學術與實務意涵：可調式 CPR 為拓樸元件奠基</a:t>
+            </a:r>
+          </a:p>
+        </p:txBody>
+      </p:sp>
+      <p:sp>
+        <p:nvSpPr>
+          <p:cNvPr id="3" name="Content Placeholder 2"/>
+          <p:cNvSpPr>
+            <a:spLocks noGrp="1"/>
+          </p:cNvSpPr>
+          <p:nvPr>
+            <p:ph idx="1"/>
+          </p:nvPr>
+        </p:nvSpPr>
+        <p:spPr/>
+        <p:txBody>
+          <a:bodyPr/>
+          <a:lstStyle/>
+          <a:p>
+            <a:pPr lvl="0"/>
+            <a:r>
+              <a:rPr b="1"/>
+              <a:t>學術</a:t>
+            </a:r>
+            <a:r>
+              <a:rPr/>
+              <a:t>：提供 Type-II DSM 在超導近接下的實驗證據，量化高階諧波與相位偏移，填補 CPR 可調性的缺口。</a:t>
+            </a:r>
+          </a:p>
+          <a:p>
+            <a:pPr lvl="0"/>
+            <a:r>
+              <a:rPr b="1"/>
+              <a:t>實務</a:t>
+            </a:r>
+            <a:r>
+              <a:rPr/>
+              <a:t>：磁場即可設定 CPR 形狀，對 </a:t>
+            </a:r>
+            <a:r>
+              <a:rPr b="1"/>
+              <a:t>超導二極體</a:t>
+            </a:r>
+            <a:r>
+              <a:rPr/>
+              <a:t>、</a:t>
+            </a:r>
+            <a:r>
+              <a:rPr b="1"/>
+              <a:t>可程式化相位邏輯</a:t>
+            </a:r>
+            <a:r>
+              <a:rPr/>
+              <a:t>、</a:t>
+            </a:r>
+            <a:r>
+              <a:rPr b="1"/>
+              <a:t>拓樸量子位元</a:t>
+            </a:r>
+            <a:r>
+              <a:rPr/>
+              <a:t> 的相位操控具直接可行性。</a:t>
+            </a:r>
+          </a:p>
+          <a:p>
+            <a:pPr lvl="0"/>
+            <a:r>
+              <a:rPr b="1"/>
+              <a:t>展示策略</a:t>
+            </a:r>
+            <a:r>
+              <a:rPr/>
+              <a:t>：依白皮書建議，以圖表凸顯「相位旋鈕」效果，口試時可快速定錨委員關注焦點。</a:t>
+            </a:r>
+          </a:p>
+        </p:txBody>
+      </p:sp>
     </p:spTree>
   </p:cSld>
 </p:sld>
@@ -6246,12 +6287,7 @@
             <p:ph type="title"/>
           </p:nvPr>
         </p:nvSpPr>
-        <p:spPr>
-          <a:xfrm>
-            <a:off x="722313" y="3305176"/>
-            <a:ext cx="7772400" cy="1021556"/>
-          </a:xfrm>
-        </p:spPr>
+        <p:spPr/>
         <p:txBody>
           <a:bodyPr/>
           <a:lstStyle/>
@@ -6261,7 +6297,56 @@
             </a:pPr>
             <a:r>
               <a:rPr/>
-              <a:t>備用投影片 (Backup Slides)</a:t>
+              <a:t>限制與風險：製程與均勻度仍需優化</a:t>
+            </a:r>
+          </a:p>
+        </p:txBody>
+      </p:sp>
+      <p:sp>
+        <p:nvSpPr>
+          <p:cNvPr id="3" name="Content Placeholder 2"/>
+          <p:cNvSpPr>
+            <a:spLocks noGrp="1"/>
+          </p:cNvSpPr>
+          <p:nvPr>
+            <p:ph idx="1"/>
+          </p:nvPr>
+        </p:nvSpPr>
+        <p:spPr/>
+        <p:txBody>
+          <a:bodyPr/>
+          <a:lstStyle/>
+          <a:p>
+            <a:pPr lvl="0"/>
+            <a:r>
+              <a:rPr b="1"/>
+              <a:t>製程</a:t>
+            </a:r>
+            <a:r>
+              <a:rPr/>
+              <a:t>：側壁沉積可能形成並聯路徑；TMD 易氧化，需嚴格原位清洗與側壁保護。</a:t>
+            </a:r>
+          </a:p>
+          <a:p>
+            <a:pPr lvl="0"/>
+            <a:r>
+              <a:rPr b="1"/>
+              <a:t>量測</a:t>
+            </a:r>
+            <a:r>
+              <a:rPr/>
+              <a:t>：接面均勻度影響干涉對比度；面內磁場角度校正仍是誤差源。</a:t>
+            </a:r>
+          </a:p>
+          <a:p>
+            <a:pPr lvl="0"/>
+            <a:r>
+              <a:rPr b="1"/>
+              <a:t>未來優化</a:t>
+            </a:r>
+            <a:r>
+              <a:rPr/>
+              <a:t>：細調離子銑削、加入防護層，並擴充角度與溫度掃描，以強化方法論防禦。</a:t>
             </a:r>
           </a:p>
         </p:txBody>
@@ -6272,135 +6357,6 @@
 </file>
 
 <file path=ppt/slides/slide26.xml><?xml version="1.0" encoding="utf-8"?>
-<p:sld xmlns:a="http://schemas.openxmlformats.org/drawingml/2006/main" xmlns:r="http://schemas.openxmlformats.org/officeDocument/2006/relationships" xmlns:p="http://schemas.openxmlformats.org/presentationml/2006/main">
-  <p:cSld>
-    <p:spTree>
-      <p:nvGrpSpPr>
-        <p:cNvPr id="1" name=""/>
-        <p:cNvGrpSpPr/>
-        <p:nvPr/>
-      </p:nvGrpSpPr>
-      <p:grpSpPr>
-        <a:xfrm>
-          <a:off x="0" y="0"/>
-          <a:ext cx="0" cy="0"/>
-          <a:chOff x="0" y="0"/>
-          <a:chExt cx="0" cy="0"/>
-        </a:xfrm>
-      </p:grpSpPr>
-      <p:sp>
-        <p:nvSpPr>
-          <p:cNvPr id="2" name="Title 1"/>
-          <p:cNvSpPr>
-            <a:spLocks noGrp="1"/>
-          </p:cNvSpPr>
-          <p:nvPr>
-            <p:ph type="title"/>
-          </p:nvPr>
-        </p:nvSpPr>
-        <p:spPr>
-          <a:xfrm>
-            <a:off x="722313" y="3305176"/>
-            <a:ext cx="7772400" cy="1021556"/>
-          </a:xfrm>
-        </p:spPr>
-        <p:txBody>
-          <a:bodyPr/>
-          <a:lstStyle/>
-          <a:p>
-            <a:pPr lvl="0" indent="0" marL="0">
-              <a:buNone/>
-            </a:pPr>
-            <a:r>
-              <a:rPr/>
-              <a:t>附錄 A：詳細實驗數據</a:t>
-            </a:r>
-          </a:p>
-        </p:txBody>
-      </p:sp>
-    </p:spTree>
-  </p:cSld>
-</p:sld>
-</file>
-
-<file path=ppt/slides/slide27.xml><?xml version="1.0" encoding="UTF-8"?><p:sld xmlns:a="http://schemas.openxmlformats.org/drawingml/2006/main" xmlns:r="http://schemas.openxmlformats.org/officeDocument/2006/relationships" xmlns:p="http://schemas.openxmlformats.org/presentationml/2006/main"><p:cSld><p:spTree><p:nvGrpSpPr><p:cNvPr id="1" name="" /><p:cNvGrpSpPr /><p:nvPr /></p:nvGrpSpPr><p:grpSpPr><a:xfrm><a:off x="0" y="0" /><a:ext cx="0" cy="0" /><a:chOff x="0" y="0" /><a:chExt cx="0" cy="0" /></a:xfrm></p:grpSpPr><p:sp><p:nvSpPr><p:cNvPr id="2" name="Title 1" /><p:cNvSpPr><a:spLocks noGrp="1" /></p:cNvSpPr><p:nvPr><p:ph type="title" /></p:nvPr></p:nvSpPr><p:spPr><a:xfrm><a:off x="457201" y="204787" /><a:ext cx="3008313" cy="871538" /></a:xfrm></p:spPr><p:txBody><a:bodyPr /><a:lstStyle /><a:p><a:pPr lvl="0" indent="0" marL="0"><a:buNone /></a:pPr><a:r><a:rPr /><a:t>完整實驗結果</a:t></a:r></a:p></p:txBody></p:sp><p:sp><p:nvSpPr><p:cNvPr id="4" name="Text Placeholder 3" /><p:cNvSpPr><a:spLocks noGrp="1" /></p:cNvSpPr><p:nvPr><p:ph idx="2" sz="half" type="body" /></p:nvPr></p:nvSpPr><p:spPr /><p:txBody><a:bodyPr /><a:lstStyle /><a:p><a:pPr lvl="0" indent="0" marL="0"><a:buNone /></a:pPr><a:r><a:rPr /><a:t>本附錄提供了主要實驗的詳細數據和補充分析。</a:t></a:r></a:p><a:p><a:pPr lvl="0" indent="0" marL="0"><a:spcBef><a:spcPts val="3000" /></a:spcBef><a:buNone /></a:pPr><a:r><a:rPr b="1" /><a:t>樣品詳細資訊</a:t></a:r></a:p><a:p><a:pPr lvl="0" indent="0" marL="0"><a:buNone /></a:pPr><a:r><a:rPr /><a:t>樣品詳細資訊</a:t></a:r></a:p><a:p><a:pPr lvl="0" indent="0" marL="0"><a:buNone /></a:pPr><a:r><a:rPr /><a:t>樣品編號</a:t></a:r></a:p><a:p><a:pPr lvl="0" indent="0" marL="0"><a:buNone /></a:pPr><a:r><a:rPr /><a:t>厚度(nm)</a:t></a:r></a:p><a:p><a:pPr lvl="0" indent="0" marL="0"><a:buNone /></a:pPr><a:r><a:rPr /><a:t>接面寬度(μm)</a:t></a:r></a:p><a:p><a:pPr lvl="0" indent="0" marL="0"><a:buNone /></a:pPr><a:r><a:rPr /><a:t>參考接面長度(μm)</a:t></a:r></a:p><a:p><a:pPr lvl="0" indent="0" marL="0"><a:buNone /></a:pPr><a:r><a:rPr /><a:t>目標接面長度(μm)</a:t></a:r></a:p><a:p><a:pPr lvl="0" indent="0" marL="0"><a:buNone /></a:pPr><a:r><a:rPr /><a:t>臨界電流(μA)</a:t></a:r></a:p><a:p><a:pPr lvl="0" indent="0" marL="0"><a:buNone /></a:pPr><a:r><a:rPr /><a:t>重捕電流(μA)</a:t></a:r></a:p><a:p><a:pPr lvl="0" indent="0" marL="0"><a:buNone /></a:pPr><a:r><a:rPr /><a:t>正常態電阻(Ω)</a:t></a:r></a:p><a:p><a:pPr lvl="0" indent="0" marL="0"><a:buNone /></a:pPr><a:r><a:rPr /><a:t>IcRn (μV)</a:t></a:r></a:p><a:p><a:pPr lvl="0" indent="0" marL="0"><a:buNone /></a:pPr><a:r><a:rPr /><a:t>二極體效率(η)</a:t></a:r></a:p><a:p><a:pPr lvl="0" indent="0" marL="0"><a:buNone /></a:pPr><a:r><a:rPr /><a:t>鈮鈦厚度(nm)</a:t></a:r></a:p><a:p><a:pPr lvl="0" indent="0" marL="0"><a:buNone /></a:pPr><a:r><a:rPr /><a:t>備註</a:t></a:r></a:p><a:p><a:pPr lvl="0" indent="0" marL="0"><a:buNone /></a:pPr><a:r><a:rPr /><a:t>003-2</a:t></a:r></a:p><a:p><a:pPr lvl="0" indent="0" marL="0"><a:buNone /></a:pPr><a:r><a:rPr /><a:t>21.17</a:t></a:r></a:p><a:p><a:pPr lvl="0" indent="0" marL="0"><a:buNone /></a:pPr><a:r><a:rPr /><a:t>1.16</a:t></a:r></a:p><a:p><a:pPr lvl="0" indent="0" marL="0"><a:buNone /></a:pPr><a:r><a:rPr /><a:t>0.40</a:t></a:r></a:p><a:p><a:pPr lvl="0" indent="0" marL="0"><a:buNone /></a:pPr><a:r><a:rPr /><a:t>0.73</a:t></a:r></a:p><a:p><a:pPr lvl="0" indent="0" marL="0"><a:buNone /></a:pPr><a:r><a:rPr /><a:t>19.1</a:t></a:r></a:p><a:p><a:pPr lvl="0" indent="0" marL="0"><a:buNone /></a:pPr><a:r><a:rPr /><a:t>3</a:t></a:r></a:p><a:p><a:pPr lvl="0" indent="0" marL="0"><a:buNone /></a:pPr><a:r><a:rPr /><a:t>1.92</a:t></a:r></a:p><a:p><a:pPr lvl="0" indent="0" marL="0"><a:buNone /></a:pPr><a:r><a:rPr /><a:t>36.6</a:t></a:r></a:p><a:p><a:pPr lvl="0" indent="0" marL="0"><a:buNone /></a:pPr><a:r><a:rPr /><a:t>150</a:t></a:r></a:p><a:p><a:pPr lvl="0" indent="0" marL="0"><a:buNone /></a:pPr><a:r><a:rPr /><a:t>003-3</a:t></a:r></a:p><a:p><a:pPr lvl="0" indent="0" marL="0"><a:buNone /></a:pPr><a:r><a:rPr /><a:t>27.79</a:t></a:r></a:p><a:p><a:pPr lvl="0" indent="0" marL="0"><a:buNone /></a:pPr><a:r><a:rPr /><a:t>0.88</a:t></a:r></a:p><a:p><a:pPr lvl="0" indent="0" marL="0"><a:buNone /></a:pPr><a:r><a:rPr /><a:t>0.33</a:t></a:r></a:p><a:p><a:pPr lvl="0" indent="0" marL="0"><a:buNone /></a:pPr><a:r><a:rPr /><a:t>0.65</a:t></a:r></a:p><a:p><a:pPr lvl="0" indent="0" marL="0"><a:buNone /></a:pPr><a:r><a:rPr /><a:t>14.5</a:t></a:r></a:p><a:p><a:pPr lvl="0" indent="0" marL="0"><a:buNone /></a:pPr><a:r><a:rPr /><a:t>1.5</a:t></a:r></a:p><a:p><a:pPr lvl="0" indent="0" marL="0"><a:buNone /></a:pPr><a:r><a:rPr /><a:t>3.24</a:t></a:r></a:p><a:p><a:pPr lvl="0" indent="0" marL="0"><a:buNone /></a:pPr><a:r><a:rPr /><a:t>46.9</a:t></a:r></a:p><a:p><a:pPr lvl="0" indent="0" marL="0"><a:buNone /></a:pPr><a:r><a:rPr /><a:t>150</a:t></a:r></a:p><a:p><a:pPr lvl="0" indent="0" marL="0"><a:buNone /></a:pPr><a:r><a:rPr /><a:t>004-1</a:t></a:r></a:p><a:p><a:pPr lvl="0" indent="0" marL="0"><a:buNone /></a:pPr><a:r><a:rPr /><a:t>1.26</a:t></a:r></a:p><a:p><a:pPr lvl="0" indent="0" marL="0"><a:buNone /></a:pPr><a:r><a:rPr /><a:t>0.26</a:t></a:r></a:p><a:p><a:pPr lvl="0" indent="0" marL="0"><a:buNone /></a:pPr><a:r><a:rPr /><a:t>0.68</a:t></a:r></a:p><a:p><a:pPr lvl="0" indent="0" marL="0"><a:buNone /></a:pPr><a:r><a:rPr /><a:t>19.4</a:t></a:r></a:p><a:p><a:pPr lvl="0" indent="0" marL="0"><a:buNone /></a:pPr><a:r><a:rPr /><a:t>16</a:t></a:r></a:p><a:p><a:pPr lvl="0" indent="0" marL="0"><a:buNone /></a:pPr><a:r><a:rPr /><a:t>11.17</a:t></a:r></a:p><a:p><a:pPr lvl="0" indent="0" marL="0"><a:buNone /></a:pPr><a:r><a:rPr /><a:t>217.1</a:t></a:r></a:p><a:p><a:pPr lvl="0" indent="0" marL="0"><a:buNone /></a:pPr><a:r><a:rPr /><a:t>70</a:t></a:r></a:p><a:p><a:pPr lvl="0" indent="0" marL="0"><a:buNone /></a:pPr><a:r><a:rPr /><a:t>Only Ref. JJ</a:t></a:r></a:p><a:p><a:pPr lvl="0" indent="0" marL="0"><a:buNone /></a:pPr><a:r><a:rPr /><a:t>004-2</a:t></a:r></a:p><a:p><a:pPr lvl="0" indent="0" marL="0"><a:buNone /></a:pPr><a:r><a:rPr /><a:t>0.56</a:t></a:r></a:p><a:p><a:pPr lvl="0" indent="0" marL="0"><a:buNone /></a:pPr><a:r><a:rPr /><a:t>0.17</a:t></a:r></a:p><a:p><a:pPr lvl="0" indent="0" marL="0"><a:buNone /></a:pPr><a:r><a:rPr /><a:t>0.67</a:t></a:r></a:p><a:p><a:pPr lvl="0" indent="0" marL="0"><a:buNone /></a:pPr><a:r><a:rPr /><a:t>32.5</a:t></a:r></a:p><a:p><a:pPr lvl="0" indent="0" marL="0"><a:buNone /></a:pPr><a:r><a:rPr /><a:t>30</a:t></a:r></a:p><a:p><a:pPr lvl="0" indent="0" marL="0"><a:buNone /></a:pPr><a:r><a:rPr /><a:t>22.29</a:t></a:r></a:p><a:p><a:pPr lvl="0" indent="0" marL="0"><a:buNone /></a:pPr><a:r><a:rPr /><a:t>725.1</a:t></a:r></a:p><a:p><a:pPr lvl="0" indent="0" marL="0"><a:buNone /></a:pPr><a:r><a:rPr /><a:t>70</a:t></a:r></a:p><a:p><a:pPr lvl="0" indent="0" marL="0"><a:buNone /></a:pPr><a:r><a:rPr /><a:t>004-3</a:t></a:r></a:p><a:p><a:pPr lvl="0" indent="0" marL="0"><a:buNone /></a:pPr><a:r><a:rPr /><a:t>1.34</a:t></a:r></a:p><a:p><a:pPr lvl="0" indent="0" marL="0"><a:buNone /></a:pPr><a:r><a:rPr /><a:t>0.24</a:t></a:r></a:p><a:p><a:pPr lvl="0" indent="0" marL="0"><a:buNone /></a:pPr><a:r><a:rPr /><a:t>0.70</a:t></a:r></a:p><a:p><a:pPr lvl="0" indent="0" marL="0"><a:buNone /></a:pPr><a:r><a:rPr /><a:t>44.5</a:t></a:r></a:p><a:p><a:pPr lvl="0" indent="0" marL="0"><a:buNone /></a:pPr><a:r><a:rPr /><a:t>33</a:t></a:r></a:p><a:p><a:pPr lvl="0" indent="0" marL="0"><a:buNone /></a:pPr><a:r><a:rPr /><a:t>35.93</a:t></a:r></a:p><a:p><a:pPr lvl="0" indent="0" marL="0"><a:buNone /></a:pPr><a:r><a:rPr /><a:t>1600.4</a:t></a:r></a:p><a:p><a:pPr lvl="0" indent="0" marL="0"><a:buNone /></a:pPr><a:r><a:rPr /><a:t>70</a:t></a:r></a:p><a:p><a:pPr lvl="0" indent="0" marL="0"><a:buNone /></a:pPr><a:r><a:rPr /><a:t>005-1</a:t></a:r></a:p><a:p><a:pPr lvl="0" indent="0" marL="0"><a:buNone /></a:pPr><a:r><a:rPr /><a:t>63.5</a:t></a:r></a:p><a:p><a:pPr lvl="0" indent="0" marL="0"><a:buNone /></a:pPr><a:r><a:rPr /><a:t>1.15</a:t></a:r></a:p><a:p><a:pPr lvl="0" indent="0" marL="0"><a:buNone /></a:pPr><a:r><a:rPr /><a:t>0.42</a:t></a:r></a:p><a:p><a:pPr lvl="0" indent="0" marL="0"><a:buNone /></a:pPr><a:r><a:rPr /><a:t>0.87</a:t></a:r></a:p><a:p><a:pPr lvl="0" indent="0" marL="0"><a:buNone /></a:pPr><a:r><a:rPr /><a:t>88.4</a:t></a:r></a:p><a:p><a:pPr lvl="0" indent="0" marL="0"><a:buNone /></a:pPr><a:r><a:rPr /><a:t>28</a:t></a:r></a:p><a:p><a:pPr lvl="0" indent="0" marL="0"><a:buNone /></a:pPr><a:r><a:rPr /><a:t>0.30</a:t></a:r></a:p><a:p><a:pPr lvl="0" indent="0" marL="0"><a:buNone /></a:pPr><a:r><a:rPr /><a:t>26.5</a:t></a:r></a:p><a:p><a:pPr lvl="0" indent="0" marL="0"><a:buNone /></a:pPr><a:r><a:rPr /><a:t>70</a:t></a:r></a:p><a:p><a:pPr lvl="0" indent="0" marL="0"><a:buNone /></a:pPr><a:r><a:rPr /><a:t>005-2</a:t></a:r></a:p><a:p><a:pPr lvl="0" indent="0" marL="0"><a:buNone /></a:pPr><a:r><a:rPr /><a:t>24.2</a:t></a:r></a:p><a:p><a:pPr lvl="0" indent="0" marL="0"><a:buNone /></a:pPr><a:r><a:rPr /><a:t>1.57</a:t></a:r></a:p><a:p><a:pPr lvl="0" indent="0" marL="0"><a:buNone /></a:pPr><a:r><a:rPr /><a:t>0.41</a:t></a:r></a:p><a:p><a:pPr lvl="0" indent="0" marL="0"><a:buNone /></a:pPr><a:r><a:rPr /><a:t>0.88</a:t></a:r></a:p><a:p><a:pPr lvl="0" indent="0" marL="0"><a:buNone /></a:pPr><a:r><a:rPr /><a:t>33.9</a:t></a:r></a:p><a:p><a:pPr lvl="0" indent="0" marL="0"><a:buNone /></a:pPr><a:r><a:rPr /><a:t>6</a:t></a:r></a:p><a:p><a:pPr lvl="0" indent="0" marL="0"><a:buNone /></a:pPr><a:r><a:rPr /><a:t>1.07</a:t></a:r></a:p><a:p><a:pPr lvl="0" indent="0" marL="0"><a:buNone /></a:pPr><a:r><a:rPr /><a:t>36.2</a:t></a:r></a:p><a:p><a:pPr lvl="0" indent="0" marL="0"><a:buNone /></a:pPr><a:r><a:rPr /><a:t>70</a:t></a:r></a:p><a:p><a:pPr lvl="0" indent="0" marL="0"><a:buNone /></a:pPr><a:r><a:rPr /><a:t>019-1</a:t></a:r></a:p><a:p><a:pPr lvl="0" indent="0" marL="0"><a:buNone /></a:pPr><a:r><a:rPr /><a:t>2.59</a:t></a:r></a:p><a:p><a:pPr lvl="0" indent="0" marL="0"><a:buNone /></a:pPr><a:r><a:rPr /><a:t>1.53</a:t></a:r></a:p><a:p><a:pPr lvl="0" indent="0" marL="0"><a:buNone /></a:pPr><a:r><a:rPr /><a:t>2.26</a:t></a:r></a:p><a:p><a:pPr lvl="0" indent="0" marL="0"><a:buNone /></a:pPr><a:r><a:rPr /><a:t>13.8</a:t></a:r></a:p><a:p><a:pPr lvl="0" indent="0" marL="0"><a:buNone /></a:pPr><a:r><a:rPr /><a:t>1.5</a:t></a:r></a:p><a:p><a:pPr lvl="0" indent="0" marL="0"><a:buNone /></a:pPr><a:r><a:rPr /><a:t>0.70</a:t></a:r></a:p><a:p><a:pPr lvl="0" indent="0" marL="0"><a:buNone /></a:pPr><a:r><a:rPr /><a:t>9.7</a:t></a:r></a:p><a:p><a:pPr lvl="0" indent="0" marL="0"><a:buNone /></a:pPr><a:r><a:rPr /><a:t>120</a:t></a:r></a:p><a:p><a:pPr lvl="0" indent="0" marL="0"><a:buNone /></a:pPr><a:r><a:rPr /><a:t>019-3</a:t></a:r></a:p><a:p><a:pPr lvl="0" indent="0" marL="0"><a:buNone /></a:pPr><a:r><a:rPr /><a:t>1.73</a:t></a:r></a:p><a:p><a:pPr lvl="0" indent="0" marL="0"><a:buNone /></a:pPr><a:r><a:rPr /><a:t>1.52</a:t></a:r></a:p><a:p><a:pPr lvl="0" indent="0" marL="0"><a:buNone /></a:pPr><a:r><a:rPr /><a:t>2.36</a:t></a:r></a:p><a:p><a:pPr lvl="0" indent="0" marL="0"><a:buNone /></a:pPr><a:r><a:rPr /><a:t>13.3</a:t></a:r></a:p><a:p><a:pPr lvl="0" indent="0" marL="0"><a:buNone /></a:pPr><a:r><a:rPr /><a:t>0.8</a:t></a:r></a:p><a:p><a:pPr lvl="0" indent="0" marL="0"><a:buNone /></a:pPr><a:r><a:rPr /><a:t>1.25</a:t></a:r></a:p><a:p><a:pPr lvl="0" indent="0" marL="0"><a:buNone /></a:pPr><a:r><a:rPr /><a:t>16.7</a:t></a:r></a:p><a:p><a:pPr lvl="0" indent="0" marL="0"><a:buNone /></a:pPr><a:r><a:rPr /><a:t>120</a:t></a:r></a:p><a:p><a:pPr lvl="0" indent="0" marL="0"><a:buNone /></a:pPr><a:r><a:rPr /><a:t>019-5</a:t></a:r></a:p><a:p><a:pPr lvl="0" indent="0" marL="0"><a:buNone /></a:pPr><a:r><a:rPr /><a:t>3.42</a:t></a:r></a:p><a:p><a:pPr lvl="0" indent="0" marL="0"><a:buNone /></a:pPr><a:r><a:rPr /><a:t>1.79</a:t></a:r></a:p><a:p><a:pPr lvl="0" indent="0" marL="0"><a:buNone /></a:pPr><a:r><a:rPr /><a:t>6.09</a:t></a:r></a:p><a:p><a:pPr lvl="0" indent="0" marL="0"><a:buNone /></a:pPr><a:r><a:rPr /><a:t>14.8</a:t></a:r></a:p><a:p><a:pPr lvl="0" indent="0" marL="0"><a:buNone /></a:pPr><a:r><a:rPr /><a:t>6</a:t></a:r></a:p><a:p><a:pPr lvl="0" indent="0" marL="0"><a:buNone /></a:pPr><a:r><a:rPr /><a:t>0.26</a:t></a:r></a:p><a:p><a:pPr lvl="0" indent="0" marL="0"><a:buNone /></a:pPr><a:r><a:rPr /><a:t>3.9</a:t></a:r></a:p><a:p><a:pPr lvl="0" indent="0" marL="0"><a:buNone /></a:pPr><a:r><a:rPr /><a:t>120</a:t></a:r></a:p><a:p><a:pPr lvl="0" indent="0" marL="0"><a:spcBef><a:spcPts val="3000" /></a:spcBef><a:buNone /></a:pPr><a:r><a:rPr b="1" /><a:t>PtTe2、NbTi量子輸運參數表</a:t></a:r></a:p></p:txBody></p:sp><p:graphicFrame><p:nvGraphicFramePr><p:cNvPr id="6" name="Content Placeholder 5" /><p:cNvGraphicFramePr><a:graphicFrameLocks noGrp="1" /></p:cNvGraphicFramePr><p:nvPr><p:ph idx="1" /></p:nvPr></p:nvGraphicFramePr><p:xfrm><a:off x="3568700" y="203200" /><a:ext cx="5105400" cy="3873500" /></p:xfrm><a:graphic><a:graphicData uri="http://schemas.openxmlformats.org/drawingml/2006/table"><a:tbl><a:tblPr firstRow="1" bandRow="1"><a:tableStyleId>{5C22544A-7EE6-4342-B048-85BDC9FD1C3A}</a:tableStyleId></a:tblPr><a:tblGrid><a:gridCol w="1231900" /><a:gridCol w="1930400" /><a:gridCol w="698500" /><a:gridCol w="762000" /><a:gridCol w="469900" /></a:tblGrid><a:tr h="0"><a:tc><a:txBody><a:bodyPr /><a:lstStyle /><a:p><a:pPr lvl="0" indent="0" marL="0" algn="ctr"><a:buNone /></a:pPr><a:r><a:rPr b="1" /><a:t>參數</a:t></a:r></a:p></a:txBody><a:tcPr /></a:tc><a:tc><a:txBody><a:bodyPr /><a:lstStyle /><a:p><a:pPr lvl="0" indent="0" marL="0" algn="ctr"><a:buNone /></a:pPr><a:r><a:rPr b="1" /><a:t>符號</a:t></a:r></a:p></a:txBody><a:tcPr /></a:tc><a:tc><a:txBody><a:bodyPr /><a:lstStyle /><a:p><a:pPr lvl="0" indent="0" marL="0" algn="ctr"><a:buNone /></a:pPr><a:r><a:rPr b="1" /><a:t>NbTi</a:t></a:r></a:p></a:txBody><a:tcPr /></a:tc><a:tc><a:txBody><a:bodyPr /><a:lstStyle /><a:p><a:pPr lvl="0" indent="0" marL="0" algn="ctr"><a:buNone /></a:pPr><a:r><a:rPr b="1" /><a:t>PtTe2</a:t></a:r></a:p></a:txBody><a:tcPr /></a:tc><a:tc><a:txBody><a:bodyPr /><a:lstStyle /><a:p><a:pPr lvl="0" indent="0" marL="0" algn="ctr"><a:buNone /></a:pPr><a:r><a:rPr b="1" /><a:t>單位</a:t></a:r></a:p></a:txBody><a:tcPr /></a:tc></a:tr><a:tr h="0"><a:tc><a:txBody><a:bodyPr /><a:lstStyle /><a:p><a:pPr lvl="0" indent="0" marL="0" algn="ctr"><a:buNone /></a:pPr><a:r><a:rPr b="1" /><a:t>費米速度</a:t></a:r><a:br /><a:r><a:rPr b="1" /><a:t>Fermi velocity</a:t></a:r></a:p></a:txBody></a:tc><a:tc><a:txBody><a:bodyPr /><a:lstStyle /><a:p><a:pPr lvl="0" indent="0" marL="0" algn="ctr"><a:buNone /></a:pPr><a14:m><m:oMath xmlns:m="http://schemas.openxmlformats.org/officeDocument/2006/math"><m:sSub><m:e><m:r><m:t>v</m:t></m:r></m:e><m:sub><m:r><m:t>F</m:t></m:r></m:sub></m:sSub></m:oMath></a14:m></a:p></a:txBody></a:tc><a:tc><a:txBody><a:bodyPr /><a:lstStyle /><a:p><a:pPr lvl="0" indent="0" marL="0" algn="ctr"><a:buNone /></a:pPr><a:r><a:rPr /><a:t>≈ 1.25–1.55</a:t></a:r></a:p></a:txBody></a:tc><a:tc><a:txBody><a:bodyPr /><a:lstStyle /><a:p><a:pPr lvl="0" indent="0" marL="0" algn="ctr"><a:buNone /></a:pPr><a14:m><m:oMath xmlns:m="http://schemas.openxmlformats.org/officeDocument/2006/math"><m:r><m:t>3.3</m:t></m:r><m:r><m:rPr><m:sty m:val="p" /></m:rPr><m:t>×</m:t></m:r><m:sSup><m:e><m:r><m:t>10</m:t></m:r></m:e><m:sup><m:r><m:rPr><m:sty m:val="p" /></m:rPr><m:t>−</m:t></m:r><m:r><m:t>5</m:t></m:r></m:sup></m:sSup></m:oMath></a14:m></a:p></a:txBody></a:tc><a:tc><a:txBody><a:bodyPr /><a:lstStyle /><a:p><a:pPr lvl="0" indent="0" marL="0" algn="ctr"><a:buNone /></a:pPr><a:r><a:rPr /><a:t>m/s</a:t></a:r></a:p></a:txBody></a:tc></a:tr><a:tr h="0"><a:tc><a:txBody><a:bodyPr /><a:lstStyle /><a:p><a:pPr lvl="0" indent="0" marL="0" algn="ctr"><a:buNone /></a:pPr><a:r><a:rPr b="1" /><a:t>平均碰撞時間</a:t></a:r><a:br /><a:r><a:rPr b="1" /><a:t>Mean free time</a:t></a:r></a:p></a:txBody></a:tc><a:tc><a:txBody><a:bodyPr /><a:lstStyle /><a:p><a:pPr lvl="0" indent="0" marL="0" algn="ctr"><a:buNone /></a:pPr><a14:m><m:oMath xmlns:m="http://schemas.openxmlformats.org/officeDocument/2006/math"><m:r><m:t>τ</m:t></m:r></m:oMath></a14:m></a:p></a:txBody></a:tc><a:tc><a:txBody><a:bodyPr /><a:lstStyle /><a:p><a:pPr lvl="0" indent="0" marL="0" algn="ctr"><a:buNone /></a:pPr><a:r><a:rPr /><a:t>≈ 10⁻¹²–10⁻¹¹</a:t></a:r></a:p></a:txBody></a:tc><a:tc><a:txBody><a:bodyPr /><a:lstStyle /><a:p><a:pPr lvl="0" indent="0" marL="0" algn="ctr"><a:buNone /></a:pPr><a:r><a:rPr /><a:t>≈ 10⁻¹²–10⁻¹¹</a:t></a:r></a:p></a:txBody></a:tc><a:tc><a:txBody><a:bodyPr /><a:lstStyle /><a:p><a:pPr lvl="0" indent="0" marL="0" algn="ctr"><a:buNone /></a:pPr><a:r><a:rPr /><a:t>s</a:t></a:r></a:p></a:txBody></a:tc></a:tr><a:tr h="0"><a:tc><a:txBody><a:bodyPr /><a:lstStyle /><a:p><a:pPr lvl="0" indent="0" marL="0" algn="ctr"><a:buNone /></a:pPr><a:r><a:rPr b="1" /><a:t>擴散係數</a:t></a:r><a:br /><a:r><a:rPr b="1" /><a:t>Diffusion coefficient</a:t></a:r></a:p></a:txBody></a:tc><a:tc><a:txBody><a:bodyPr /><a:lstStyle /><a:p><a:pPr lvl="0" indent="0" marL="0" algn="ctr"><a:buNone /></a:pPr><a14:m><m:oMath xmlns:m="http://schemas.openxmlformats.org/officeDocument/2006/math"><m:r><m:t>D</m:t></m:r><m:r><m:rPr><m:sty m:val="p" /></m:rPr><m:t>=</m:t></m:r><m:sSubSup><m:e><m:r><m:t>v</m:t></m:r></m:e><m:sub><m:r><m:t>F</m:t></m:r></m:sub><m:sup><m:r><m:t>2</m:t></m:r></m:sup></m:sSubSup><m:f><m:fPr><m:type m:val="bar" /></m:fPr><m:num><m:r><m:t>τ</m:t></m:r></m:num><m:den><m:r><m:t>2</m:t></m:r></m:den></m:f></m:oMath></a14:m></a:p></a:txBody></a:tc><a:tc><a:txBody><a:bodyPr /><a:lstStyle /><a:p><a:pPr lvl="0" indent="0" marL="0" algn="ctr"><a:buNone /></a:pPr><a:r><a:rPr /><a:t>≈ 5.6×10²–5.6×10³</a:t></a:r></a:p></a:txBody></a:tc><a:tc><a:txBody><a:bodyPr /><a:lstStyle /><a:p><a:pPr lvl="0" indent="0" marL="0" algn="ctr"><a:buNone /></a:pPr><a:r><a:rPr /><a:t>≈ 1.5×10²–2.4×10³</a:t></a:r></a:p></a:txBody></a:tc><a:tc><a:txBody><a:bodyPr /><a:lstStyle /><a:p><a:pPr lvl="0" indent="0" marL="0" algn="ctr"><a:buNone /></a:pPr><a:r><a:rPr /><a:t>cm²/s</a:t></a:r></a:p></a:txBody></a:tc></a:tr><a:tr h="0"><a:tc><a:txBody><a:bodyPr /><a:lstStyle /><a:p><a:pPr lvl="0" indent="0" marL="0" algn="ctr"><a:buNone /></a:pPr><a:r><a:rPr b="1" /><a:t>電阻率</a:t></a:r><a:br /><a:r><a:rPr b="1" /><a:t>Resistivity</a:t></a:r><a:r><a:rPr /><a:t> ¹</a:t></a:r></a:p></a:txBody></a:tc><a:tc><a:txBody><a:bodyPr /><a:lstStyle /><a:p><a:pPr lvl="0" indent="0" marL="0" algn="ctr"><a:buNone /></a:pPr><a14:m><m:oMath xmlns:m="http://schemas.openxmlformats.org/officeDocument/2006/math"><m:r><m:t>ρ</m:t></m:r><m:r><m:rPr><m:sty m:val="p" /></m:rPr><m:t>=</m:t></m:r><m:sSup><m:e><m:d><m:dPr><m:begChr m:val="[" /><m:sepChr m:val="" /><m:endChr m:val="]" /><m:grow /></m:dPr><m:e><m:sSub><m:e><m:r><m:t>n</m:t></m:r></m:e><m:sub><m:r><m:t>s</m:t></m:r></m:sub></m:sSub><m:r><m:t>e</m:t></m:r><m:sSub><m:e><m:r><m:t>μ</m:t></m:r></m:e><m:sub><m:r><m:t>e</m:t></m:r></m:sub></m:sSub></m:e></m:d></m:e><m:sup><m:r><m:rPr><m:sty m:val="p" /></m:rPr><m:t>−</m:t></m:r><m:r><m:t>1</m:t></m:r></m:sup></m:sSup></m:oMath></a14:m></a:p></a:txBody></a:tc><a:tc><a:txBody><a:bodyPr /><a:lstStyle /><a:p><a:pPr lvl="0" indent="0" marL="0" algn="ctr"><a:buNone /></a:pPr><a:r><a:rPr /><a:t>≈ 0.001–0.01</a:t></a:r></a:p></a:txBody></a:tc><a:tc><a:txBody><a:bodyPr /><a:lstStyle /><a:p><a:pPr lvl="0" indent="0" marL="0" algn="ctr"><a:buNone /></a:pPr><a:r><a:rPr /><a:t>≈ 0.0002–0.002</a:t></a:r></a:p></a:txBody></a:tc><a:tc><a:txBody><a:bodyPr /><a:lstStyle /><a:p><a:pPr lvl="0" indent="0" marL="0" algn="ctr"><a:buNone /></a:pPr><a:r><a:rPr /><a:t>kΩ (per □)</a:t></a:r></a:p></a:txBody></a:tc></a:tr><a:tr h="0"><a:tc><a:txBody><a:bodyPr /><a:lstStyle /><a:p><a:pPr lvl="0" indent="0" marL="0" algn="ctr"><a:buNone /></a:pPr><a:r><a:rPr b="1" /><a:t>費米波長</a:t></a:r><a:br /><a:r><a:rPr b="1" /><a:t>Fermi wavelength</a:t></a:r></a:p></a:txBody></a:tc><a:tc><a:txBody><a:bodyPr /><a:lstStyle /><a:p><a:pPr lvl="0" indent="0" marL="0" algn="ctr"><a:buNone /></a:pPr><a14:m><m:oMath xmlns:m="http://schemas.openxmlformats.org/officeDocument/2006/math"><m:sSub><m:e><m:r><m:t>λ</m:t></m:r></m:e><m:sub><m:r><m:t>F</m:t></m:r></m:sub></m:sSub><m:r><m:rPr><m:sty m:val="p" /></m:rPr><m:t>=</m:t></m:r><m:r><m:t>2</m:t></m:r><m:f><m:fPr><m:type m:val="bar" /></m:fPr><m:num><m:r><m:t>π</m:t></m:r></m:num><m:den><m:sSub><m:e><m:r><m:t>k</m:t></m:r></m:e><m:sub><m:r><m:t>F</m:t></m:r></m:sub></m:sSub></m:den></m:f></m:oMath></a14:m></a:p></a:txBody></a:tc><a:tc><a:txBody><a:bodyPr /><a:lstStyle /><a:p><a:pPr lvl="0" indent="0" marL="0" algn="ctr"><a:buNone /></a:pPr><a:r><a:rPr /><a:t>≈ 0.32 nm</a:t></a:r></a:p></a:txBody></a:tc><a:tc><a:txBody><a:bodyPr /><a:lstStyle /><a:p><a:pPr lvl="0" indent="0" marL="0" algn="ctr"><a:buNone /></a:pPr><a:r><a:rPr /><a:t>≈ 7–11 nm</a:t></a:r></a:p></a:txBody></a:tc><a:tc><a:txBody><a:bodyPr /><a:lstStyle /><a:p><a:pPr lvl="0" indent="0" marL="0" algn="ctr"><a:buNone /></a:pPr><a:r><a:rPr /><a:t>nm</a:t></a:r></a:p></a:txBody></a:tc></a:tr><a:tr h="0"><a:tc><a:txBody><a:bodyPr /><a:lstStyle /><a:p><a:pPr lvl="0" indent="0" marL="0" algn="ctr"><a:buNone /></a:pPr><a:r><a:rPr b="1" /><a:t>平均自由路徑</a:t></a:r><a:br /><a:r><a:rPr b="1" /><a:t>Mean-free path</a:t></a:r></a:p></a:txBody></a:tc><a:tc><a:txBody><a:bodyPr /><a:lstStyle /><a:p><a:pPr lvl="0" indent="0" marL="0" algn="ctr"><a:buNone /></a:pPr><a14:m><m:oMath xmlns:m="http://schemas.openxmlformats.org/officeDocument/2006/math"><m:sSub><m:e><m:r><m:t>l</m:t></m:r></m:e><m:sub><m:r><m:t>e</m:t></m:r></m:sub></m:sSub><m:r><m:rPr><m:sty m:val="p" /></m:rPr><m:t>=</m:t></m:r><m:sSub><m:e><m:r><m:t>v</m:t></m:r></m:e><m:sub><m:r><m:t>F</m:t></m:r></m:sub></m:sSub><m:r><m:t>τ</m:t></m:r></m:oMath></a14:m></a:p></a:txBody></a:tc><a:tc><a:txBody><a:bodyPr /><a:lstStyle /><a:p><a:pPr lvl="0" indent="0" marL="0" algn="ctr"><a:buNone /></a:pPr><a:r><a:rPr /><a:t>80–800</a:t></a:r></a:p></a:txBody></a:tc><a:tc><a:txBody><a:bodyPr /><a:lstStyle /><a:p><a:pPr lvl="0" indent="0" marL="0" algn="ctr"><a:buNone /></a:pPr><a:r><a:rPr /><a:t>180</a:t></a:r></a:p></a:txBody></a:tc><a:tc><a:txBody><a:bodyPr /><a:lstStyle /><a:p><a:pPr lvl="0" indent="0" marL="0" algn="ctr"><a:buNone /></a:pPr><a:r><a:rPr /><a:t>nm</a:t></a:r></a:p></a:txBody></a:tc></a:tr><a:tr h="0"><a:tc><a:txBody><a:bodyPr /><a:lstStyle /><a:p><a:pPr lvl="0" indent="0" marL="0" algn="ctr"><a:buNone /></a:pPr><a:r><a:rPr b="1" /><a:t>載子遷移率</a:t></a:r><a:br /><a:r><a:rPr b="1" /><a:t>Electron mobility</a:t></a:r></a:p></a:txBody></a:tc><a:tc><a:txBody><a:bodyPr /><a:lstStyle /><a:p><a:pPr lvl="0" indent="0" marL="0" algn="ctr"><a:buNone /></a:pPr><a14:m><m:oMath xmlns:m="http://schemas.openxmlformats.org/officeDocument/2006/math"><m:sSub><m:e><m:r><m:t>μ</m:t></m:r></m:e><m:sub><m:r><m:t>e</m:t></m:r></m:sub></m:sSub><m:r><m:rPr><m:sty m:val="p" /></m:rPr><m:t>=</m:t></m:r><m:f><m:fPr><m:type m:val="bar" /></m:fPr><m:num><m:sSub><m:e><m:r><m:t>v</m:t></m:r></m:e><m:sub><m:r><m:t>F</m:t></m:r></m:sub></m:sSub></m:num><m:den><m:sSub><m:e><m:r><m:t>l</m:t></m:r></m:e><m:sub><m:r><m:t>e</m:t></m:r></m:sub></m:sSub></m:den></m:f></m:oMath></a14:m></a:p></a:txBody></a:tc><a:tc><a:txBody><a:bodyPr /><a:lstStyle /><a:p><a:pPr lvl="0" indent="0" marL="0" algn="ctr"><a:buNone /></a:pPr><a:r><a:rPr /><a:t>≈ 1.25–1.55</a:t></a:r></a:p></a:txBody></a:tc><a:tc><a:txBody><a:bodyPr /><a:lstStyle /><a:p><a:pPr lvl="0" indent="0" marL="0" algn="ctr"><a:buNone /></a:pPr><a:r><a:rPr /><a:t>≈ 6.5–7.5</a:t></a:r></a:p></a:txBody></a:tc><a:tc><a:txBody><a:bodyPr /><a:lstStyle /><a:p><a:pPr lvl="0" indent="0" marL="0" algn="ctr"><a:buNone /></a:pPr><a:r><a:rPr /><a:t>cm²/Vs</a:t></a:r></a:p></a:txBody></a:tc></a:tr><a:tr h="0"><a:tc><a:txBody><a:bodyPr /><a:lstStyle /><a:p><a:pPr lvl="0" indent="0" marL="0" algn="ctr"><a:buNone /></a:pPr><a:r><a:rPr b="1" /><a:t>狄拉克點</a:t></a:r><a:br /><a:r><a:rPr b="1" /><a:t>Dirac point</a:t></a:r></a:p></a:txBody></a:tc><a:tc><a:txBody><a:bodyPr /><a:lstStyle /><a:p><a:pPr lvl="0" indent="0" marL="0" algn="ctr"><a:buNone /></a:pPr><a14:m><m:oMath xmlns:m="http://schemas.openxmlformats.org/officeDocument/2006/math"><m:sSub><m:e><m:r><m:t>E</m:t></m:r></m:e><m:sub><m:r><m:t>D</m:t></m:r></m:sub></m:sSub></m:oMath></a14:m></a:p></a:txBody></a:tc><a:tc><a:txBody><a:bodyPr /><a:lstStyle /><a:p><a:pPr lvl="0" indent="0" marL="0" algn="ctr"><a:buNone /></a:pPr><a:r><a:rPr /><a:t>≈ 0.32 eV</a:t></a:r></a:p></a:txBody></a:tc><a:tc><a:txBody><a:bodyPr /><a:lstStyle /><a:p><a:pPr lvl="0" indent="0" marL="0" algn="ctr"><a:buNone /></a:pPr><a:r><a:rPr /><a:t>≈ 0.32 eV</a:t></a:r></a:p></a:txBody></a:tc><a:tc><a:txBody><a:bodyPr /><a:lstStyle /><a:p><a:pPr lvl="0" indent="0" marL="0" algn="ctr"><a:buNone /></a:pPr><a:r><a:rPr /><a:t>eV</a:t></a:r></a:p></a:txBody></a:tc></a:tr><a:tr h="0"><a:tc><a:txBody><a:bodyPr /><a:lstStyle /><a:p><a:pPr lvl="0" indent="0" marL="0" algn="ctr"><a:buNone /></a:pPr><a:r><a:rPr b="1" /><a:t>超導相干長度</a:t></a:r><a:br /><a:r><a:rPr b="1" /><a:t>Superconducting coherence length</a:t></a:r></a:p></a:txBody></a:tc><a:tc><a:txBody><a:bodyPr /><a:lstStyle /><a:p><a:pPr lvl="0" indent="0" marL="0" algn="ctr"><a:buNone /></a:pPr><a14:m><m:oMath xmlns:m="http://schemas.openxmlformats.org/officeDocument/2006/math"><m:r><m:t>ξ</m:t></m:r></m:oMath></a14:m></a:p></a:txBody></a:tc><a:tc><a:txBody><a:bodyPr /><a:lstStyle /><a:p><a:pPr lvl="0" indent="0" marL="0" algn="ctr"><a:buNone /></a:pPr><a:r><a:rPr /><a:t>≈ 10 nm</a:t></a:r></a:p></a:txBody></a:tc><a:tc><a:txBody><a:bodyPr /><a:lstStyle /><a:p><a:pPr lvl="0" indent="0" marL="0" algn="ctr"><a:buNone /></a:pPr><a:r><a:rPr /><a:t>≈ 10 nm</a:t></a:r></a:p></a:txBody></a:tc><a:tc><a:txBody><a:bodyPr /><a:lstStyle /><a:p><a:pPr lvl="0" indent="0" marL="0" algn="ctr"><a:buNone /></a:pPr><a:r><a:rPr /><a:t>nm</a:t></a:r></a:p></a:txBody></a:tc></a:tr></a:tbl></a:graphicData></a:graphic></p:graphicFrame><p:sp><p:nvSpPr><p:cNvPr id="1" name="TextBox 3" /><p:cNvSpPr txBox="1" /><p:nvPr /></p:nvSpPr><p:spPr><a:xfrm><a:off x="3568700" y="4076700" /><a:ext cx="5105400" cy="508000" /></a:xfrm><a:prstGeom prst="rect"><a:avLst /></a:prstGeom><a:noFill /></p:spPr><p:txBody><a:bodyPr /><a:lstStyle /><a:p><a:pPr lvl="0" indent="0" marL="0" algn="ctr"><a:buNone /></a:pPr><a:r><a:rPr /><a:t>PtTe2、NbTi量子輸運參數表</a:t></a:r></a:p></p:txBody></p:sp></p:spTree></p:cSld></p:sld>
-</file>
-
-<file path=ppt/slides/slide28.xml><?xml version="1.0" encoding="utf-8"?>
-<p:sld xmlns:a="http://schemas.openxmlformats.org/drawingml/2006/main" xmlns:r="http://schemas.openxmlformats.org/officeDocument/2006/relationships" xmlns:p="http://schemas.openxmlformats.org/presentationml/2006/main">
-  <p:cSld>
-    <p:spTree>
-      <p:nvGrpSpPr>
-        <p:cNvPr id="1" name=""/>
-        <p:cNvGrpSpPr/>
-        <p:nvPr/>
-      </p:nvGrpSpPr>
-      <p:grpSpPr>
-        <a:xfrm>
-          <a:off x="0" y="0"/>
-          <a:ext cx="0" cy="0"/>
-          <a:chOff x="0" y="0"/>
-          <a:chExt cx="0" cy="0"/>
-        </a:xfrm>
-      </p:grpSpPr>
-      <p:sp>
-        <p:nvSpPr>
-          <p:cNvPr id="2" name="Title 1"/>
-          <p:cNvSpPr>
-            <a:spLocks noGrp="1"/>
-          </p:cNvSpPr>
-          <p:nvPr>
-            <p:ph type="title"/>
-          </p:nvPr>
-        </p:nvSpPr>
-        <p:spPr>
-          <a:xfrm>
-            <a:off x="722313" y="3305176"/>
-            <a:ext cx="7772400" cy="1021556"/>
-          </a:xfrm>
-        </p:spPr>
-        <p:txBody>
-          <a:bodyPr/>
-          <a:lstStyle/>
-          <a:p>
-            <a:pPr lvl="0" indent="0" marL="0">
-              <a:buNone/>
-            </a:pPr>
-            <a:r>
-              <a:rPr/>
-              <a:t>參考文獻</a:t>
-            </a:r>
-          </a:p>
-        </p:txBody>
-      </p:sp>
-    </p:spTree>
-  </p:cSld>
-</p:sld>
-</file>
-
-<file path=ppt/slides/slide29.xml><?xml version="1.0" encoding="utf-8"?>
-<p:sld xmlns:a="http://schemas.openxmlformats.org/drawingml/2006/main" xmlns:r="http://schemas.openxmlformats.org/officeDocument/2006/relationships" xmlns:p="http://schemas.openxmlformats.org/presentationml/2006/main">
-  <p:cSld>
-    <p:spTree>
-      <p:nvGrpSpPr>
-        <p:cNvPr id="1" name=""/>
-        <p:cNvGrpSpPr/>
-        <p:nvPr/>
-      </p:nvGrpSpPr>
-      <p:grpSpPr>
-        <a:xfrm>
-          <a:off x="0" y="0"/>
-          <a:ext cx="0" cy="0"/>
-          <a:chOff x="0" y="0"/>
-          <a:chExt cx="0" cy="0"/>
-        </a:xfrm>
-      </p:grpSpPr>
-    </p:spTree>
-  </p:cSld>
-</p:sld>
-</file>
-
-<file path=ppt/slides/slide3.xml><?xml version="1.0" encoding="utf-8"?>
 <p:sld xmlns:a="http://schemas.openxmlformats.org/drawingml/2006/main" xmlns:r="http://schemas.openxmlformats.org/officeDocument/2006/relationships" xmlns:p="http://schemas.openxmlformats.org/presentationml/2006/main">
   <p:cSld>
     <p:spTree>
@@ -6429,7 +6385,12 @@
                 <p:ph type="title"/>
               </p:nvPr>
             </p:nvSpPr>
-            <p:spPr/>
+            <p:spPr>
+              <a:xfrm>
+                <a:off x="722313" y="3305176"/>
+                <a:ext cx="7772400" cy="1021556"/>
+              </a:xfrm>
+            </p:spPr>
             <p:txBody>
               <a:bodyPr/>
               <a:lstStyle/>
@@ -6439,7 +6400,7 @@
                 </a:pPr>
                 <a:r>
                   <a:rPr/>
-                  <a:t>研究背景與動機：為何選擇 PtTe</a:t>
+                  <a:t>收斂與下一步：PtTe</a:t>
                 </a:r>
                 <a14:m>
                   <m:oMath xmlns:m="http://schemas.openxmlformats.org/officeDocument/2006/math">
@@ -6459,13 +6420,445 @@
                 </a14:m>
                 <a:r>
                   <a:rPr/>
-                  <a:t>？</a:t>
+                  <a:t> 展現可調式 CPR 平台</a:t>
                 </a:r>
               </a:p>
             </p:txBody>
           </p:sp>
         </mc:Choice>
       </mc:AlternateContent>
+    </p:spTree>
+  </p:cSld>
+</p:sld>
+</file>
+
+<file path=ppt/slides/slide27.xml><?xml version="1.0" encoding="utf-8"?>
+<p:sld xmlns:a="http://schemas.openxmlformats.org/drawingml/2006/main" xmlns:r="http://schemas.openxmlformats.org/officeDocument/2006/relationships" xmlns:p="http://schemas.openxmlformats.org/presentationml/2006/main">
+  <p:cSld>
+    <p:spTree>
+      <p:nvGrpSpPr>
+        <p:cNvPr id="1" name=""/>
+        <p:cNvGrpSpPr/>
+        <p:nvPr/>
+      </p:nvGrpSpPr>
+      <p:grpSpPr>
+        <a:xfrm>
+          <a:off x="0" y="0"/>
+          <a:ext cx="0" cy="0"/>
+          <a:chOff x="0" y="0"/>
+          <a:chExt cx="0" cy="0"/>
+        </a:xfrm>
+      </p:grpSpPr>
+      <p:sp>
+        <p:nvSpPr>
+          <p:cNvPr id="2" name="Title 1"/>
+          <p:cNvSpPr>
+            <a:spLocks noGrp="1"/>
+          </p:cNvSpPr>
+          <p:nvPr>
+            <p:ph type="title"/>
+          </p:nvPr>
+        </p:nvSpPr>
+        <p:spPr/>
+        <p:txBody>
+          <a:bodyPr/>
+          <a:lstStyle/>
+          <a:p>
+            <a:pPr lvl="0" indent="0" marL="0">
+              <a:buNone/>
+            </a:pPr>
+            <a:r>
+              <a:rPr/>
+              <a:t>主要回答：磁場可重塑 CPR 並建立相位偏壓</a:t>
+            </a:r>
+          </a:p>
+        </p:txBody>
+      </p:sp>
+      <mc:AlternateContent xmlns:mc="http://schemas.openxmlformats.org/markup-compatibility/2006">
+        <mc:Choice xmlns:a14="http://schemas.microsoft.com/office/drawing/2010/main" Requires="a14">
+          <p:sp>
+            <p:nvSpPr>
+              <p:cNvPr id="3" name="Content Placeholder 2"/>
+              <p:cNvSpPr>
+                <a:spLocks noGrp="1"/>
+              </p:cNvSpPr>
+              <p:nvPr>
+                <p:ph idx="1"/>
+              </p:nvPr>
+            </p:nvSpPr>
+            <p:spPr/>
+            <p:txBody>
+              <a:bodyPr/>
+              <a:lstStyle/>
+              <a:p>
+                <a:pPr lvl="0" indent="-342900" marL="342900">
+                  <a:buAutoNum type="arabicPeriod"/>
+                </a:pPr>
+                <a:r>
+                  <a:rPr b="1"/>
+                  <a:t>高品質平台</a:t>
+                </a:r>
+                <a:r>
+                  <a:rPr/>
+                  <a:t>：以非對稱 SQUID 量測高透明 PtTe</a:t>
+                </a:r>
+                <a14:m>
+                  <m:oMath xmlns:m="http://schemas.openxmlformats.org/officeDocument/2006/math">
+                    <m:sSub>
+                      <m:e>
+                        <m:r>
+                          <m:t>​</m:t>
+                        </m:r>
+                      </m:e>
+                      <m:sub>
+                        <m:r>
+                          <m:t>2</m:t>
+                        </m:r>
+                      </m:sub>
+                    </m:sSub>
+                  </m:oMath>
+                </a14:m>
+                <a:r>
+                  <a:rPr/>
+                  <a:t> 接面，完成 </a:t>
+                </a:r>
+                <a14:m>
+                  <m:oMath xmlns:m="http://schemas.openxmlformats.org/officeDocument/2006/math">
+                    <m:r>
+                      <m:rPr>
+                        <m:nor/>
+                        <m:sty m:val="p"/>
+                      </m:rPr>
+                      <m:t>Swath</m:t>
+                    </m:r>
+                  </m:oMath>
+                </a14:m>
+                <a:r>
+                  <a:rPr/>
+                  <a:t> 階段的品質驗證。</a:t>
+                </a:r>
+              </a:p>
+              <a:p>
+                <a:pPr lvl="0" indent="-342900" marL="342900">
+                  <a:buAutoNum type="arabicPeriod"/>
+                </a:pPr>
+                <a:r>
+                  <a:rPr b="1"/>
+                  <a:t>非正弦 CPR</a:t>
+                </a:r>
+                <a:r>
+                  <a:rPr/>
+                  <a:t>：直接觀測到顯著 </a:t>
+                </a:r>
+                <a:r>
+                  <a:rPr b="1"/>
+                  <a:t>二階諧波 </a:t>
+                </a:r>
+                <a14:m>
+                  <m:oMath xmlns:m="http://schemas.openxmlformats.org/officeDocument/2006/math">
+                    <m:sSub>
+                      <m:e>
+                        <m:r>
+                          <m:t>I</m:t>
+                        </m:r>
+                      </m:e>
+                      <m:sub>
+                        <m:r>
+                          <m:t>2</m:t>
+                        </m:r>
+                      </m:sub>
+                    </m:sSub>
+                  </m:oMath>
+                </a14:m>
+                <a:r>
+                  <a:rPr/>
+                  <a:t>，並以諧波模型量化相位差 </a:t>
+                </a:r>
+                <a14:m>
+                  <m:oMath xmlns:m="http://schemas.openxmlformats.org/officeDocument/2006/math">
+                    <m:r>
+                      <m:t>δ</m:t>
+                    </m:r>
+                  </m:oMath>
+                </a14:m>
+                <a:r>
+                  <a:rPr/>
+                  <a:t>。</a:t>
+                </a:r>
+              </a:p>
+              <a:p>
+                <a:pPr lvl="0" indent="-342900" marL="342900">
+                  <a:buAutoNum type="arabicPeriod"/>
+                </a:pPr>
+                <a:r>
+                  <a:rPr b="1"/>
+                  <a:t>磁場調控</a:t>
+                </a:r>
+                <a:r>
+                  <a:rPr/>
+                  <a:t>：證實面內磁場可連續調整 CPR（</a:t>
+                </a:r>
+                <a14:m>
+                  <m:oMath xmlns:m="http://schemas.openxmlformats.org/officeDocument/2006/math">
+                    <m:sSub>
+                      <m:e>
+                        <m:r>
+                          <m:t>φ</m:t>
+                        </m:r>
+                      </m:e>
+                      <m:sub>
+                        <m:r>
+                          <m:t>0</m:t>
+                        </m:r>
+                      </m:sub>
+                    </m:sSub>
+                  </m:oMath>
+                </a14:m>
+                <a:r>
+                  <a:rPr/>
+                  <a:t> 偏移），為可程式化超導元件提供相位旋鈕。</a:t>
+                </a:r>
+              </a:p>
+            </p:txBody>
+          </p:sp>
+        </mc:Choice>
+      </mc:AlternateContent>
+    </p:spTree>
+  </p:cSld>
+</p:sld>
+</file>
+
+<file path=ppt/slides/slide28.xml><?xml version="1.0" encoding="utf-8"?>
+<p:sld xmlns:a="http://schemas.openxmlformats.org/drawingml/2006/main" xmlns:r="http://schemas.openxmlformats.org/officeDocument/2006/relationships" xmlns:p="http://schemas.openxmlformats.org/presentationml/2006/main">
+  <p:cSld>
+    <p:spTree>
+      <p:nvGrpSpPr>
+        <p:cNvPr id="1" name=""/>
+        <p:cNvGrpSpPr/>
+        <p:nvPr/>
+      </p:nvGrpSpPr>
+      <p:grpSpPr>
+        <a:xfrm>
+          <a:off x="0" y="0"/>
+          <a:ext cx="0" cy="0"/>
+          <a:chOff x="0" y="0"/>
+          <a:chExt cx="0" cy="0"/>
+        </a:xfrm>
+      </p:grpSpPr>
+      <p:sp>
+        <p:nvSpPr>
+          <p:cNvPr id="2" name="Title 1"/>
+          <p:cNvSpPr>
+            <a:spLocks noGrp="1"/>
+          </p:cNvSpPr>
+          <p:nvPr>
+            <p:ph type="title"/>
+          </p:nvPr>
+        </p:nvSpPr>
+        <p:spPr/>
+        <p:txBody>
+          <a:bodyPr/>
+          <a:lstStyle/>
+          <a:p>
+            <a:pPr lvl="0" indent="0" marL="0">
+              <a:buNone/>
+            </a:pPr>
+            <a:r>
+              <a:rPr/>
+              <a:t>下一步：深化機制並向應用推進</a:t>
+            </a:r>
+          </a:p>
+        </p:txBody>
+      </p:sp>
+      <p:sp>
+        <p:nvSpPr>
+          <p:cNvPr id="3" name="Content Placeholder 2"/>
+          <p:cNvSpPr>
+            <a:spLocks noGrp="1"/>
+          </p:cNvSpPr>
+          <p:nvPr>
+            <p:ph idx="1"/>
+          </p:nvPr>
+        </p:nvSpPr>
+        <p:spPr/>
+        <p:txBody>
+          <a:bodyPr/>
+          <a:lstStyle/>
+          <a:p>
+            <a:pPr lvl="0"/>
+            <a:r>
+              <a:rPr b="1"/>
+              <a:t>機制釐清</a:t>
+            </a:r>
+            <a:r>
+              <a:rPr/>
+              <a:t>：溫度依賴量測以區分體相與表面態；Shapiro steps 驗證 AC 約瑟夫森效應。</a:t>
+            </a:r>
+          </a:p>
+          <a:p>
+            <a:pPr lvl="0"/>
+            <a:r>
+              <a:rPr b="1"/>
+              <a:t>應用路線</a:t>
+            </a:r>
+            <a:r>
+              <a:rPr/>
+              <a:t>：邁向 </a:t>
+            </a:r>
+            <a:r>
+              <a:rPr b="1"/>
+              <a:t>超導二極體</a:t>
+            </a:r>
+            <a:r>
+              <a:rPr/>
+              <a:t> 與 </a:t>
+            </a:r>
+            <a:r>
+              <a:rPr b="1"/>
+              <a:t>拓樸量子位元</a:t>
+            </a:r>
+            <a:r>
+              <a:rPr/>
+              <a:t>，探索零磁場下的非互易與相位操控。</a:t>
+            </a:r>
+          </a:p>
+          <a:p>
+            <a:pPr lvl="0"/>
+            <a:r>
+              <a:rPr b="1"/>
+              <a:t>資料強化</a:t>
+            </a:r>
+            <a:r>
+              <a:rPr/>
+              <a:t>：擴充角度與場強掃描，與白皮書強調的「備用投影片」策略搭配，應對委員質疑。</a:t>
+            </a:r>
+          </a:p>
+        </p:txBody>
+      </p:sp>
+    </p:spTree>
+  </p:cSld>
+</p:sld>
+</file>
+
+<file path=ppt/slides/slide29.xml><?xml version="1.0" encoding="utf-8"?>
+<p:sld xmlns:a="http://schemas.openxmlformats.org/drawingml/2006/main" xmlns:r="http://schemas.openxmlformats.org/officeDocument/2006/relationships" xmlns:p="http://schemas.openxmlformats.org/presentationml/2006/main">
+  <p:cSld>
+    <p:spTree>
+      <p:nvGrpSpPr>
+        <p:cNvPr id="1" name=""/>
+        <p:cNvGrpSpPr/>
+        <p:nvPr/>
+      </p:nvGrpSpPr>
+      <p:grpSpPr>
+        <a:xfrm>
+          <a:off x="0" y="0"/>
+          <a:ext cx="0" cy="0"/>
+          <a:chOff x="0" y="0"/>
+          <a:chExt cx="0" cy="0"/>
+        </a:xfrm>
+      </p:grpSpPr>
+      <p:sp>
+        <p:nvSpPr>
+          <p:cNvPr id="2" name="Title 1"/>
+          <p:cNvSpPr>
+            <a:spLocks noGrp="1"/>
+          </p:cNvSpPr>
+          <p:nvPr>
+            <p:ph type="title"/>
+          </p:nvPr>
+        </p:nvSpPr>
+        <p:spPr/>
+        <p:txBody>
+          <a:bodyPr/>
+          <a:lstStyle/>
+          <a:p>
+            <a:pPr lvl="0" indent="0" marL="0">
+              <a:buNone/>
+            </a:pPr>
+            <a:r>
+              <a:rPr/>
+              <a:t>臨場策略：對齊白皮書的收尾與 Q&amp;A 節奏</a:t>
+            </a:r>
+          </a:p>
+        </p:txBody>
+      </p:sp>
+      <p:sp>
+        <p:nvSpPr>
+          <p:cNvPr id="3" name="Content Placeholder 2"/>
+          <p:cNvSpPr>
+            <a:spLocks noGrp="1"/>
+          </p:cNvSpPr>
+          <p:nvPr>
+            <p:ph idx="1"/>
+          </p:nvPr>
+        </p:nvSpPr>
+        <p:spPr/>
+        <p:txBody>
+          <a:bodyPr/>
+          <a:lstStyle/>
+          <a:p>
+            <a:pPr lvl="0"/>
+            <a:r>
+              <a:rPr/>
+              <a:t>結尾重申核心貢獻與可調性，並預告備用投影片涵蓋樣品統計、完整 CPR 擬合與檢定結果。</a:t>
+            </a:r>
+          </a:p>
+          <a:p>
+            <a:pPr lvl="0"/>
+            <a:r>
+              <a:rPr/>
+              <a:t>Q&amp;A 將依「承認限制→合理辯護」話術回應方法論挑戰，確保展演與文件一致。</a:t>
+            </a:r>
+          </a:p>
+        </p:txBody>
+      </p:sp>
+    </p:spTree>
+  </p:cSld>
+</p:sld>
+</file>
+
+<file path=ppt/slides/slide3.xml><?xml version="1.0" encoding="utf-8"?>
+<p:sld xmlns:a="http://schemas.openxmlformats.org/drawingml/2006/main" xmlns:r="http://schemas.openxmlformats.org/officeDocument/2006/relationships" xmlns:p="http://schemas.openxmlformats.org/presentationml/2006/main">
+  <p:cSld>
+    <p:spTree>
+      <p:nvGrpSpPr>
+        <p:cNvPr id="1" name=""/>
+        <p:cNvGrpSpPr/>
+        <p:nvPr/>
+      </p:nvGrpSpPr>
+      <p:grpSpPr>
+        <a:xfrm>
+          <a:off x="0" y="0"/>
+          <a:ext cx="0" cy="0"/>
+          <a:chOff x="0" y="0"/>
+          <a:chExt cx="0" cy="0"/>
+        </a:xfrm>
+      </p:grpSpPr>
+      <p:sp>
+        <p:nvSpPr>
+          <p:cNvPr id="2" name="Title 1"/>
+          <p:cNvSpPr>
+            <a:spLocks noGrp="1"/>
+          </p:cNvSpPr>
+          <p:nvPr>
+            <p:ph type="title"/>
+          </p:nvPr>
+        </p:nvSpPr>
+        <p:spPr/>
+        <p:txBody>
+          <a:bodyPr/>
+          <a:lstStyle/>
+          <a:p>
+            <a:pPr lvl="0" indent="0" marL="0">
+              <a:buNone/>
+            </a:pPr>
+            <a:r>
+              <a:rPr/>
+              <a:t>一分鐘摘要 (Executive Summary)</a:t>
+            </a:r>
+          </a:p>
+        </p:txBody>
+      </p:sp>
       <mc:AlternateContent xmlns:mc="http://schemas.openxmlformats.org/markup-compatibility/2006">
         <mc:Choice xmlns:a14="http://schemas.microsoft.com/office/drawing/2010/main" Requires="a14">
           <p:sp>
@@ -6486,21 +6879,85 @@
                 <a:pPr lvl="0"/>
                 <a:r>
                   <a:rPr b="1"/>
-                  <a:t>新興量子材料與宏觀量子元件的結合</a:t>
+                  <a:t>問題</a:t>
+                </a:r>
+                <a:r>
+                  <a:rPr/>
+                  <a:t>：拓樸半金屬接面的 CPR 難以被「連續調控」，現有研究缺乏直接量測。</a:t>
                 </a:r>
               </a:p>
               <a:p>
-                <a:pPr lvl="1"/>
+                <a:pPr lvl="0"/>
                 <a:r>
                   <a:rPr b="1"/>
-                  <a:t>PtTe</a:t>
+                  <a:t>方法</a:t>
+                </a:r>
+                <a:r>
+                  <a:rPr/>
+                  <a:t>：以 </a:t>
+                </a:r>
+                <a:r>
+                  <a:rPr b="1"/>
+                  <a:t>非對稱 SQUID</a:t>
+                </a:r>
+                <a:r>
+                  <a:rPr/>
+                  <a:t> 作為相位偏壓探頭，量測 </a:t>
                 </a:r>
                 <a14:m>
                   <m:oMath xmlns:m="http://schemas.openxmlformats.org/officeDocument/2006/math">
                     <m:sSub>
                       <m:e>
                         <m:r>
-                          <m:t>​</m:t>
+                          <m:t>I</m:t>
+                        </m:r>
+                      </m:e>
+                      <m:sub>
+                        <m:r>
+                          <m:t>c</m:t>
+                        </m:r>
+                      </m:sub>
+                    </m:sSub>
+                    <m:d>
+                      <m:dPr>
+                        <m:begChr m:val="("/>
+                        <m:sepChr m:val=""/>
+                        <m:endChr m:val=")"/>
+                        <m:grow/>
+                      </m:dPr>
+                      <m:e>
+                        <m:r>
+                          <m:t>Φ</m:t>
+                        </m:r>
+                      </m:e>
+                    </m:d>
+                  </m:oMath>
+                </a14:m>
+                <a:r>
+                  <a:rPr/>
+                  <a:t> 並反推 CPR，掃描面內磁場向量。</a:t>
+                </a:r>
+              </a:p>
+              <a:p>
+                <a:pPr lvl="0"/>
+                <a:r>
+                  <a:rPr b="1"/>
+                  <a:t>核心發現</a:t>
+                </a:r>
+                <a:r>
+                  <a:rPr/>
+                  <a:t>：面內磁場會放大 </a:t>
+                </a:r>
+                <a:r>
+                  <a:rPr b="1"/>
+                  <a:t>二階諧波 (</a:t>
+                </a:r>
+                <a14:m>
+                  <m:oMath xmlns:m="http://schemas.openxmlformats.org/officeDocument/2006/math">
+                    <m:sSub>
+                      <m:e>
+                        <m:r>
+                          <m:t>I</m:t>
                         </m:r>
                       </m:e>
                       <m:sub>
@@ -6513,112 +6970,34 @@
                 </a14:m>
                 <a:r>
                   <a:rPr b="1"/>
-                  <a:t> (Type-II Dirac Semimetal)</a:t>
-                </a:r>
-                <a:r>
-                  <a:rPr/>
-                  <a:t>：具有極度傾斜的狄拉克錐與拓樸表面態。</a:t>
-                </a:r>
-              </a:p>
-              <a:p>
-                <a:pPr lvl="1"/>
-                <a:r>
-                  <a:rPr b="1"/>
-                  <a:t>SQUID (Superconducting Quantum Interference Device)</a:t>
-                </a:r>
-                <a:r>
-                  <a:rPr/>
-                  <a:t>：極高靈敏度的磁通量測平台。</a:t>
-                </a:r>
-              </a:p>
-              <a:p>
-                <a:pPr lvl="0"/>
-                <a:r>
-                  <a:rPr b="1"/>
-                  <a:t>關鍵缺口 (Research Gap)</a:t>
-                </a:r>
-              </a:p>
-              <a:p>
-                <a:pPr lvl="1"/>
-                <a:r>
-                  <a:rPr/>
-                  <a:t>既有研究多聚焦於 </a:t>
-                </a:r>
-                <a:r>
-                  <a:rPr b="1"/>
-                  <a:t>約瑟夫森二極體效應 (JDE)</a:t>
-                </a:r>
-                <a:r>
-                  <a:rPr/>
-                  <a:t>。</a:t>
-                </a:r>
-              </a:p>
-              <a:p>
-                <a:pPr lvl="1"/>
-                <a:r>
-                  <a:rPr b="1"/>
-                  <a:t>缺乏</a:t>
-                </a:r>
-                <a:r>
-                  <a:rPr/>
-                  <a:t> 對 </a:t>
-                </a:r>
-                <a:r>
-                  <a:rPr b="1"/>
-                  <a:t>電流-相位關係 (CPR)</a:t>
-                </a:r>
-                <a:r>
-                  <a:rPr/>
-                  <a:t> 及其 </a:t>
-                </a:r>
-                <a:r>
-                  <a:rPr b="1"/>
-                  <a:t>磁場調控</a:t>
-                </a:r>
-                <a:r>
-                  <a:rPr/>
-                  <a:t> 的直接、定量量測。</a:t>
-                </a:r>
-              </a:p>
-              <a:p>
-                <a:pPr lvl="0"/>
-                <a:r>
-                  <a:rPr b="1"/>
-                  <a:t>核心策略</a:t>
-                </a:r>
-              </a:p>
-              <a:p>
-                <a:pPr lvl="1"/>
-                <a:r>
-                  <a:rPr/>
-                  <a:t>利用 </a:t>
-                </a:r>
-                <a:r>
-                  <a:rPr b="1"/>
-                  <a:t>非對稱 SQUID (aSQUID)</a:t>
-                </a:r>
-                <a:r>
-                  <a:rPr/>
-                  <a:t> 作為相位探針。</a:t>
-                </a:r>
-              </a:p>
-              <a:p>
-                <a:pPr lvl="1"/>
-                <a:r>
-                  <a:rPr/>
-                  <a:t>解析 PtTe</a:t>
+                  <a:t>)</a:t>
+                </a:r>
+                <a:r>
+                  <a:rPr/>
+                  <a:t> 並產生相位偏移 </a:t>
+                </a:r>
+                <a14:m>
+                  <m:oMath xmlns:m="http://schemas.openxmlformats.org/officeDocument/2006/math">
+                    <m:r>
+                      <m:t>δ</m:t>
+                    </m:r>
+                  </m:oMath>
+                </a14:m>
+                <a:r>
+                  <a:rPr/>
+                  <a:t>，形成可調式 </a:t>
                 </a:r>
                 <a14:m>
                   <m:oMath xmlns:m="http://schemas.openxmlformats.org/officeDocument/2006/math">
                     <m:sSub>
                       <m:e>
                         <m:r>
-                          <m:t>​</m:t>
+                          <m:t>φ</m:t>
                         </m:r>
                       </m:e>
                       <m:sub>
                         <m:r>
-                          <m:t>2</m:t>
+                          <m:t>0</m:t>
                         </m:r>
                       </m:sub>
                     </m:sSub>
@@ -6626,29 +7005,225 @@
                 </a14:m>
                 <a:r>
                   <a:rPr/>
-                  <a:t> 在超導近接效應下的 </a:t>
-                </a:r>
+                  <a:t> 接面。</a:t>
+                </a:r>
+              </a:p>
+              <a:p>
+                <a:pPr lvl="0"/>
                 <a:r>
                   <a:rPr b="1"/>
-                  <a:t>高階諧波</a:t>
-                </a:r>
-                <a:r>
-                  <a:rPr/>
-                  <a:t> 與 </a:t>
-                </a:r>
-                <a:r>
-                  <a:rPr b="1"/>
-                  <a:t>輸運機制</a:t>
-                </a:r>
-                <a:r>
-                  <a:rPr/>
-                  <a:t>。</a:t>
+                  <a:t>意涵</a:t>
+                </a:r>
+                <a:r>
+                  <a:rPr/>
+                  <a:t>：證實 PtTe</a:t>
+                </a:r>
+                <a14:m>
+                  <m:oMath xmlns:m="http://schemas.openxmlformats.org/officeDocument/2006/math">
+                    <m:sSub>
+                      <m:e>
+                        <m:r>
+                          <m:t>​</m:t>
+                        </m:r>
+                      </m:e>
+                      <m:sub>
+                        <m:r>
+                          <m:t>2</m:t>
+                        </m:r>
+                      </m:sub>
+                    </m:sSub>
+                  </m:oMath>
+                </a14:m>
+                <a:r>
+                  <a:rPr/>
+                  <a:t> 可作為可程式化相位旋鈕，對超導二極體與拓樸量子元件具指標性。</a:t>
                 </a:r>
               </a:p>
             </p:txBody>
           </p:sp>
         </mc:Choice>
       </mc:AlternateContent>
+    </p:spTree>
+  </p:cSld>
+</p:sld>
+</file>
+
+<file path=ppt/slides/slide30.xml><?xml version="1.0" encoding="utf-8"?>
+<p:sld xmlns:a="http://schemas.openxmlformats.org/drawingml/2006/main" xmlns:r="http://schemas.openxmlformats.org/officeDocument/2006/relationships" xmlns:p="http://schemas.openxmlformats.org/presentationml/2006/main">
+  <p:cSld>
+    <p:spTree>
+      <p:nvGrpSpPr>
+        <p:cNvPr id="1" name=""/>
+        <p:cNvGrpSpPr/>
+        <p:nvPr/>
+      </p:nvGrpSpPr>
+      <p:grpSpPr>
+        <a:xfrm>
+          <a:off x="0" y="0"/>
+          <a:ext cx="0" cy="0"/>
+          <a:chOff x="0" y="0"/>
+          <a:chExt cx="0" cy="0"/>
+        </a:xfrm>
+      </p:grpSpPr>
+      <p:sp>
+        <p:nvSpPr>
+          <p:cNvPr id="2" name="Title 1"/>
+          <p:cNvSpPr>
+            <a:spLocks noGrp="1"/>
+          </p:cNvSpPr>
+          <p:nvPr>
+            <p:ph type="title"/>
+          </p:nvPr>
+        </p:nvSpPr>
+        <p:spPr>
+          <a:xfrm>
+            <a:off x="722313" y="3305176"/>
+            <a:ext cx="7772400" cy="1021556"/>
+          </a:xfrm>
+        </p:spPr>
+        <p:txBody>
+          <a:bodyPr/>
+          <a:lstStyle/>
+          <a:p>
+            <a:pPr lvl="0" indent="0" marL="0">
+              <a:buNone/>
+            </a:pPr>
+            <a:r>
+              <a:rPr/>
+              <a:t>備用投影片：Q&amp;A 即時切換 (Backup Slides)</a:t>
+            </a:r>
+          </a:p>
+        </p:txBody>
+      </p:sp>
+    </p:spTree>
+  </p:cSld>
+</p:sld>
+</file>
+
+<file path=ppt/slides/slide31.xml><?xml version="1.0" encoding="utf-8"?>
+<p:sld xmlns:a="http://schemas.openxmlformats.org/drawingml/2006/main" xmlns:r="http://schemas.openxmlformats.org/officeDocument/2006/relationships" xmlns:p="http://schemas.openxmlformats.org/presentationml/2006/main">
+  <p:cSld>
+    <p:spTree>
+      <p:nvGrpSpPr>
+        <p:cNvPr id="1" name=""/>
+        <p:cNvGrpSpPr/>
+        <p:nvPr/>
+      </p:nvGrpSpPr>
+      <p:grpSpPr>
+        <a:xfrm>
+          <a:off x="0" y="0"/>
+          <a:ext cx="0" cy="0"/>
+          <a:chOff x="0" y="0"/>
+          <a:chExt cx="0" cy="0"/>
+        </a:xfrm>
+      </p:grpSpPr>
+      <p:sp>
+        <p:nvSpPr>
+          <p:cNvPr id="2" name="Title 1"/>
+          <p:cNvSpPr>
+            <a:spLocks noGrp="1"/>
+          </p:cNvSpPr>
+          <p:nvPr>
+            <p:ph type="title"/>
+          </p:nvPr>
+        </p:nvSpPr>
+        <p:spPr>
+          <a:xfrm>
+            <a:off x="722313" y="3305176"/>
+            <a:ext cx="7772400" cy="1021556"/>
+          </a:xfrm>
+        </p:spPr>
+        <p:txBody>
+          <a:bodyPr/>
+          <a:lstStyle/>
+          <a:p>
+            <a:pPr lvl="0" indent="0" marL="0">
+              <a:buNone/>
+            </a:pPr>
+            <a:r>
+              <a:rPr/>
+              <a:t>備用投影片：委員質疑時的數據佐證</a:t>
+            </a:r>
+          </a:p>
+        </p:txBody>
+      </p:sp>
+    </p:spTree>
+  </p:cSld>
+</p:sld>
+</file>
+
+<file path=ppt/slides/slide32.xml><?xml version="1.0" encoding="UTF-8"?><p:sld xmlns:a="http://schemas.openxmlformats.org/drawingml/2006/main" xmlns:r="http://schemas.openxmlformats.org/officeDocument/2006/relationships" xmlns:p="http://schemas.openxmlformats.org/presentationml/2006/main"><p:cSld><p:spTree><p:nvGrpSpPr><p:cNvPr id="1" name="" /><p:cNvGrpSpPr /><p:nvPr /></p:nvGrpSpPr><p:grpSpPr><a:xfrm><a:off x="0" y="0" /><a:ext cx="0" cy="0" /><a:chOff x="0" y="0" /><a:chExt cx="0" cy="0" /></a:xfrm></p:grpSpPr><p:sp><p:nvSpPr><p:cNvPr id="2" name="Title 1" /><p:cNvSpPr><a:spLocks noGrp="1" /></p:cNvSpPr><p:nvPr><p:ph type="title" /></p:nvPr></p:nvSpPr><p:spPr><a:xfrm><a:off x="457201" y="204787" /><a:ext cx="3008313" cy="871538" /></a:xfrm></p:spPr><p:txBody><a:bodyPr /><a:lstStyle /><a:p><a:pPr lvl="0" indent="0" marL="0"><a:buNone /></a:pPr><a:r><a:rPr /><a:t>備查：樣品統計與補充分析</a:t></a:r></a:p></p:txBody></p:sp><p:sp><p:nvSpPr><p:cNvPr id="4" name="Text Placeholder 3" /><p:cNvSpPr><a:spLocks noGrp="1" /></p:cNvSpPr><p:nvPr><p:ph idx="2" sz="half" type="body" /></p:nvPr></p:nvSpPr><p:spPr /><p:txBody><a:bodyPr /><a:lstStyle /><a:p><a:pPr lvl="0" indent="0" marL="0"><a:buNone /></a:pPr><a:r><a:rPr /><a:t>依白皮書建議，本區保留可即時切換的佐證表與補充參數。</a:t></a:r></a:p><a:p><a:pPr lvl="0" indent="0" marL="0"><a:spcBef><a:spcPts val="3000" /></a:spcBef><a:buNone /></a:pPr><a:r><a:rPr b="1" /><a:t>樣品詳細資訊</a:t></a:r></a:p><a:p><a:pPr lvl="0" indent="0" marL="0"><a:buNone /></a:pPr><a:r><a:rPr /><a:t>樣品詳細資訊</a:t></a:r></a:p><a:p><a:pPr lvl="0" indent="0" marL="0"><a:buNone /></a:pPr><a:r><a:rPr /><a:t>樣品編號</a:t></a:r></a:p><a:p><a:pPr lvl="0" indent="0" marL="0"><a:buNone /></a:pPr><a:r><a:rPr /><a:t>厚度(nm)</a:t></a:r></a:p><a:p><a:pPr lvl="0" indent="0" marL="0"><a:buNone /></a:pPr><a:r><a:rPr /><a:t>接面寬度(μm)</a:t></a:r></a:p><a:p><a:pPr lvl="0" indent="0" marL="0"><a:buNone /></a:pPr><a:r><a:rPr /><a:t>參考接面長度(μm)</a:t></a:r></a:p><a:p><a:pPr lvl="0" indent="0" marL="0"><a:buNone /></a:pPr><a:r><a:rPr /><a:t>目標接面長度(μm)</a:t></a:r></a:p><a:p><a:pPr lvl="0" indent="0" marL="0"><a:buNone /></a:pPr><a:r><a:rPr /><a:t>臨界電流(μA)</a:t></a:r></a:p><a:p><a:pPr lvl="0" indent="0" marL="0"><a:buNone /></a:pPr><a:r><a:rPr /><a:t>重捕電流(μA)</a:t></a:r></a:p><a:p><a:pPr lvl="0" indent="0" marL="0"><a:buNone /></a:pPr><a:r><a:rPr /><a:t>正常態電阻(Ω)</a:t></a:r></a:p><a:p><a:pPr lvl="0" indent="0" marL="0"><a:buNone /></a:pPr><a:r><a:rPr /><a:t>IcRn (μV)</a:t></a:r></a:p><a:p><a:pPr lvl="0" indent="0" marL="0"><a:buNone /></a:pPr><a:r><a:rPr /><a:t>二極體效率(η)</a:t></a:r></a:p><a:p><a:pPr lvl="0" indent="0" marL="0"><a:buNone /></a:pPr><a:r><a:rPr /><a:t>鈮鈦厚度(nm)</a:t></a:r></a:p><a:p><a:pPr lvl="0" indent="0" marL="0"><a:buNone /></a:pPr><a:r><a:rPr /><a:t>備註</a:t></a:r></a:p><a:p><a:pPr lvl="0" indent="0" marL="0"><a:buNone /></a:pPr><a:r><a:rPr /><a:t>003-2</a:t></a:r></a:p><a:p><a:pPr lvl="0" indent="0" marL="0"><a:buNone /></a:pPr><a:r><a:rPr /><a:t>21.17</a:t></a:r></a:p><a:p><a:pPr lvl="0" indent="0" marL="0"><a:buNone /></a:pPr><a:r><a:rPr /><a:t>1.16</a:t></a:r></a:p><a:p><a:pPr lvl="0" indent="0" marL="0"><a:buNone /></a:pPr><a:r><a:rPr /><a:t>0.40</a:t></a:r></a:p><a:p><a:pPr lvl="0" indent="0" marL="0"><a:buNone /></a:pPr><a:r><a:rPr /><a:t>0.73</a:t></a:r></a:p><a:p><a:pPr lvl="0" indent="0" marL="0"><a:buNone /></a:pPr><a:r><a:rPr /><a:t>19.1</a:t></a:r></a:p><a:p><a:pPr lvl="0" indent="0" marL="0"><a:buNone /></a:pPr><a:r><a:rPr /><a:t>3</a:t></a:r></a:p><a:p><a:pPr lvl="0" indent="0" marL="0"><a:buNone /></a:pPr><a:r><a:rPr /><a:t>1.92</a:t></a:r></a:p><a:p><a:pPr lvl="0" indent="0" marL="0"><a:buNone /></a:pPr><a:r><a:rPr /><a:t>36.6</a:t></a:r></a:p><a:p><a:pPr lvl="0" indent="0" marL="0"><a:buNone /></a:pPr><a:r><a:rPr /><a:t>150</a:t></a:r></a:p><a:p><a:pPr lvl="0" indent="0" marL="0"><a:buNone /></a:pPr><a:r><a:rPr /><a:t>003-3</a:t></a:r></a:p><a:p><a:pPr lvl="0" indent="0" marL="0"><a:buNone /></a:pPr><a:r><a:rPr /><a:t>27.79</a:t></a:r></a:p><a:p><a:pPr lvl="0" indent="0" marL="0"><a:buNone /></a:pPr><a:r><a:rPr /><a:t>0.88</a:t></a:r></a:p><a:p><a:pPr lvl="0" indent="0" marL="0"><a:buNone /></a:pPr><a:r><a:rPr /><a:t>0.33</a:t></a:r></a:p><a:p><a:pPr lvl="0" indent="0" marL="0"><a:buNone /></a:pPr><a:r><a:rPr /><a:t>0.65</a:t></a:r></a:p><a:p><a:pPr lvl="0" indent="0" marL="0"><a:buNone /></a:pPr><a:r><a:rPr /><a:t>14.5</a:t></a:r></a:p><a:p><a:pPr lvl="0" indent="0" marL="0"><a:buNone /></a:pPr><a:r><a:rPr /><a:t>1.5</a:t></a:r></a:p><a:p><a:pPr lvl="0" indent="0" marL="0"><a:buNone /></a:pPr><a:r><a:rPr /><a:t>3.24</a:t></a:r></a:p><a:p><a:pPr lvl="0" indent="0" marL="0"><a:buNone /></a:pPr><a:r><a:rPr /><a:t>46.9</a:t></a:r></a:p><a:p><a:pPr lvl="0" indent="0" marL="0"><a:buNone /></a:pPr><a:r><a:rPr /><a:t>150</a:t></a:r></a:p><a:p><a:pPr lvl="0" indent="0" marL="0"><a:buNone /></a:pPr><a:r><a:rPr /><a:t>004-1</a:t></a:r></a:p><a:p><a:pPr lvl="0" indent="0" marL="0"><a:buNone /></a:pPr><a:r><a:rPr /><a:t>1.26</a:t></a:r></a:p><a:p><a:pPr lvl="0" indent="0" marL="0"><a:buNone /></a:pPr><a:r><a:rPr /><a:t>0.26</a:t></a:r></a:p><a:p><a:pPr lvl="0" indent="0" marL="0"><a:buNone /></a:pPr><a:r><a:rPr /><a:t>0.68</a:t></a:r></a:p><a:p><a:pPr lvl="0" indent="0" marL="0"><a:buNone /></a:pPr><a:r><a:rPr /><a:t>19.4</a:t></a:r></a:p><a:p><a:pPr lvl="0" indent="0" marL="0"><a:buNone /></a:pPr><a:r><a:rPr /><a:t>16</a:t></a:r></a:p><a:p><a:pPr lvl="0" indent="0" marL="0"><a:buNone /></a:pPr><a:r><a:rPr /><a:t>11.17</a:t></a:r></a:p><a:p><a:pPr lvl="0" indent="0" marL="0"><a:buNone /></a:pPr><a:r><a:rPr /><a:t>217.1</a:t></a:r></a:p><a:p><a:pPr lvl="0" indent="0" marL="0"><a:buNone /></a:pPr><a:r><a:rPr /><a:t>70</a:t></a:r></a:p><a:p><a:pPr lvl="0" indent="0" marL="0"><a:buNone /></a:pPr><a:r><a:rPr /><a:t>Only Ref. JJ</a:t></a:r></a:p><a:p><a:pPr lvl="0" indent="0" marL="0"><a:buNone /></a:pPr><a:r><a:rPr /><a:t>004-2</a:t></a:r></a:p><a:p><a:pPr lvl="0" indent="0" marL="0"><a:buNone /></a:pPr><a:r><a:rPr /><a:t>0.56</a:t></a:r></a:p><a:p><a:pPr lvl="0" indent="0" marL="0"><a:buNone /></a:pPr><a:r><a:rPr /><a:t>0.17</a:t></a:r></a:p><a:p><a:pPr lvl="0" indent="0" marL="0"><a:buNone /></a:pPr><a:r><a:rPr /><a:t>0.67</a:t></a:r></a:p><a:p><a:pPr lvl="0" indent="0" marL="0"><a:buNone /></a:pPr><a:r><a:rPr /><a:t>32.5</a:t></a:r></a:p><a:p><a:pPr lvl="0" indent="0" marL="0"><a:buNone /></a:pPr><a:r><a:rPr /><a:t>30</a:t></a:r></a:p><a:p><a:pPr lvl="0" indent="0" marL="0"><a:buNone /></a:pPr><a:r><a:rPr /><a:t>22.29</a:t></a:r></a:p><a:p><a:pPr lvl="0" indent="0" marL="0"><a:buNone /></a:pPr><a:r><a:rPr /><a:t>725.1</a:t></a:r></a:p><a:p><a:pPr lvl="0" indent="0" marL="0"><a:buNone /></a:pPr><a:r><a:rPr /><a:t>70</a:t></a:r></a:p><a:p><a:pPr lvl="0" indent="0" marL="0"><a:buNone /></a:pPr><a:r><a:rPr /><a:t>004-3</a:t></a:r></a:p><a:p><a:pPr lvl="0" indent="0" marL="0"><a:buNone /></a:pPr><a:r><a:rPr /><a:t>1.34</a:t></a:r></a:p><a:p><a:pPr lvl="0" indent="0" marL="0"><a:buNone /></a:pPr><a:r><a:rPr /><a:t>0.24</a:t></a:r></a:p><a:p><a:pPr lvl="0" indent="0" marL="0"><a:buNone /></a:pPr><a:r><a:rPr /><a:t>0.70</a:t></a:r></a:p><a:p><a:pPr lvl="0" indent="0" marL="0"><a:buNone /></a:pPr><a:r><a:rPr /><a:t>44.5</a:t></a:r></a:p><a:p><a:pPr lvl="0" indent="0" marL="0"><a:buNone /></a:pPr><a:r><a:rPr /><a:t>33</a:t></a:r></a:p><a:p><a:pPr lvl="0" indent="0" marL="0"><a:buNone /></a:pPr><a:r><a:rPr /><a:t>35.93</a:t></a:r></a:p><a:p><a:pPr lvl="0" indent="0" marL="0"><a:buNone /></a:pPr><a:r><a:rPr /><a:t>1600.4</a:t></a:r></a:p><a:p><a:pPr lvl="0" indent="0" marL="0"><a:buNone /></a:pPr><a:r><a:rPr /><a:t>70</a:t></a:r></a:p><a:p><a:pPr lvl="0" indent="0" marL="0"><a:buNone /></a:pPr><a:r><a:rPr /><a:t>005-1</a:t></a:r></a:p><a:p><a:pPr lvl="0" indent="0" marL="0"><a:buNone /></a:pPr><a:r><a:rPr /><a:t>63.5</a:t></a:r></a:p><a:p><a:pPr lvl="0" indent="0" marL="0"><a:buNone /></a:pPr><a:r><a:rPr /><a:t>1.15</a:t></a:r></a:p><a:p><a:pPr lvl="0" indent="0" marL="0"><a:buNone /></a:pPr><a:r><a:rPr /><a:t>0.42</a:t></a:r></a:p><a:p><a:pPr lvl="0" indent="0" marL="0"><a:buNone /></a:pPr><a:r><a:rPr /><a:t>0.87</a:t></a:r></a:p><a:p><a:pPr lvl="0" indent="0" marL="0"><a:buNone /></a:pPr><a:r><a:rPr /><a:t>88.4</a:t></a:r></a:p><a:p><a:pPr lvl="0" indent="0" marL="0"><a:buNone /></a:pPr><a:r><a:rPr /><a:t>28</a:t></a:r></a:p><a:p><a:pPr lvl="0" indent="0" marL="0"><a:buNone /></a:pPr><a:r><a:rPr /><a:t>0.30</a:t></a:r></a:p><a:p><a:pPr lvl="0" indent="0" marL="0"><a:buNone /></a:pPr><a:r><a:rPr /><a:t>26.5</a:t></a:r></a:p><a:p><a:pPr lvl="0" indent="0" marL="0"><a:buNone /></a:pPr><a:r><a:rPr /><a:t>70</a:t></a:r></a:p><a:p><a:pPr lvl="0" indent="0" marL="0"><a:buNone /></a:pPr><a:r><a:rPr /><a:t>005-2</a:t></a:r></a:p><a:p><a:pPr lvl="0" indent="0" marL="0"><a:buNone /></a:pPr><a:r><a:rPr /><a:t>24.2</a:t></a:r></a:p><a:p><a:pPr lvl="0" indent="0" marL="0"><a:buNone /></a:pPr><a:r><a:rPr /><a:t>1.57</a:t></a:r></a:p><a:p><a:pPr lvl="0" indent="0" marL="0"><a:buNone /></a:pPr><a:r><a:rPr /><a:t>0.41</a:t></a:r></a:p><a:p><a:pPr lvl="0" indent="0" marL="0"><a:buNone /></a:pPr><a:r><a:rPr /><a:t>0.88</a:t></a:r></a:p><a:p><a:pPr lvl="0" indent="0" marL="0"><a:buNone /></a:pPr><a:r><a:rPr /><a:t>33.9</a:t></a:r></a:p><a:p><a:pPr lvl="0" indent="0" marL="0"><a:buNone /></a:pPr><a:r><a:rPr /><a:t>6</a:t></a:r></a:p><a:p><a:pPr lvl="0" indent="0" marL="0"><a:buNone /></a:pPr><a:r><a:rPr /><a:t>1.07</a:t></a:r></a:p><a:p><a:pPr lvl="0" indent="0" marL="0"><a:buNone /></a:pPr><a:r><a:rPr /><a:t>36.2</a:t></a:r></a:p><a:p><a:pPr lvl="0" indent="0" marL="0"><a:buNone /></a:pPr><a:r><a:rPr /><a:t>70</a:t></a:r></a:p><a:p><a:pPr lvl="0" indent="0" marL="0"><a:buNone /></a:pPr><a:r><a:rPr /><a:t>019-1</a:t></a:r></a:p><a:p><a:pPr lvl="0" indent="0" marL="0"><a:buNone /></a:pPr><a:r><a:rPr /><a:t>2.59</a:t></a:r></a:p><a:p><a:pPr lvl="0" indent="0" marL="0"><a:buNone /></a:pPr><a:r><a:rPr /><a:t>1.53</a:t></a:r></a:p><a:p><a:pPr lvl="0" indent="0" marL="0"><a:buNone /></a:pPr><a:r><a:rPr /><a:t>2.26</a:t></a:r></a:p><a:p><a:pPr lvl="0" indent="0" marL="0"><a:buNone /></a:pPr><a:r><a:rPr /><a:t>13.8</a:t></a:r></a:p><a:p><a:pPr lvl="0" indent="0" marL="0"><a:buNone /></a:pPr><a:r><a:rPr /><a:t>1.5</a:t></a:r></a:p><a:p><a:pPr lvl="0" indent="0" marL="0"><a:buNone /></a:pPr><a:r><a:rPr /><a:t>0.70</a:t></a:r></a:p><a:p><a:pPr lvl="0" indent="0" marL="0"><a:buNone /></a:pPr><a:r><a:rPr /><a:t>9.7</a:t></a:r></a:p><a:p><a:pPr lvl="0" indent="0" marL="0"><a:buNone /></a:pPr><a:r><a:rPr /><a:t>120</a:t></a:r></a:p><a:p><a:pPr lvl="0" indent="0" marL="0"><a:buNone /></a:pPr><a:r><a:rPr /><a:t>019-3</a:t></a:r></a:p><a:p><a:pPr lvl="0" indent="0" marL="0"><a:buNone /></a:pPr><a:r><a:rPr /><a:t>1.73</a:t></a:r></a:p><a:p><a:pPr lvl="0" indent="0" marL="0"><a:buNone /></a:pPr><a:r><a:rPr /><a:t>1.52</a:t></a:r></a:p><a:p><a:pPr lvl="0" indent="0" marL="0"><a:buNone /></a:pPr><a:r><a:rPr /><a:t>2.36</a:t></a:r></a:p><a:p><a:pPr lvl="0" indent="0" marL="0"><a:buNone /></a:pPr><a:r><a:rPr /><a:t>13.3</a:t></a:r></a:p><a:p><a:pPr lvl="0" indent="0" marL="0"><a:buNone /></a:pPr><a:r><a:rPr /><a:t>0.8</a:t></a:r></a:p><a:p><a:pPr lvl="0" indent="0" marL="0"><a:buNone /></a:pPr><a:r><a:rPr /><a:t>1.25</a:t></a:r></a:p><a:p><a:pPr lvl="0" indent="0" marL="0"><a:buNone /></a:pPr><a:r><a:rPr /><a:t>16.7</a:t></a:r></a:p><a:p><a:pPr lvl="0" indent="0" marL="0"><a:buNone /></a:pPr><a:r><a:rPr /><a:t>120</a:t></a:r></a:p><a:p><a:pPr lvl="0" indent="0" marL="0"><a:buNone /></a:pPr><a:r><a:rPr /><a:t>019-5</a:t></a:r></a:p><a:p><a:pPr lvl="0" indent="0" marL="0"><a:buNone /></a:pPr><a:r><a:rPr /><a:t>3.42</a:t></a:r></a:p><a:p><a:pPr lvl="0" indent="0" marL="0"><a:buNone /></a:pPr><a:r><a:rPr /><a:t>1.79</a:t></a:r></a:p><a:p><a:pPr lvl="0" indent="0" marL="0"><a:buNone /></a:pPr><a:r><a:rPr /><a:t>6.09</a:t></a:r></a:p><a:p><a:pPr lvl="0" indent="0" marL="0"><a:buNone /></a:pPr><a:r><a:rPr /><a:t>14.8</a:t></a:r></a:p><a:p><a:pPr lvl="0" indent="0" marL="0"><a:buNone /></a:pPr><a:r><a:rPr /><a:t>6</a:t></a:r></a:p><a:p><a:pPr lvl="0" indent="0" marL="0"><a:buNone /></a:pPr><a:r><a:rPr /><a:t>0.26</a:t></a:r></a:p><a:p><a:pPr lvl="0" indent="0" marL="0"><a:buNone /></a:pPr><a:r><a:rPr /><a:t>3.9</a:t></a:r></a:p><a:p><a:pPr lvl="0" indent="0" marL="0"><a:buNone /></a:pPr><a:r><a:rPr /><a:t>120</a:t></a:r></a:p><a:p><a:pPr lvl="0" indent="0" marL="0"><a:spcBef><a:spcPts val="3000" /></a:spcBef><a:buNone /></a:pPr><a:r><a:rPr b="1" /><a:t>PtTe2、NbTi量子輸運參數表</a:t></a:r></a:p></p:txBody></p:sp><p:graphicFrame><p:nvGraphicFramePr><p:cNvPr id="6" name="Content Placeholder 5" /><p:cNvGraphicFramePr><a:graphicFrameLocks noGrp="1" /></p:cNvGraphicFramePr><p:nvPr><p:ph idx="1" /></p:nvPr></p:nvGraphicFramePr><p:xfrm><a:off x="3568700" y="203200" /><a:ext cx="5105400" cy="3873500" /></p:xfrm><a:graphic><a:graphicData uri="http://schemas.openxmlformats.org/drawingml/2006/table"><a:tbl><a:tblPr firstRow="1" bandRow="1"><a:tableStyleId>{5C22544A-7EE6-4342-B048-85BDC9FD1C3A}</a:tableStyleId></a:tblPr><a:tblGrid><a:gridCol w="1231900" /><a:gridCol w="1930400" /><a:gridCol w="698500" /><a:gridCol w="762000" /><a:gridCol w="469900" /></a:tblGrid><a:tr h="0"><a:tc><a:txBody><a:bodyPr /><a:lstStyle /><a:p><a:pPr lvl="0" indent="0" marL="0" algn="ctr"><a:buNone /></a:pPr><a:r><a:rPr b="1" /><a:t>參數</a:t></a:r></a:p></a:txBody><a:tcPr /></a:tc><a:tc><a:txBody><a:bodyPr /><a:lstStyle /><a:p><a:pPr lvl="0" indent="0" marL="0" algn="ctr"><a:buNone /></a:pPr><a:r><a:rPr b="1" /><a:t>符號</a:t></a:r></a:p></a:txBody><a:tcPr /></a:tc><a:tc><a:txBody><a:bodyPr /><a:lstStyle /><a:p><a:pPr lvl="0" indent="0" marL="0" algn="ctr"><a:buNone /></a:pPr><a:r><a:rPr b="1" /><a:t>NbTi</a:t></a:r></a:p></a:txBody><a:tcPr /></a:tc><a:tc><a:txBody><a:bodyPr /><a:lstStyle /><a:p><a:pPr lvl="0" indent="0" marL="0" algn="ctr"><a:buNone /></a:pPr><a:r><a:rPr b="1" /><a:t>PtTe2</a:t></a:r></a:p></a:txBody><a:tcPr /></a:tc><a:tc><a:txBody><a:bodyPr /><a:lstStyle /><a:p><a:pPr lvl="0" indent="0" marL="0" algn="ctr"><a:buNone /></a:pPr><a:r><a:rPr b="1" /><a:t>單位</a:t></a:r></a:p></a:txBody><a:tcPr /></a:tc></a:tr><a:tr h="0"><a:tc><a:txBody><a:bodyPr /><a:lstStyle /><a:p><a:pPr lvl="0" indent="0" marL="0" algn="ctr"><a:buNone /></a:pPr><a:r><a:rPr b="1" /><a:t>費米速度</a:t></a:r><a:br /><a:r><a:rPr b="1" /><a:t>Fermi velocity</a:t></a:r></a:p></a:txBody></a:tc><a:tc><a:txBody><a:bodyPr /><a:lstStyle /><a:p><a:pPr lvl="0" indent="0" marL="0" algn="ctr"><a:buNone /></a:pPr><a14:m><m:oMath xmlns:m="http://schemas.openxmlformats.org/officeDocument/2006/math"><m:sSub><m:e><m:r><m:t>v</m:t></m:r></m:e><m:sub><m:r><m:t>F</m:t></m:r></m:sub></m:sSub></m:oMath></a14:m></a:p></a:txBody></a:tc><a:tc><a:txBody><a:bodyPr /><a:lstStyle /><a:p><a:pPr lvl="0" indent="0" marL="0" algn="ctr"><a:buNone /></a:pPr><a:r><a:rPr /><a:t>≈ 1.25–1.55</a:t></a:r></a:p></a:txBody></a:tc><a:tc><a:txBody><a:bodyPr /><a:lstStyle /><a:p><a:pPr lvl="0" indent="0" marL="0" algn="ctr"><a:buNone /></a:pPr><a14:m><m:oMath xmlns:m="http://schemas.openxmlformats.org/officeDocument/2006/math"><m:r><m:t>3.3</m:t></m:r><m:r><m:rPr><m:sty m:val="p" /></m:rPr><m:t>×</m:t></m:r><m:sSup><m:e><m:r><m:t>10</m:t></m:r></m:e><m:sup><m:r><m:rPr><m:sty m:val="p" /></m:rPr><m:t>−</m:t></m:r><m:r><m:t>5</m:t></m:r></m:sup></m:sSup></m:oMath></a14:m></a:p></a:txBody></a:tc><a:tc><a:txBody><a:bodyPr /><a:lstStyle /><a:p><a:pPr lvl="0" indent="0" marL="0" algn="ctr"><a:buNone /></a:pPr><a:r><a:rPr /><a:t>m/s</a:t></a:r></a:p></a:txBody></a:tc></a:tr><a:tr h="0"><a:tc><a:txBody><a:bodyPr /><a:lstStyle /><a:p><a:pPr lvl="0" indent="0" marL="0" algn="ctr"><a:buNone /></a:pPr><a:r><a:rPr b="1" /><a:t>平均碰撞時間</a:t></a:r><a:br /><a:r><a:rPr b="1" /><a:t>Mean free time</a:t></a:r></a:p></a:txBody></a:tc><a:tc><a:txBody><a:bodyPr /><a:lstStyle /><a:p><a:pPr lvl="0" indent="0" marL="0" algn="ctr"><a:buNone /></a:pPr><a14:m><m:oMath xmlns:m="http://schemas.openxmlformats.org/officeDocument/2006/math"><m:r><m:t>τ</m:t></m:r></m:oMath></a14:m></a:p></a:txBody></a:tc><a:tc><a:txBody><a:bodyPr /><a:lstStyle /><a:p><a:pPr lvl="0" indent="0" marL="0" algn="ctr"><a:buNone /></a:pPr><a:r><a:rPr /><a:t>≈ 10⁻¹²–10⁻¹¹</a:t></a:r></a:p></a:txBody></a:tc><a:tc><a:txBody><a:bodyPr /><a:lstStyle /><a:p><a:pPr lvl="0" indent="0" marL="0" algn="ctr"><a:buNone /></a:pPr><a:r><a:rPr /><a:t>≈ 10⁻¹²–10⁻¹¹</a:t></a:r></a:p></a:txBody></a:tc><a:tc><a:txBody><a:bodyPr /><a:lstStyle /><a:p><a:pPr lvl="0" indent="0" marL="0" algn="ctr"><a:buNone /></a:pPr><a:r><a:rPr /><a:t>s</a:t></a:r></a:p></a:txBody></a:tc></a:tr><a:tr h="0"><a:tc><a:txBody><a:bodyPr /><a:lstStyle /><a:p><a:pPr lvl="0" indent="0" marL="0" algn="ctr"><a:buNone /></a:pPr><a:r><a:rPr b="1" /><a:t>擴散係數</a:t></a:r><a:br /><a:r><a:rPr b="1" /><a:t>Diffusion coefficient</a:t></a:r></a:p></a:txBody></a:tc><a:tc><a:txBody><a:bodyPr /><a:lstStyle /><a:p><a:pPr lvl="0" indent="0" marL="0" algn="ctr"><a:buNone /></a:pPr><a14:m><m:oMath xmlns:m="http://schemas.openxmlformats.org/officeDocument/2006/math"><m:r><m:t>D</m:t></m:r><m:r><m:rPr><m:sty m:val="p" /></m:rPr><m:t>=</m:t></m:r><m:sSubSup><m:e><m:r><m:t>v</m:t></m:r></m:e><m:sub><m:r><m:t>F</m:t></m:r></m:sub><m:sup><m:r><m:t>2</m:t></m:r></m:sup></m:sSubSup><m:f><m:fPr><m:type m:val="bar" /></m:fPr><m:num><m:r><m:t>τ</m:t></m:r></m:num><m:den><m:r><m:t>2</m:t></m:r></m:den></m:f></m:oMath></a14:m></a:p></a:txBody></a:tc><a:tc><a:txBody><a:bodyPr /><a:lstStyle /><a:p><a:pPr lvl="0" indent="0" marL="0" algn="ctr"><a:buNone /></a:pPr><a:r><a:rPr /><a:t>≈ 5.6×10²–5.6×10³</a:t></a:r></a:p></a:txBody></a:tc><a:tc><a:txBody><a:bodyPr /><a:lstStyle /><a:p><a:pPr lvl="0" indent="0" marL="0" algn="ctr"><a:buNone /></a:pPr><a:r><a:rPr /><a:t>≈ 1.5×10²–2.4×10³</a:t></a:r></a:p></a:txBody></a:tc><a:tc><a:txBody><a:bodyPr /><a:lstStyle /><a:p><a:pPr lvl="0" indent="0" marL="0" algn="ctr"><a:buNone /></a:pPr><a:r><a:rPr /><a:t>cm²/s</a:t></a:r></a:p></a:txBody></a:tc></a:tr><a:tr h="0"><a:tc><a:txBody><a:bodyPr /><a:lstStyle /><a:p><a:pPr lvl="0" indent="0" marL="0" algn="ctr"><a:buNone /></a:pPr><a:r><a:rPr b="1" /><a:t>電阻率</a:t></a:r><a:br /><a:r><a:rPr b="1" /><a:t>Resistivity</a:t></a:r><a:r><a:rPr /><a:t> ¹</a:t></a:r></a:p></a:txBody></a:tc><a:tc><a:txBody><a:bodyPr /><a:lstStyle /><a:p><a:pPr lvl="0" indent="0" marL="0" algn="ctr"><a:buNone /></a:pPr><a14:m><m:oMath xmlns:m="http://schemas.openxmlformats.org/officeDocument/2006/math"><m:r><m:t>ρ</m:t></m:r><m:r><m:rPr><m:sty m:val="p" /></m:rPr><m:t>=</m:t></m:r><m:sSup><m:e><m:d><m:dPr><m:begChr m:val="[" /><m:sepChr m:val="" /><m:endChr m:val="]" /><m:grow /></m:dPr><m:e><m:sSub><m:e><m:r><m:t>n</m:t></m:r></m:e><m:sub><m:r><m:t>s</m:t></m:r></m:sub></m:sSub><m:r><m:t>e</m:t></m:r><m:sSub><m:e><m:r><m:t>μ</m:t></m:r></m:e><m:sub><m:r><m:t>e</m:t></m:r></m:sub></m:sSub></m:e></m:d></m:e><m:sup><m:r><m:rPr><m:sty m:val="p" /></m:rPr><m:t>−</m:t></m:r><m:r><m:t>1</m:t></m:r></m:sup></m:sSup></m:oMath></a14:m></a:p></a:txBody></a:tc><a:tc><a:txBody><a:bodyPr /><a:lstStyle /><a:p><a:pPr lvl="0" indent="0" marL="0" algn="ctr"><a:buNone /></a:pPr><a:r><a:rPr /><a:t>≈ 0.001–0.01</a:t></a:r></a:p></a:txBody></a:tc><a:tc><a:txBody><a:bodyPr /><a:lstStyle /><a:p><a:pPr lvl="0" indent="0" marL="0" algn="ctr"><a:buNone /></a:pPr><a:r><a:rPr /><a:t>≈ 0.0002–0.002</a:t></a:r></a:p></a:txBody></a:tc><a:tc><a:txBody><a:bodyPr /><a:lstStyle /><a:p><a:pPr lvl="0" indent="0" marL="0" algn="ctr"><a:buNone /></a:pPr><a:r><a:rPr /><a:t>kΩ (per □)</a:t></a:r></a:p></a:txBody></a:tc></a:tr><a:tr h="0"><a:tc><a:txBody><a:bodyPr /><a:lstStyle /><a:p><a:pPr lvl="0" indent="0" marL="0" algn="ctr"><a:buNone /></a:pPr><a:r><a:rPr b="1" /><a:t>費米波長</a:t></a:r><a:br /><a:r><a:rPr b="1" /><a:t>Fermi wavelength</a:t></a:r></a:p></a:txBody></a:tc><a:tc><a:txBody><a:bodyPr /><a:lstStyle /><a:p><a:pPr lvl="0" indent="0" marL="0" algn="ctr"><a:buNone /></a:pPr><a14:m><m:oMath xmlns:m="http://schemas.openxmlformats.org/officeDocument/2006/math"><m:sSub><m:e><m:r><m:t>λ</m:t></m:r></m:e><m:sub><m:r><m:t>F</m:t></m:r></m:sub></m:sSub><m:r><m:rPr><m:sty m:val="p" /></m:rPr><m:t>=</m:t></m:r><m:r><m:t>2</m:t></m:r><m:f><m:fPr><m:type m:val="bar" /></m:fPr><m:num><m:r><m:t>π</m:t></m:r></m:num><m:den><m:sSub><m:e><m:r><m:t>k</m:t></m:r></m:e><m:sub><m:r><m:t>F</m:t></m:r></m:sub></m:sSub></m:den></m:f></m:oMath></a14:m></a:p></a:txBody></a:tc><a:tc><a:txBody><a:bodyPr /><a:lstStyle /><a:p><a:pPr lvl="0" indent="0" marL="0" algn="ctr"><a:buNone /></a:pPr><a:r><a:rPr /><a:t>≈ 0.32 nm</a:t></a:r></a:p></a:txBody></a:tc><a:tc><a:txBody><a:bodyPr /><a:lstStyle /><a:p><a:pPr lvl="0" indent="0" marL="0" algn="ctr"><a:buNone /></a:pPr><a:r><a:rPr /><a:t>≈ 7–11 nm</a:t></a:r></a:p></a:txBody></a:tc><a:tc><a:txBody><a:bodyPr /><a:lstStyle /><a:p><a:pPr lvl="0" indent="0" marL="0" algn="ctr"><a:buNone /></a:pPr><a:r><a:rPr /><a:t>nm</a:t></a:r></a:p></a:txBody></a:tc></a:tr><a:tr h="0"><a:tc><a:txBody><a:bodyPr /><a:lstStyle /><a:p><a:pPr lvl="0" indent="0" marL="0" algn="ctr"><a:buNone /></a:pPr><a:r><a:rPr b="1" /><a:t>平均自由路徑</a:t></a:r><a:br /><a:r><a:rPr b="1" /><a:t>Mean-free path</a:t></a:r></a:p></a:txBody></a:tc><a:tc><a:txBody><a:bodyPr /><a:lstStyle /><a:p><a:pPr lvl="0" indent="0" marL="0" algn="ctr"><a:buNone /></a:pPr><a14:m><m:oMath xmlns:m="http://schemas.openxmlformats.org/officeDocument/2006/math"><m:sSub><m:e><m:r><m:t>l</m:t></m:r></m:e><m:sub><m:r><m:t>e</m:t></m:r></m:sub></m:sSub><m:r><m:rPr><m:sty m:val="p" /></m:rPr><m:t>=</m:t></m:r><m:sSub><m:e><m:r><m:t>v</m:t></m:r></m:e><m:sub><m:r><m:t>F</m:t></m:r></m:sub></m:sSub><m:r><m:t>τ</m:t></m:r></m:oMath></a14:m></a:p></a:txBody></a:tc><a:tc><a:txBody><a:bodyPr /><a:lstStyle /><a:p><a:pPr lvl="0" indent="0" marL="0" algn="ctr"><a:buNone /></a:pPr><a:r><a:rPr /><a:t>80–800</a:t></a:r></a:p></a:txBody></a:tc><a:tc><a:txBody><a:bodyPr /><a:lstStyle /><a:p><a:pPr lvl="0" indent="0" marL="0" algn="ctr"><a:buNone /></a:pPr><a:r><a:rPr /><a:t>180</a:t></a:r></a:p></a:txBody></a:tc><a:tc><a:txBody><a:bodyPr /><a:lstStyle /><a:p><a:pPr lvl="0" indent="0" marL="0" algn="ctr"><a:buNone /></a:pPr><a:r><a:rPr /><a:t>nm</a:t></a:r></a:p></a:txBody></a:tc></a:tr><a:tr h="0"><a:tc><a:txBody><a:bodyPr /><a:lstStyle /><a:p><a:pPr lvl="0" indent="0" marL="0" algn="ctr"><a:buNone /></a:pPr><a:r><a:rPr b="1" /><a:t>載子遷移率</a:t></a:r><a:br /><a:r><a:rPr b="1" /><a:t>Electron mobility</a:t></a:r></a:p></a:txBody></a:tc><a:tc><a:txBody><a:bodyPr /><a:lstStyle /><a:p><a:pPr lvl="0" indent="0" marL="0" algn="ctr"><a:buNone /></a:pPr><a14:m><m:oMath xmlns:m="http://schemas.openxmlformats.org/officeDocument/2006/math"><m:sSub><m:e><m:r><m:t>μ</m:t></m:r></m:e><m:sub><m:r><m:t>e</m:t></m:r></m:sub></m:sSub><m:r><m:rPr><m:sty m:val="p" /></m:rPr><m:t>=</m:t></m:r><m:f><m:fPr><m:type m:val="bar" /></m:fPr><m:num><m:sSub><m:e><m:r><m:t>v</m:t></m:r></m:e><m:sub><m:r><m:t>F</m:t></m:r></m:sub></m:sSub></m:num><m:den><m:sSub><m:e><m:r><m:t>l</m:t></m:r></m:e><m:sub><m:r><m:t>e</m:t></m:r></m:sub></m:sSub></m:den></m:f></m:oMath></a14:m></a:p></a:txBody></a:tc><a:tc><a:txBody><a:bodyPr /><a:lstStyle /><a:p><a:pPr lvl="0" indent="0" marL="0" algn="ctr"><a:buNone /></a:pPr><a:r><a:rPr /><a:t>≈ 1.25–1.55</a:t></a:r></a:p></a:txBody></a:tc><a:tc><a:txBody><a:bodyPr /><a:lstStyle /><a:p><a:pPr lvl="0" indent="0" marL="0" algn="ctr"><a:buNone /></a:pPr><a:r><a:rPr /><a:t>≈ 6.5–7.5</a:t></a:r></a:p></a:txBody></a:tc><a:tc><a:txBody><a:bodyPr /><a:lstStyle /><a:p><a:pPr lvl="0" indent="0" marL="0" algn="ctr"><a:buNone /></a:pPr><a:r><a:rPr /><a:t>cm²/Vs</a:t></a:r></a:p></a:txBody></a:tc></a:tr><a:tr h="0"><a:tc><a:txBody><a:bodyPr /><a:lstStyle /><a:p><a:pPr lvl="0" indent="0" marL="0" algn="ctr"><a:buNone /></a:pPr><a:r><a:rPr b="1" /><a:t>狄拉克點</a:t></a:r><a:br /><a:r><a:rPr b="1" /><a:t>Dirac point</a:t></a:r></a:p></a:txBody></a:tc><a:tc><a:txBody><a:bodyPr /><a:lstStyle /><a:p><a:pPr lvl="0" indent="0" marL="0" algn="ctr"><a:buNone /></a:pPr><a14:m><m:oMath xmlns:m="http://schemas.openxmlformats.org/officeDocument/2006/math"><m:sSub><m:e><m:r><m:t>E</m:t></m:r></m:e><m:sub><m:r><m:t>D</m:t></m:r></m:sub></m:sSub></m:oMath></a14:m></a:p></a:txBody></a:tc><a:tc><a:txBody><a:bodyPr /><a:lstStyle /><a:p><a:pPr lvl="0" indent="0" marL="0" algn="ctr"><a:buNone /></a:pPr><a:r><a:rPr /><a:t>≈ 0.32 eV</a:t></a:r></a:p></a:txBody></a:tc><a:tc><a:txBody><a:bodyPr /><a:lstStyle /><a:p><a:pPr lvl="0" indent="0" marL="0" algn="ctr"><a:buNone /></a:pPr><a:r><a:rPr /><a:t>≈ 0.32 eV</a:t></a:r></a:p></a:txBody></a:tc><a:tc><a:txBody><a:bodyPr /><a:lstStyle /><a:p><a:pPr lvl="0" indent="0" marL="0" algn="ctr"><a:buNone /></a:pPr><a:r><a:rPr /><a:t>eV</a:t></a:r></a:p></a:txBody></a:tc></a:tr><a:tr h="0"><a:tc><a:txBody><a:bodyPr /><a:lstStyle /><a:p><a:pPr lvl="0" indent="0" marL="0" algn="ctr"><a:buNone /></a:pPr><a:r><a:rPr b="1" /><a:t>超導相干長度</a:t></a:r><a:br /><a:r><a:rPr b="1" /><a:t>Superconducting coherence length</a:t></a:r></a:p></a:txBody></a:tc><a:tc><a:txBody><a:bodyPr /><a:lstStyle /><a:p><a:pPr lvl="0" indent="0" marL="0" algn="ctr"><a:buNone /></a:pPr><a14:m><m:oMath xmlns:m="http://schemas.openxmlformats.org/officeDocument/2006/math"><m:r><m:t>ξ</m:t></m:r></m:oMath></a14:m></a:p></a:txBody></a:tc><a:tc><a:txBody><a:bodyPr /><a:lstStyle /><a:p><a:pPr lvl="0" indent="0" marL="0" algn="ctr"><a:buNone /></a:pPr><a:r><a:rPr /><a:t>≈ 10 nm</a:t></a:r></a:p></a:txBody></a:tc><a:tc><a:txBody><a:bodyPr /><a:lstStyle /><a:p><a:pPr lvl="0" indent="0" marL="0" algn="ctr"><a:buNone /></a:pPr><a:r><a:rPr /><a:t>≈ 10 nm</a:t></a:r></a:p></a:txBody></a:tc><a:tc><a:txBody><a:bodyPr /><a:lstStyle /><a:p><a:pPr lvl="0" indent="0" marL="0" algn="ctr"><a:buNone /></a:pPr><a:r><a:rPr /><a:t>nm</a:t></a:r></a:p></a:txBody></a:tc></a:tr></a:tbl></a:graphicData></a:graphic></p:graphicFrame><p:sp><p:nvSpPr><p:cNvPr id="1" name="TextBox 3" /><p:cNvSpPr txBox="1" /><p:nvPr /></p:nvSpPr><p:spPr><a:xfrm><a:off x="3568700" y="4076700" /><a:ext cx="5105400" cy="508000" /></a:xfrm><a:prstGeom prst="rect"><a:avLst /></a:prstGeom><a:noFill /></p:spPr><p:txBody><a:bodyPr /><a:lstStyle /><a:p><a:pPr lvl="0" indent="0" marL="0" algn="ctr"><a:buNone /></a:pPr><a:r><a:rPr /><a:t>PtTe2、NbTi量子輸運參數表</a:t></a:r></a:p></p:txBody></p:sp></p:spTree></p:cSld></p:sld>
+</file>
+
+<file path=ppt/slides/slide33.xml><?xml version="1.0" encoding="utf-8"?>
+<p:sld xmlns:a="http://schemas.openxmlformats.org/drawingml/2006/main" xmlns:r="http://schemas.openxmlformats.org/officeDocument/2006/relationships" xmlns:p="http://schemas.openxmlformats.org/presentationml/2006/main">
+  <p:cSld>
+    <p:spTree>
+      <p:nvGrpSpPr>
+        <p:cNvPr id="1" name=""/>
+        <p:cNvGrpSpPr/>
+        <p:nvPr/>
+      </p:nvGrpSpPr>
+      <p:grpSpPr>
+        <a:xfrm>
+          <a:off x="0" y="0"/>
+          <a:ext cx="0" cy="0"/>
+          <a:chOff x="0" y="0"/>
+          <a:chExt cx="0" cy="0"/>
+        </a:xfrm>
+      </p:grpSpPr>
+      <p:sp>
+        <p:nvSpPr>
+          <p:cNvPr id="2" name="Title 1"/>
+          <p:cNvSpPr>
+            <a:spLocks noGrp="1"/>
+          </p:cNvSpPr>
+          <p:nvPr>
+            <p:ph type="title"/>
+          </p:nvPr>
+        </p:nvSpPr>
+        <p:spPr>
+          <a:xfrm>
+            <a:off x="722313" y="3305176"/>
+            <a:ext cx="7772400" cy="1021556"/>
+          </a:xfrm>
+        </p:spPr>
+        <p:txBody>
+          <a:bodyPr/>
+          <a:lstStyle/>
+          <a:p>
+            <a:pPr lvl="0" indent="0" marL="0">
+              <a:buNone/>
+            </a:pPr>
+            <a:r>
+              <a:rPr/>
+              <a:t>參考文獻</a:t>
+            </a:r>
+          </a:p>
+        </p:txBody>
+      </p:sp>
+    </p:spTree>
+  </p:cSld>
+</p:sld>
+</file>
+
+<file path=ppt/slides/slide34.xml><?xml version="1.0" encoding="utf-8"?>
+<p:sld xmlns:a="http://schemas.openxmlformats.org/drawingml/2006/main" xmlns:r="http://schemas.openxmlformats.org/officeDocument/2006/relationships" xmlns:p="http://schemas.openxmlformats.org/presentationml/2006/main">
+  <p:cSld>
+    <p:spTree>
+      <p:nvGrpSpPr>
+        <p:cNvPr id="1" name=""/>
+        <p:cNvGrpSpPr/>
+        <p:nvPr/>
+      </p:nvGrpSpPr>
+      <p:grpSpPr>
+        <a:xfrm>
+          <a:off x="0" y="0"/>
+          <a:ext cx="0" cy="0"/>
+          <a:chOff x="0" y="0"/>
+          <a:chExt cx="0" cy="0"/>
+        </a:xfrm>
+      </p:grpSpPr>
     </p:spTree>
   </p:cSld>
 </p:sld>
@@ -6691,7 +7266,7 @@
             </a:pPr>
             <a:r>
               <a:rPr/>
-              <a:t>研究目的 (Research Objectives)</a:t>
+              <a:t>研究問題與目標：回答「能否用磁場調控 CPR？」</a:t>
             </a:r>
           </a:p>
         </p:txBody>
@@ -6718,49 +7293,35 @@
                 </a:pPr>
                 <a:r>
                   <a:rPr b="1"/>
-                  <a:t>定量重構 CPR (Reconstruct CPR)</a:t>
-                </a:r>
-              </a:p>
-              <a:p>
-                <a:pPr lvl="1"/>
-                <a:r>
-                  <a:rPr/>
-                  <a:t>直接量測 PtTe</a:t>
+                  <a:t>定量重構 CPR</a:t>
+                </a:r>
+                <a:r>
+                  <a:rPr/>
+                  <a:t>：直接量測並拆解 </a:t>
                 </a:r>
                 <a14:m>
                   <m:oMath xmlns:m="http://schemas.openxmlformats.org/officeDocument/2006/math">
-                    <m:sSub>
+                    <m:r>
+                      <m:t>I</m:t>
+                    </m:r>
+                    <m:d>
+                      <m:dPr>
+                        <m:begChr m:val="("/>
+                        <m:sepChr m:val=""/>
+                        <m:endChr m:val=")"/>
+                        <m:grow/>
+                      </m:dPr>
                       <m:e>
                         <m:r>
-                          <m:t>​</m:t>
+                          <m:t>φ</m:t>
                         </m:r>
                       </m:e>
-                      <m:sub>
-                        <m:r>
-                          <m:t>2</m:t>
-                        </m:r>
-                      </m:sub>
-                    </m:sSub>
+                    </m:d>
                   </m:oMath>
                 </a14:m>
                 <a:r>
                   <a:rPr/>
-                  <a:t> 接面的電流-相位關係。</a:t>
-                </a:r>
-              </a:p>
-              <a:p>
-                <a:pPr lvl="1"/>
-                <a:r>
-                  <a:rPr/>
-                  <a:t>解析 </a:t>
-                </a:r>
-                <a:r>
-                  <a:rPr b="1"/>
-                  <a:t>高階諧波 (Higher Harmonics)</a:t>
-                </a:r>
-                <a:r>
-                  <a:rPr/>
-                  <a:t> 成分。</a:t>
+                  <a:t> 的諧波成分，確認高階諧波的權重。</a:t>
                 </a:r>
               </a:p>
               <a:p>
@@ -6769,29 +7330,11 @@
                 </a:pPr>
                 <a:r>
                   <a:rPr b="1"/>
-                  <a:t>磁場調控機制 (Magnetic Tuning)</a:t>
-                </a:r>
-              </a:p>
-              <a:p>
-                <a:pPr lvl="1"/>
-                <a:r>
-                  <a:rPr/>
-                  <a:t>探討 </a:t>
-                </a:r>
-                <a:r>
-                  <a:rPr b="1"/>
-                  <a:t>面內磁場</a:t>
-                </a:r>
-                <a:r>
-                  <a:rPr/>
-                  <a:t> 對 CPR 的連續調控行為。</a:t>
-                </a:r>
-              </a:p>
-              <a:p>
-                <a:pPr lvl="1"/>
-                <a:r>
-                  <a:rPr/>
-                  <a:t>連結微觀拓樸性質與宏觀輸運現象。</a:t>
+                  <a:t>磁場調控機制</a:t>
+                </a:r>
+                <a:r>
+                  <a:rPr/>
+                  <a:t>：檢驗面內磁場對 CPR 形狀與相位的影響，建立可調旋鈕的實驗證據。</a:t>
                 </a:r>
               </a:p>
               <a:p>
@@ -6800,37 +7343,27 @@
                 </a:pPr>
                 <a:r>
                   <a:rPr b="1"/>
-                  <a:t>建立物理圖像 (Physical Picture)</a:t>
-                </a:r>
-              </a:p>
-              <a:p>
-                <a:pPr lvl="1"/>
-                <a:r>
-                  <a:rPr/>
-                  <a:t>釐清 </a:t>
+                  <a:t>物理圖像</a:t>
+                </a:r>
+                <a:r>
+                  <a:rPr/>
+                  <a:t>：釐清 </a:t>
                 </a:r>
                 <a:r>
                   <a:rPr b="1"/>
-                  <a:t>體相多能帶 (Bulk Multiband)</a:t>
-                </a:r>
-                <a:r>
-                  <a:rPr/>
-                  <a:t> vs. </a:t>
+                  <a:t>體相多能帶</a:t>
+                </a:r>
+                <a:r>
+                  <a:rPr/>
+                  <a:t> 與 </a:t>
                 </a:r>
                 <a:r>
                   <a:rPr b="1"/>
-                  <a:t>拓樸表面態 (Surface States)</a:t>
-                </a:r>
-                <a:r>
-                  <a:rPr/>
-                  <a:t> 的競爭機制。</a:t>
-                </a:r>
-              </a:p>
-              <a:p>
-                <a:pPr lvl="1"/>
-                <a:r>
-                  <a:rPr/>
-                  <a:t>評估 PtTe</a:t>
+                  <a:t>拓樸表面態</a:t>
+                </a:r>
+                <a:r>
+                  <a:rPr/>
+                  <a:t> 的競合，評估 PtTe</a:t>
                 </a:r>
                 <a14:m>
                   <m:oMath xmlns:m="http://schemas.openxmlformats.org/officeDocument/2006/math">
@@ -6889,12 +7422,7 @@
             <p:ph type="title"/>
           </p:nvPr>
         </p:nvSpPr>
-        <p:spPr>
-          <a:xfrm>
-            <a:off x="722313" y="3305176"/>
-            <a:ext cx="7772400" cy="1021556"/>
-          </a:xfrm>
-        </p:spPr>
+        <p:spPr/>
         <p:txBody>
           <a:bodyPr/>
           <a:lstStyle/>
@@ -6904,7 +7432,56 @@
             </a:pPr>
             <a:r>
               <a:rPr/>
-              <a:t>理論背景</a:t>
+              <a:t>簡報路線圖：先廣角掃描，再對關鍵發現深潛</a:t>
+            </a:r>
+          </a:p>
+        </p:txBody>
+      </p:sp>
+      <p:sp>
+        <p:nvSpPr>
+          <p:cNvPr id="3" name="Content Placeholder 2"/>
+          <p:cNvSpPr>
+            <a:spLocks noGrp="1"/>
+          </p:cNvSpPr>
+          <p:nvPr>
+            <p:ph idx="1"/>
+          </p:nvPr>
+        </p:nvSpPr>
+        <p:spPr/>
+        <p:txBody>
+          <a:bodyPr/>
+          <a:lstStyle/>
+          <a:p>
+            <a:pPr lvl="0"/>
+            <a:r>
+              <a:rPr b="1"/>
+              <a:t>Swath（前半）</a:t>
+            </a:r>
+            <a:r>
+              <a:rPr/>
+              <a:t>：建構研究背景、缺口與方法論，交代量測與樣品品質。</a:t>
+            </a:r>
+          </a:p>
+          <a:p>
+            <a:pPr lvl="0"/>
+            <a:r>
+              <a:rPr b="1"/>
+              <a:t>Dive（中段）</a:t>
+            </a:r>
+            <a:r>
+              <a:rPr/>
+              <a:t>：聚焦兩個核心發現——干涉圖樣畸變與二階諧波增強，對應兩個主要質疑。</a:t>
+            </a:r>
+          </a:p>
+          <a:p>
+            <a:pPr lvl="0"/>
+            <a:r>
+              <a:rPr b="1"/>
+              <a:t>收斂（後段）</a:t>
+            </a:r>
+            <a:r>
+              <a:rPr/>
+              <a:t>：討論意涵與限制，提出未來工作與備用投影片，讓委員可即時查核。</a:t>
             </a:r>
           </a:p>
         </p:txBody>
@@ -6941,7 +7518,12 @@
             <p:ph type="title"/>
           </p:nvPr>
         </p:nvSpPr>
-        <p:spPr/>
+        <p:spPr>
+          <a:xfrm>
+            <a:off x="722313" y="3305176"/>
+            <a:ext cx="7772400" cy="1021556"/>
+          </a:xfrm>
+        </p:spPr>
         <p:txBody>
           <a:bodyPr/>
           <a:lstStyle/>
@@ -6951,203 +7533,11 @@
             </a:pPr>
             <a:r>
               <a:rPr/>
-              <a:t>核心理論架構：從材料到元件</a:t>
-            </a:r>
-          </a:p>
-        </p:txBody>
-      </p:sp>
-      <mc:AlternateContent xmlns:mc="http://schemas.openxmlformats.org/markup-compatibility/2006">
-        <mc:Choice xmlns:a14="http://schemas.microsoft.com/office/drawing/2010/main" Requires="a14">
-          <p:sp>
-            <p:nvSpPr>
-              <p:cNvPr id="3" name="Content Placeholder 2"/>
-              <p:cNvSpPr>
-                <a:spLocks noGrp="1"/>
-              </p:cNvSpPr>
-              <p:nvPr>
-                <p:ph idx="1"/>
-              </p:nvPr>
-            </p:nvSpPr>
-            <p:spPr/>
-            <p:txBody>
-              <a:bodyPr/>
-              <a:lstStyle/>
-              <a:p>
-                <a:pPr lvl="0"/>
-                <a:r>
-                  <a:rPr b="1"/>
-                  <a:t>第二類狄拉克半金屬 (Type-II DSM, PtTe</a:t>
-                </a:r>
-                <a14:m>
-                  <m:oMath xmlns:m="http://schemas.openxmlformats.org/officeDocument/2006/math">
-                    <m:sSub>
-                      <m:e>
-                        <m:r>
-                          <m:t>​</m:t>
-                        </m:r>
-                      </m:e>
-                      <m:sub>
-                        <m:r>
-                          <m:t>2</m:t>
-                        </m:r>
-                      </m:sub>
-                    </m:sSub>
-                  </m:oMath>
-                </a14:m>
-                <a:r>
-                  <a:rPr b="1"/>
-                  <a:t>)</a:t>
-                </a:r>
-              </a:p>
-              <a:p>
-                <a:pPr lvl="1"/>
-                <a:r>
-                  <a:rPr/>
-                  <a:t>具有受晶體對稱性保護的 </a:t>
-                </a:r>
-                <a:r>
-                  <a:rPr b="1"/>
-                  <a:t>狄拉克錐 (Dirac Cone)</a:t>
-                </a:r>
-                <a:r>
-                  <a:rPr/>
-                  <a:t> 與 </a:t>
-                </a:r>
-                <a:r>
-                  <a:rPr b="1"/>
-                  <a:t>拓樸表面態</a:t>
-                </a:r>
-                <a:r>
-                  <a:rPr/>
-                  <a:t>。</a:t>
-                </a:r>
-              </a:p>
-              <a:p>
-                <a:pPr lvl="1"/>
-                <a:r>
-                  <a:rPr/>
-                  <a:t>費米能階附近的 </a:t>
-                </a:r>
-                <a:r>
-                  <a:rPr b="1"/>
-                  <a:t>多能帶 (Multiband)</a:t>
-                </a:r>
-                <a:r>
-                  <a:rPr/>
-                  <a:t> 特性主導低能輸運。</a:t>
-                </a:r>
-              </a:p>
-              <a:p>
-                <a:pPr lvl="0"/>
-                <a:r>
-                  <a:rPr b="1"/>
-                  <a:t>超導近接效應 (Proximity Effect)</a:t>
-                </a:r>
-              </a:p>
-              <a:p>
-                <a:pPr lvl="1"/>
-                <a:r>
-                  <a:rPr b="1"/>
-                  <a:t>S-DSM-S 接面</a:t>
-                </a:r>
-                <a:r>
-                  <a:rPr/>
-                  <a:t>：超導關聯透過 </a:t>
-                </a:r>
-                <a:r>
-                  <a:rPr b="1"/>
-                  <a:t>安德烈夫反射 (Andreev Reflection)</a:t>
-                </a:r>
-                <a:r>
-                  <a:rPr/>
-                  <a:t> 穿透半金屬。</a:t>
-                </a:r>
-              </a:p>
-              <a:p>
-                <a:pPr lvl="1"/>
-                <a:r>
-                  <a:rPr b="1"/>
-                  <a:t>非正弦 CPR</a:t>
-                </a:r>
-                <a:r>
-                  <a:rPr/>
-                  <a:t>：高透明度接面或拓樸態可導致 </a:t>
-                </a:r>
-                <a14:m>
-                  <m:oMath xmlns:m="http://schemas.openxmlformats.org/officeDocument/2006/math">
-                    <m:r>
-                      <m:t>I</m:t>
-                    </m:r>
-                    <m:d>
-                      <m:dPr>
-                        <m:begChr m:val="("/>
-                        <m:sepChr m:val=""/>
-                        <m:endChr m:val=")"/>
-                        <m:grow/>
-                      </m:dPr>
-                      <m:e>
-                        <m:r>
-                          <m:t>φ</m:t>
-                        </m:r>
-                      </m:e>
-                    </m:d>
-                    <m:r>
-                      <m:rPr>
-                        <m:sty m:val="p"/>
-                      </m:rPr>
-                      <m:t>=</m:t>
-                    </m:r>
-                    <m:r>
-                      <m:rPr>
-                        <m:sty m:val="p"/>
-                      </m:rPr>
-                      <m:t>∑</m:t>
-                    </m:r>
-                    <m:sSub>
-                      <m:e>
-                        <m:r>
-                          <m:t>A</m:t>
-                        </m:r>
-                      </m:e>
-                      <m:sub>
-                        <m:r>
-                          <m:t>n</m:t>
-                        </m:r>
-                      </m:sub>
-                    </m:sSub>
-                    <m:r>
-                      <m:rPr>
-                        <m:sty m:val="p"/>
-                      </m:rPr>
-                      <m:t>sin</m:t>
-                    </m:r>
-                    <m:d>
-                      <m:dPr>
-                        <m:begChr m:val="("/>
-                        <m:sepChr m:val=""/>
-                        <m:endChr m:val=")"/>
-                        <m:grow/>
-                      </m:dPr>
-                      <m:e>
-                        <m:r>
-                          <m:t>n</m:t>
-                        </m:r>
-                        <m:r>
-                          <m:t>φ</m:t>
-                        </m:r>
-                      </m:e>
-                    </m:d>
-                  </m:oMath>
-                </a14:m>
-                <a:r>
-                  <a:rPr/>
-                  <a:t>。</a:t>
-                </a:r>
-              </a:p>
-            </p:txBody>
-          </p:sp>
-        </mc:Choice>
-      </mc:AlternateContent>
+              <a:t>研究脈絡：缺乏可調式 CPR 的直接證據</a:t>
+            </a:r>
+          </a:p>
+        </p:txBody>
+      </p:sp>
     </p:spTree>
   </p:cSld>
 </p:sld>
@@ -7190,7 +7580,383 @@
             </a:pPr>
             <a:r>
               <a:rPr/>
-              <a:t>關鍵測量工具：非對稱 SQUID (aSQUID)</a:t>
+              <a:t>Gap 與重要性：需要能被操控的 CPR 來驅動量子元件</a:t>
+            </a:r>
+          </a:p>
+        </p:txBody>
+      </p:sp>
+      <mc:AlternateContent xmlns:mc="http://schemas.openxmlformats.org/markup-compatibility/2006">
+        <mc:Choice xmlns:a14="http://schemas.microsoft.com/office/drawing/2010/main" Requires="a14">
+          <p:sp>
+            <p:nvSpPr>
+              <p:cNvPr id="3" name="Content Placeholder 2"/>
+              <p:cNvSpPr>
+                <a:spLocks noGrp="1"/>
+              </p:cNvSpPr>
+              <p:nvPr>
+                <p:ph idx="1"/>
+              </p:nvPr>
+            </p:nvSpPr>
+            <p:spPr/>
+            <p:txBody>
+              <a:bodyPr/>
+              <a:lstStyle/>
+              <a:p>
+                <a:pPr lvl="0"/>
+                <a:r>
+                  <a:rPr b="1"/>
+                  <a:t>拓樸半金屬 + 超導近接</a:t>
+                </a:r>
+                <a:r>
+                  <a:rPr/>
+                  <a:t> 被視為實現超導二極體與拓樸量子位元的候選平台，但 </a:t>
+                </a:r>
+                <a:r>
+                  <a:rPr b="1"/>
+                  <a:t>可連續調控的 CPR</a:t>
+                </a:r>
+                <a:r>
+                  <a:rPr/>
+                  <a:t> 實驗證據稀少。</a:t>
+                </a:r>
+              </a:p>
+              <a:p>
+                <a:pPr lvl="0"/>
+                <a:r>
+                  <a:rPr/>
+                  <a:t>既有研究多聚焦於 </a:t>
+                </a:r>
+                <a:r>
+                  <a:rPr b="1"/>
+                  <a:t>約瑟夫森二極體效應 (JDE)</a:t>
+                </a:r>
+                <a:r>
+                  <a:rPr/>
+                  <a:t>，缺乏針對 </a:t>
+                </a:r>
+                <a:r>
+                  <a:rPr b="1"/>
+                  <a:t>高階諧波與相位偏移</a:t>
+                </a:r>
+                <a:r>
+                  <a:rPr/>
+                  <a:t> 的直接量測與模型驗證。</a:t>
+                </a:r>
+              </a:p>
+              <a:p>
+                <a:pPr lvl="0"/>
+                <a:r>
+                  <a:rPr/>
+                  <a:t>本工作以 </a:t>
+                </a:r>
+                <a:r>
+                  <a:rPr b="1"/>
+                  <a:t>面內磁場</a:t>
+                </a:r>
+                <a:r>
+                  <a:rPr/>
+                  <a:t> 作為控制參數，驗證 PtTe</a:t>
+                </a:r>
+                <a14:m>
+                  <m:oMath xmlns:m="http://schemas.openxmlformats.org/officeDocument/2006/math">
+                    <m:sSub>
+                      <m:e>
+                        <m:r>
+                          <m:t>​</m:t>
+                        </m:r>
+                      </m:e>
+                      <m:sub>
+                        <m:r>
+                          <m:t>2</m:t>
+                        </m:r>
+                      </m:sub>
+                    </m:sSub>
+                  </m:oMath>
+                </a14:m>
+                <a:r>
+                  <a:rPr/>
+                  <a:t> 接面 CPR 是否具備工程化的可調性。</a:t>
+                </a:r>
+              </a:p>
+            </p:txBody>
+          </p:sp>
+        </mc:Choice>
+      </mc:AlternateContent>
+    </p:spTree>
+  </p:cSld>
+</p:sld>
+</file>
+
+<file path=ppt/slides/slide8.xml><?xml version="1.0" encoding="utf-8"?>
+<p:sld xmlns:a="http://schemas.openxmlformats.org/drawingml/2006/main" xmlns:r="http://schemas.openxmlformats.org/officeDocument/2006/relationships" xmlns:p="http://schemas.openxmlformats.org/presentationml/2006/main">
+  <p:cSld>
+    <p:spTree>
+      <p:nvGrpSpPr>
+        <p:cNvPr id="1" name=""/>
+        <p:cNvGrpSpPr/>
+        <p:nvPr/>
+      </p:nvGrpSpPr>
+      <p:grpSpPr>
+        <a:xfrm>
+          <a:off x="0" y="0"/>
+          <a:ext cx="0" cy="0"/>
+          <a:chOff x="0" y="0"/>
+          <a:chExt cx="0" cy="0"/>
+        </a:xfrm>
+      </p:grpSpPr>
+      <p:sp>
+        <p:nvSpPr>
+          <p:cNvPr id="2" name="Title 1"/>
+          <p:cNvSpPr>
+            <a:spLocks noGrp="1"/>
+          </p:cNvSpPr>
+          <p:nvPr>
+            <p:ph type="title"/>
+          </p:nvPr>
+        </p:nvSpPr>
+        <p:spPr/>
+        <p:txBody>
+          <a:bodyPr/>
+          <a:lstStyle/>
+          <a:p>
+            <a:pPr lvl="0" indent="0" marL="0">
+              <a:buNone/>
+            </a:pPr>
+            <a:r>
+              <a:rPr/>
+              <a:t>理論支撐：Type-II DSM 與超導近接效應預期非正弦 CPR</a:t>
+            </a:r>
+          </a:p>
+        </p:txBody>
+      </p:sp>
+      <mc:AlternateContent xmlns:mc="http://schemas.openxmlformats.org/markup-compatibility/2006">
+        <mc:Choice xmlns:a14="http://schemas.microsoft.com/office/drawing/2010/main" Requires="a14">
+          <p:sp>
+            <p:nvSpPr>
+              <p:cNvPr id="3" name="Content Placeholder 2"/>
+              <p:cNvSpPr>
+                <a:spLocks noGrp="1"/>
+              </p:cNvSpPr>
+              <p:nvPr>
+                <p:ph idx="1"/>
+              </p:nvPr>
+            </p:nvSpPr>
+            <p:spPr/>
+            <p:txBody>
+              <a:bodyPr/>
+              <a:lstStyle/>
+              <a:p>
+                <a:pPr lvl="0"/>
+                <a:r>
+                  <a:rPr b="1"/>
+                  <a:t>第二類狄拉克半金屬 (Type-II DSM, PtTe</a:t>
+                </a:r>
+                <a14:m>
+                  <m:oMath xmlns:m="http://schemas.openxmlformats.org/officeDocument/2006/math">
+                    <m:sSub>
+                      <m:e>
+                        <m:r>
+                          <m:t>​</m:t>
+                        </m:r>
+                      </m:e>
+                      <m:sub>
+                        <m:r>
+                          <m:t>2</m:t>
+                        </m:r>
+                      </m:sub>
+                    </m:sSub>
+                  </m:oMath>
+                </a14:m>
+                <a:r>
+                  <a:rPr b="1"/>
+                  <a:t>)</a:t>
+                </a:r>
+              </a:p>
+              <a:p>
+                <a:pPr lvl="1"/>
+                <a:r>
+                  <a:rPr/>
+                  <a:t>受晶體對稱性保護的 </a:t>
+                </a:r>
+                <a:r>
+                  <a:rPr b="1"/>
+                  <a:t>狄拉克錐</a:t>
+                </a:r>
+                <a:r>
+                  <a:rPr/>
+                  <a:t> 與 </a:t>
+                </a:r>
+                <a:r>
+                  <a:rPr b="1"/>
+                  <a:t>拓樸表面態</a:t>
+                </a:r>
+                <a:r>
+                  <a:rPr/>
+                  <a:t>，伴隨 </a:t>
+                </a:r>
+                <a:r>
+                  <a:rPr b="1"/>
+                  <a:t>多能帶 (Multiband)</a:t>
+                </a:r>
+                <a:r>
+                  <a:rPr/>
+                  <a:t> 輸運。</a:t>
+                </a:r>
+              </a:p>
+              <a:p>
+                <a:pPr lvl="0"/>
+                <a:r>
+                  <a:rPr b="1"/>
+                  <a:t>超導近接效應 (Proximity Effect)</a:t>
+                </a:r>
+              </a:p>
+              <a:p>
+                <a:pPr lvl="1"/>
+                <a:r>
+                  <a:rPr/>
+                  <a:t>在 </a:t>
+                </a:r>
+                <a:r>
+                  <a:rPr b="1"/>
+                  <a:t>S-DSM-S 接面</a:t>
+                </a:r>
+                <a:r>
+                  <a:rPr/>
+                  <a:t> 中，安德烈夫反射促成超導關聯穿透半金屬。</a:t>
+                </a:r>
+              </a:p>
+              <a:p>
+                <a:pPr lvl="1"/>
+                <a:r>
+                  <a:rPr/>
+                  <a:t>高透明度或拓樸態可導致 </a:t>
+                </a:r>
+                <a:r>
+                  <a:rPr b="1"/>
+                  <a:t>非正弦 CPR</a:t>
+                </a:r>
+                <a:r>
+                  <a:rPr/>
+                  <a:t>：</a:t>
+                </a:r>
+                <a14:m>
+                  <m:oMath xmlns:m="http://schemas.openxmlformats.org/officeDocument/2006/math">
+                    <m:r>
+                      <m:t>I</m:t>
+                    </m:r>
+                    <m:d>
+                      <m:dPr>
+                        <m:begChr m:val="("/>
+                        <m:sepChr m:val=""/>
+                        <m:endChr m:val=")"/>
+                        <m:grow/>
+                      </m:dPr>
+                      <m:e>
+                        <m:r>
+                          <m:t>φ</m:t>
+                        </m:r>
+                      </m:e>
+                    </m:d>
+                    <m:r>
+                      <m:rPr>
+                        <m:sty m:val="p"/>
+                      </m:rPr>
+                      <m:t>=</m:t>
+                    </m:r>
+                    <m:r>
+                      <m:rPr>
+                        <m:sty m:val="p"/>
+                      </m:rPr>
+                      <m:t>∑</m:t>
+                    </m:r>
+                    <m:sSub>
+                      <m:e>
+                        <m:r>
+                          <m:t>A</m:t>
+                        </m:r>
+                      </m:e>
+                      <m:sub>
+                        <m:r>
+                          <m:t>n</m:t>
+                        </m:r>
+                      </m:sub>
+                    </m:sSub>
+                    <m:r>
+                      <m:rPr>
+                        <m:sty m:val="p"/>
+                      </m:rPr>
+                      <m:t>sin</m:t>
+                    </m:r>
+                    <m:d>
+                      <m:dPr>
+                        <m:begChr m:val="("/>
+                        <m:sepChr m:val=""/>
+                        <m:endChr m:val=")"/>
+                        <m:grow/>
+                      </m:dPr>
+                      <m:e>
+                        <m:r>
+                          <m:t>n</m:t>
+                        </m:r>
+                        <m:r>
+                          <m:t>φ</m:t>
+                        </m:r>
+                      </m:e>
+                    </m:d>
+                  </m:oMath>
+                </a14:m>
+                <a:r>
+                  <a:rPr/>
+                  <a:t>，高階諧波反映內部相位結構。</a:t>
+                </a:r>
+              </a:p>
+            </p:txBody>
+          </p:sp>
+        </mc:Choice>
+      </mc:AlternateContent>
+    </p:spTree>
+  </p:cSld>
+</p:sld>
+</file>
+
+<file path=ppt/slides/slide9.xml><?xml version="1.0" encoding="utf-8"?>
+<p:sld xmlns:a="http://schemas.openxmlformats.org/drawingml/2006/main" xmlns:r="http://schemas.openxmlformats.org/officeDocument/2006/relationships" xmlns:p="http://schemas.openxmlformats.org/presentationml/2006/main">
+  <p:cSld>
+    <p:spTree>
+      <p:nvGrpSpPr>
+        <p:cNvPr id="1" name=""/>
+        <p:cNvGrpSpPr/>
+        <p:nvPr/>
+      </p:nvGrpSpPr>
+      <p:grpSpPr>
+        <a:xfrm>
+          <a:off x="0" y="0"/>
+          <a:ext cx="0" cy="0"/>
+          <a:chOff x="0" y="0"/>
+          <a:chExt cx="0" cy="0"/>
+        </a:xfrm>
+      </p:grpSpPr>
+      <p:sp>
+        <p:nvSpPr>
+          <p:cNvPr id="2" name="Title 1"/>
+          <p:cNvSpPr>
+            <a:spLocks noGrp="1"/>
+          </p:cNvSpPr>
+          <p:nvPr>
+            <p:ph type="title"/>
+          </p:nvPr>
+        </p:nvSpPr>
+        <p:spPr/>
+        <p:txBody>
+          <a:bodyPr/>
+          <a:lstStyle/>
+          <a:p>
+            <a:pPr lvl="0" indent="0" marL="0">
+              <a:buNone/>
+            </a:pPr>
+            <a:r>
+              <a:rPr/>
+              <a:t>量測策略：非對稱 SQUID 直接讀取 CPR</a:t>
             </a:r>
           </a:p>
         </p:txBody>
@@ -7219,7 +7985,7 @@
                 </a:r>
                 <a:r>
                   <a:rPr/>
-                  <a:t>：</a:t>
+                  <a:t>：設定 </a:t>
                 </a:r>
                 <a14:m>
                   <m:oMath xmlns:m="http://schemas.openxmlformats.org/officeDocument/2006/math">
@@ -7286,12 +8052,9 @@
                     </m:sSubSup>
                   </m:oMath>
                 </a14:m>
-              </a:p>
-              <a:p>
-                <a:pPr lvl="1"/>
-                <a:r>
-                  <a:rPr/>
-                  <a:t>強參考接面 (Reference Junction) 鎖定相位 </a:t>
+                <a:r>
+                  <a:rPr/>
+                  <a:t>，以強參考接面鎖定 </a:t>
                 </a:r>
                 <a14:m>
                   <m:oMath xmlns:m="http://schemas.openxmlformats.org/officeDocument/2006/math">
@@ -7333,10 +8096,14 @@
                 </a:r>
               </a:p>
               <a:p>
-                <a:pPr lvl="1"/>
-                <a:r>
-                  <a:rPr/>
-                  <a:t>外加磁通 </a:t>
+                <a:pPr lvl="0"/>
+                <a:r>
+                  <a:rPr b="1"/>
+                  <a:t>相位掃描</a:t>
+                </a:r>
+                <a:r>
+                  <a:rPr/>
+                  <a:t>：外加磁通 </a:t>
                 </a:r>
                 <a14:m>
                   <m:oMath xmlns:m="http://schemas.openxmlformats.org/officeDocument/2006/math">
@@ -7382,32 +8149,7 @@
                 </a14:m>
                 <a:r>
                   <a:rPr/>
-                  <a:t>。</a:t>
-                </a:r>
-              </a:p>
-              <a:p>
-                <a:pPr lvl="0"/>
-                <a:r>
-                  <a:rPr b="1"/>
-                  <a:t>核心優勢</a:t>
-                </a:r>
-              </a:p>
-              <a:p>
-                <a:pPr lvl="1"/>
-                <a:r>
-                  <a:rPr b="1"/>
-                  <a:t>“相位偏置探測器” (Phase-Biased Detector)</a:t>
-                </a:r>
-                <a:r>
-                  <a:rPr/>
-                  <a:t>。</a:t>
-                </a:r>
-              </a:p>
-              <a:p>
-                <a:pPr lvl="1"/>
-                <a:r>
-                  <a:rPr/>
-                  <a:t>可直接從 </a:t>
+                  <a:t>，</a:t>
                 </a:r>
                 <a14:m>
                   <m:oMath xmlns:m="http://schemas.openxmlformats.org/officeDocument/2006/math">
@@ -7440,15 +8182,26 @@
                 </a14:m>
                 <a:r>
                   <a:rPr/>
-                  <a:t> 調變曲線 </a:t>
-                </a:r>
+                  <a:t> 即為 CPR 的映射。</a:t>
+                </a:r>
+              </a:p>
+              <a:p>
+                <a:pPr lvl="0"/>
                 <a:r>
                   <a:rPr b="1"/>
-                  <a:t>讀出 (Readout)</a:t>
-                </a:r>
-                <a:r>
-                  <a:rPr/>
-                  <a:t> 目標接面的 CPR。</a:t>
+                  <a:t>優勢</a:t>
+                </a:r>
+                <a:r>
+                  <a:rPr/>
+                  <a:t>：充當 </a:t>
+                </a:r>
+                <a:r>
+                  <a:rPr b="1"/>
+                  <a:t>相位偏壓探測器</a:t>
+                </a:r>
+                <a:r>
+                  <a:rPr/>
+                  <a:t>，以單次量測取得完整 CPR，符合白皮書「視覺化優先」與「快速定錨」原則。</a:t>
                 </a:r>
               </a:p>
             </p:txBody>
@@ -7485,223 +8238,6 @@
           </a:ln>
         </p:spPr>
       </p:pic>
-    </p:spTree>
-  </p:cSld>
-</p:sld>
-</file>
-
-<file path=ppt/slides/slide8.xml><?xml version="1.0" encoding="utf-8"?>
-<p:sld xmlns:a="http://schemas.openxmlformats.org/drawingml/2006/main" xmlns:r="http://schemas.openxmlformats.org/officeDocument/2006/relationships" xmlns:p="http://schemas.openxmlformats.org/presentationml/2006/main">
-  <p:cSld>
-    <p:spTree>
-      <p:nvGrpSpPr>
-        <p:cNvPr id="1" name=""/>
-        <p:cNvGrpSpPr/>
-        <p:nvPr/>
-      </p:nvGrpSpPr>
-      <p:grpSpPr>
-        <a:xfrm>
-          <a:off x="0" y="0"/>
-          <a:ext cx="0" cy="0"/>
-          <a:chOff x="0" y="0"/>
-          <a:chExt cx="0" cy="0"/>
-        </a:xfrm>
-      </p:grpSpPr>
-      <p:sp>
-        <p:nvSpPr>
-          <p:cNvPr id="2" name="Title 1"/>
-          <p:cNvSpPr>
-            <a:spLocks noGrp="1"/>
-          </p:cNvSpPr>
-          <p:nvPr>
-            <p:ph type="title"/>
-          </p:nvPr>
-        </p:nvSpPr>
-        <p:spPr>
-          <a:xfrm>
-            <a:off x="722313" y="3305176"/>
-            <a:ext cx="7772400" cy="1021556"/>
-          </a:xfrm>
-        </p:spPr>
-        <p:txBody>
-          <a:bodyPr/>
-          <a:lstStyle/>
-          <a:p>
-            <a:pPr lvl="0" indent="0" marL="0">
-              <a:buNone/>
-            </a:pPr>
-            <a:r>
-              <a:rPr/>
-              <a:t>實驗方法</a:t>
-            </a:r>
-          </a:p>
-        </p:txBody>
-      </p:sp>
-    </p:spTree>
-  </p:cSld>
-</p:sld>
-</file>
-
-<file path=ppt/slides/slide9.xml><?xml version="1.0" encoding="utf-8"?>
-<p:sld xmlns:a="http://schemas.openxmlformats.org/drawingml/2006/main" xmlns:r="http://schemas.openxmlformats.org/officeDocument/2006/relationships" xmlns:p="http://schemas.openxmlformats.org/presentationml/2006/main">
-  <p:cSld>
-    <p:spTree>
-      <p:nvGrpSpPr>
-        <p:cNvPr id="1" name=""/>
-        <p:cNvGrpSpPr/>
-        <p:nvPr/>
-      </p:nvGrpSpPr>
-      <p:grpSpPr>
-        <a:xfrm>
-          <a:off x="0" y="0"/>
-          <a:ext cx="0" cy="0"/>
-          <a:chOff x="0" y="0"/>
-          <a:chExt cx="0" cy="0"/>
-        </a:xfrm>
-      </p:grpSpPr>
-      <p:sp>
-        <p:nvSpPr>
-          <p:cNvPr id="2" name="Title 1"/>
-          <p:cNvSpPr>
-            <a:spLocks noGrp="1"/>
-          </p:cNvSpPr>
-          <p:nvPr>
-            <p:ph type="title"/>
-          </p:nvPr>
-        </p:nvSpPr>
-        <p:spPr/>
-        <p:txBody>
-          <a:bodyPr/>
-          <a:lstStyle/>
-          <a:p>
-            <a:pPr lvl="0" indent="0" marL="0">
-              <a:buNone/>
-            </a:pPr>
-            <a:r>
-              <a:rPr/>
-              <a:t>元件製備流程 (Fabrication)</a:t>
-            </a:r>
-          </a:p>
-        </p:txBody>
-      </p:sp>
-      <mc:AlternateContent xmlns:mc="http://schemas.openxmlformats.org/markup-compatibility/2006">
-        <mc:Choice xmlns:a14="http://schemas.microsoft.com/office/drawing/2010/main" Requires="a14">
-          <p:sp>
-            <p:nvSpPr>
-              <p:cNvPr id="3" name="Content Placeholder 2"/>
-              <p:cNvSpPr>
-                <a:spLocks noGrp="1"/>
-              </p:cNvSpPr>
-              <p:nvPr>
-                <p:ph idx="1"/>
-              </p:nvPr>
-            </p:nvSpPr>
-            <p:spPr/>
-            <p:txBody>
-              <a:bodyPr/>
-              <a:lstStyle/>
-              <a:p>
-                <a:pPr lvl="0"/>
-                <a:r>
-                  <a:rPr b="1"/>
-                  <a:t>材料來源</a:t>
-                </a:r>
-                <a:r>
-                  <a:rPr/>
-                  <a:t>：1T-PtTe</a:t>
-                </a:r>
-                <a14:m>
-                  <m:oMath xmlns:m="http://schemas.openxmlformats.org/officeDocument/2006/math">
-                    <m:sSub>
-                      <m:e>
-                        <m:r>
-                          <m:t>​</m:t>
-                        </m:r>
-                      </m:e>
-                      <m:sub>
-                        <m:r>
-                          <m:t>2</m:t>
-                        </m:r>
-                      </m:sub>
-                    </m:sSub>
-                  </m:oMath>
-                </a14:m>
-                <a:r>
-                  <a:rPr/>
-                  <a:t> 單晶 (助熔劑法生長)。</a:t>
-                </a:r>
-              </a:p>
-              <a:p>
-                <a:pPr lvl="0"/>
-                <a:r>
-                  <a:rPr b="1"/>
-                  <a:t>關鍵製程</a:t>
-                </a:r>
-              </a:p>
-              <a:p>
-                <a:pPr lvl="1" indent="-342900" marL="685800">
-                  <a:buAutoNum type="arabicPeriod"/>
-                </a:pPr>
-                <a:r>
-                  <a:rPr b="1"/>
-                  <a:t>機械剝離 (Exfoliation)</a:t>
-                </a:r>
-                <a:r>
-                  <a:rPr/>
-                  <a:t>：製備原子級厚度薄片。</a:t>
-                </a:r>
-              </a:p>
-              <a:p>
-                <a:pPr lvl="1" indent="-342900" marL="685800">
-                  <a:buAutoNum type="arabicPeriod"/>
-                </a:pPr>
-                <a:r>
-                  <a:rPr b="1"/>
-                  <a:t>電子束微影 (EBL)</a:t>
-                </a:r>
-                <a:r>
-                  <a:rPr/>
-                  <a:t>：定義奈米級電極圖案。</a:t>
-                </a:r>
-              </a:p>
-              <a:p>
-                <a:pPr lvl="1" indent="-342900" marL="685800">
-                  <a:buAutoNum type="arabicPeriod"/>
-                </a:pPr>
-                <a:r>
-                  <a:rPr b="1"/>
-                  <a:t>原位離子銑削 (In-situ Ion Milling)</a:t>
-                </a:r>
-                <a:r>
-                  <a:rPr/>
-                  <a:t>：確保低阻抗介面接觸。</a:t>
-                </a:r>
-              </a:p>
-              <a:p>
-                <a:pPr lvl="1" indent="-342900" marL="685800">
-                  <a:buAutoNum type="arabicPeriod"/>
-                </a:pPr>
-                <a:r>
-                  <a:rPr b="1"/>
-                  <a:t>超導電極沉積</a:t>
-                </a:r>
-                <a:r>
-                  <a:rPr/>
-                  <a:t>：濺鍍 </a:t>
-                </a:r>
-                <a:r>
-                  <a:rPr b="1"/>
-                  <a:t>NbTi</a:t>
-                </a:r>
-                <a:r>
-                  <a:rPr/>
-                  <a:t> (70-120 nm)。</a:t>
-                </a:r>
-              </a:p>
-            </p:txBody>
-          </p:sp>
-        </mc:Choice>
-      </mc:AlternateContent>
     </p:spTree>
   </p:cSld>
 </p:sld>

</xml_diff>